<commit_message>
Tighten the COMDT one pager
Adopt the CO's shortened copy: three short paragraphs in the month 1
assessment, condensed watch items, and a rewritten command assessment.
Remove the Outlook section, which repeated the command assessment, so
that assessment now stands alone as the conclusion. Redistribute the
reclaimed space rather than leaving it at the foot.

Co-Authored-By: Claude Fable 5 <noreply@anthropic.com>
Claude-Session: https://claude.ai/code/session_01YLo1WfwUDkbwfJEF3ZNVbB
</commit_message>
<xml_diff>
--- a/output/nzalc-month1-comdt-update.pptx
+++ b/output/nzalc-month1-comdt-update.pptx
@@ -986,7 +986,7 @@
         <p:spPr>
           <a:xfrm>
             <a:off x="566928" y="859536"/>
-            <a:ext cx="4965192" cy="310896"/>
+            <a:ext cx="4873752" cy="329184"/>
           </a:xfrm>
           <a:prstGeom prst="rect">
             <a:avLst/>
@@ -1002,7 +1002,7 @@
               <a:buNone/>
             </a:pPr>
             <a:r>
-              <a:rPr lang="en-US" sz="1900" b="1" dirty="0">
+              <a:rPr lang="en-US" sz="2000" b="1" dirty="0">
                 <a:solidFill>
                   <a:srgbClr val="1A1A1A"/>
                 </a:solidFill>
@@ -1012,7 +1012,7 @@
               </a:rPr>
               <a:t>FY26/27 Month 1 Financial Position</a:t>
             </a:r>
-            <a:endParaRPr lang="en-US" sz="1900" dirty="0"/>
+            <a:endParaRPr lang="en-US" sz="2000" dirty="0"/>
           </a:p>
         </p:txBody>
       </p:sp>
@@ -1024,8 +1024,8 @@
         </p:nvSpPr>
         <p:spPr>
           <a:xfrm>
-            <a:off x="566928" y="1170432"/>
-            <a:ext cx="4965192" cy="182880"/>
+            <a:off x="566928" y="1188720"/>
+            <a:ext cx="4873752" cy="182880"/>
           </a:xfrm>
           <a:prstGeom prst="rect">
             <a:avLst/>
@@ -1063,8 +1063,8 @@
         </p:nvSpPr>
         <p:spPr>
           <a:xfrm>
-            <a:off x="5623560" y="896112"/>
-            <a:ext cx="1371600" cy="402336"/>
+            <a:off x="5577840" y="896112"/>
+            <a:ext cx="1417320" cy="420624"/>
           </a:xfrm>
           <a:prstGeom prst="rect">
             <a:avLst/>
@@ -1083,8 +1083,8 @@
         </p:nvSpPr>
         <p:spPr>
           <a:xfrm>
-            <a:off x="5623560" y="932688"/>
-            <a:ext cx="1371600" cy="128016"/>
+            <a:off x="5577840" y="932688"/>
+            <a:ext cx="1417320" cy="137160"/>
           </a:xfrm>
           <a:prstGeom prst="rect">
             <a:avLst/>
@@ -1122,8 +1122,8 @@
         </p:nvSpPr>
         <p:spPr>
           <a:xfrm>
-            <a:off x="5623560" y="1060704"/>
-            <a:ext cx="1371600" cy="201168"/>
+            <a:off x="5577840" y="1069848"/>
+            <a:ext cx="1417320" cy="210312"/>
           </a:xfrm>
           <a:prstGeom prst="rect">
             <a:avLst/>
@@ -1139,7 +1139,7 @@
               <a:buNone/>
             </a:pPr>
             <a:r>
-              <a:rPr lang="en-US" sz="1100" b="1" dirty="0">
+              <a:rPr lang="en-US" sz="1150" b="1" dirty="0">
                 <a:solidFill>
                   <a:srgbClr val="1A1A1A"/>
                 </a:solidFill>
@@ -1149,7 +1149,7 @@
               </a:rPr>
               <a:t>GREEN–AMBER</a:t>
             </a:r>
-            <a:endParaRPr lang="en-US" sz="1100" dirty="0"/>
+            <a:endParaRPr lang="en-US" sz="1150" dirty="0"/>
           </a:p>
         </p:txBody>
       </p:sp>
@@ -1161,7 +1161,7 @@
         </p:nvSpPr>
         <p:spPr>
           <a:xfrm>
-            <a:off x="566928" y="1426464"/>
+            <a:off x="566928" y="1444752"/>
             <a:ext cx="6428232" cy="16459"/>
           </a:xfrm>
           <a:prstGeom prst="rect">
@@ -1181,8 +1181,8 @@
         </p:nvSpPr>
         <p:spPr>
           <a:xfrm>
-            <a:off x="566928" y="1627632"/>
-            <a:ext cx="1511046" cy="932688"/>
+            <a:off x="566928" y="1719072"/>
+            <a:ext cx="1511046" cy="1042416"/>
           </a:xfrm>
           <a:prstGeom prst="rect">
             <a:avLst/>
@@ -1201,8 +1201,8 @@
         </p:nvSpPr>
         <p:spPr>
           <a:xfrm>
-            <a:off x="566928" y="1627632"/>
-            <a:ext cx="1511046" cy="25603"/>
+            <a:off x="566928" y="1719072"/>
+            <a:ext cx="1511046" cy="27432"/>
           </a:xfrm>
           <a:prstGeom prst="rect">
             <a:avLst/>
@@ -1221,8 +1221,8 @@
         </p:nvSpPr>
         <p:spPr>
           <a:xfrm>
-            <a:off x="694944" y="1737360"/>
-            <a:ext cx="1255014" cy="146304"/>
+            <a:off x="704088" y="1847088"/>
+            <a:ext cx="1236726" cy="146304"/>
           </a:xfrm>
           <a:prstGeom prst="rect">
             <a:avLst/>
@@ -1238,7 +1238,7 @@
               <a:buNone/>
             </a:pPr>
             <a:r>
-              <a:rPr lang="en-US" sz="620" b="1" spc="80" kern="0" dirty="0">
+              <a:rPr lang="en-US" sz="640" b="1" spc="80" kern="0" dirty="0">
                 <a:solidFill>
                   <a:srgbClr val="6E6E6E"/>
                 </a:solidFill>
@@ -1248,7 +1248,7 @@
               </a:rPr>
               <a:t>FY BUDGET</a:t>
             </a:r>
-            <a:endParaRPr lang="en-US" sz="620" dirty="0"/>
+            <a:endParaRPr lang="en-US" sz="640" dirty="0"/>
           </a:p>
         </p:txBody>
       </p:sp>
@@ -1260,8 +1260,8 @@
         </p:nvSpPr>
         <p:spPr>
           <a:xfrm>
-            <a:off x="694944" y="1920240"/>
-            <a:ext cx="1255014" cy="310896"/>
+            <a:off x="704088" y="2048256"/>
+            <a:ext cx="1236726" cy="347472"/>
           </a:xfrm>
           <a:prstGeom prst="rect">
             <a:avLst/>
@@ -1277,7 +1277,7 @@
               <a:buNone/>
             </a:pPr>
             <a:r>
-              <a:rPr lang="en-US" sz="1800" b="1" dirty="0">
+              <a:rPr lang="en-US" sz="2000" b="1" dirty="0">
                 <a:solidFill>
                   <a:srgbClr val="1A1A1A"/>
                 </a:solidFill>
@@ -1287,7 +1287,7 @@
               </a:rPr>
               <a:t>$811.6k</a:t>
             </a:r>
-            <a:endParaRPr lang="en-US" sz="1800" dirty="0"/>
+            <a:endParaRPr lang="en-US" sz="2000" dirty="0"/>
           </a:p>
         </p:txBody>
       </p:sp>
@@ -1299,8 +1299,8 @@
         </p:nvSpPr>
         <p:spPr>
           <a:xfrm>
-            <a:off x="694944" y="2249424"/>
-            <a:ext cx="1255014" cy="256032"/>
+            <a:off x="704088" y="2432304"/>
+            <a:ext cx="1236726" cy="256032"/>
           </a:xfrm>
           <a:prstGeom prst="rect">
             <a:avLst/>
@@ -1319,7 +1319,7 @@
               <a:buNone/>
             </a:pPr>
             <a:r>
-              <a:rPr lang="en-US" sz="680" dirty="0">
+              <a:rPr lang="en-US" sz="700" dirty="0">
                 <a:solidFill>
                   <a:srgbClr val="6E6E6E"/>
                 </a:solidFill>
@@ -1327,9 +1327,9 @@
                 <a:ea typeface="Arial" pitchFamily="34" charset="-122"/>
                 <a:cs typeface="Arial" pitchFamily="34" charset="-120"/>
               </a:rPr>
-              <a:t>SAP full year plan</a:t>
-            </a:r>
-            <a:endParaRPr lang="en-US" sz="680" dirty="0"/>
+              <a:t>SAP full-year plan</a:t>
+            </a:r>
+            <a:endParaRPr lang="en-US" sz="700" dirty="0"/>
           </a:p>
         </p:txBody>
       </p:sp>
@@ -1341,8 +1341,8 @@
         </p:nvSpPr>
         <p:spPr>
           <a:xfrm>
-            <a:off x="2205990" y="1627632"/>
-            <a:ext cx="1511046" cy="932688"/>
+            <a:off x="2205990" y="1719072"/>
+            <a:ext cx="1511046" cy="1042416"/>
           </a:xfrm>
           <a:prstGeom prst="rect">
             <a:avLst/>
@@ -1361,8 +1361,8 @@
         </p:nvSpPr>
         <p:spPr>
           <a:xfrm>
-            <a:off x="2205990" y="1627632"/>
-            <a:ext cx="1511046" cy="25603"/>
+            <a:off x="2205990" y="1719072"/>
+            <a:ext cx="1511046" cy="27432"/>
           </a:xfrm>
           <a:prstGeom prst="rect">
             <a:avLst/>
@@ -1381,8 +1381,8 @@
         </p:nvSpPr>
         <p:spPr>
           <a:xfrm>
-            <a:off x="2334006" y="1737360"/>
-            <a:ext cx="1255014" cy="146304"/>
+            <a:off x="2343150" y="1847088"/>
+            <a:ext cx="1236726" cy="146304"/>
           </a:xfrm>
           <a:prstGeom prst="rect">
             <a:avLst/>
@@ -1398,7 +1398,7 @@
               <a:buNone/>
             </a:pPr>
             <a:r>
-              <a:rPr lang="en-US" sz="620" b="1" spc="80" kern="0" dirty="0">
+              <a:rPr lang="en-US" sz="640" b="1" spc="80" kern="0" dirty="0">
                 <a:solidFill>
                   <a:srgbClr val="6E6E6E"/>
                 </a:solidFill>
@@ -1408,7 +1408,7 @@
               </a:rPr>
               <a:t>JULY ACTUAL</a:t>
             </a:r>
-            <a:endParaRPr lang="en-US" sz="620" dirty="0"/>
+            <a:endParaRPr lang="en-US" sz="640" dirty="0"/>
           </a:p>
         </p:txBody>
       </p:sp>
@@ -1420,8 +1420,8 @@
         </p:nvSpPr>
         <p:spPr>
           <a:xfrm>
-            <a:off x="2334006" y="1920240"/>
-            <a:ext cx="1255014" cy="310896"/>
+            <a:off x="2343150" y="2048256"/>
+            <a:ext cx="1236726" cy="347472"/>
           </a:xfrm>
           <a:prstGeom prst="rect">
             <a:avLst/>
@@ -1437,7 +1437,7 @@
               <a:buNone/>
             </a:pPr>
             <a:r>
-              <a:rPr lang="en-US" sz="1800" b="1" dirty="0">
+              <a:rPr lang="en-US" sz="2000" b="1" dirty="0">
                 <a:solidFill>
                   <a:srgbClr val="1A1A1A"/>
                 </a:solidFill>
@@ -1447,7 +1447,7 @@
               </a:rPr>
               <a:t>$40.5k</a:t>
             </a:r>
-            <a:endParaRPr lang="en-US" sz="1800" dirty="0"/>
+            <a:endParaRPr lang="en-US" sz="2000" dirty="0"/>
           </a:p>
         </p:txBody>
       </p:sp>
@@ -1459,8 +1459,8 @@
         </p:nvSpPr>
         <p:spPr>
           <a:xfrm>
-            <a:off x="2334006" y="2249424"/>
-            <a:ext cx="1255014" cy="256032"/>
+            <a:off x="2343150" y="2432304"/>
+            <a:ext cx="1236726" cy="256032"/>
           </a:xfrm>
           <a:prstGeom prst="rect">
             <a:avLst/>
@@ -1479,7 +1479,7 @@
               <a:buNone/>
             </a:pPr>
             <a:r>
-              <a:rPr lang="en-US" sz="680" dirty="0">
+              <a:rPr lang="en-US" sz="700" dirty="0">
                 <a:solidFill>
                   <a:srgbClr val="6E6E6E"/>
                 </a:solidFill>
@@ -1487,9 +1487,9 @@
                 <a:ea typeface="Arial" pitchFamily="34" charset="-122"/>
                 <a:cs typeface="Arial" pitchFamily="34" charset="-120"/>
               </a:rPr>
-              <a:t>against a $23.0k profile</a:t>
-            </a:r>
-            <a:endParaRPr lang="en-US" sz="680" dirty="0"/>
+              <a:t>against $23.0k profile</a:t>
+            </a:r>
+            <a:endParaRPr lang="en-US" sz="700" dirty="0"/>
           </a:p>
         </p:txBody>
       </p:sp>
@@ -1501,8 +1501,8 @@
         </p:nvSpPr>
         <p:spPr>
           <a:xfrm>
-            <a:off x="3845052" y="1627632"/>
-            <a:ext cx="1511046" cy="932688"/>
+            <a:off x="3845052" y="1719072"/>
+            <a:ext cx="1511046" cy="1042416"/>
           </a:xfrm>
           <a:prstGeom prst="rect">
             <a:avLst/>
@@ -1521,8 +1521,8 @@
         </p:nvSpPr>
         <p:spPr>
           <a:xfrm>
-            <a:off x="3845052" y="1627632"/>
-            <a:ext cx="1511046" cy="25603"/>
+            <a:off x="3845052" y="1719072"/>
+            <a:ext cx="1511046" cy="27432"/>
           </a:xfrm>
           <a:prstGeom prst="rect">
             <a:avLst/>
@@ -1541,8 +1541,8 @@
         </p:nvSpPr>
         <p:spPr>
           <a:xfrm>
-            <a:off x="3973068" y="1737360"/>
-            <a:ext cx="1255014" cy="146304"/>
+            <a:off x="3982212" y="1847088"/>
+            <a:ext cx="1236726" cy="146304"/>
           </a:xfrm>
           <a:prstGeom prst="rect">
             <a:avLst/>
@@ -1558,7 +1558,7 @@
               <a:buNone/>
             </a:pPr>
             <a:r>
-              <a:rPr lang="en-US" sz="620" b="1" spc="80" kern="0" dirty="0">
+              <a:rPr lang="en-US" sz="640" b="1" spc="80" kern="0" dirty="0">
                 <a:solidFill>
                   <a:srgbClr val="6E6E6E"/>
                 </a:solidFill>
@@ -1568,7 +1568,7 @@
               </a:rPr>
               <a:t>BUDGET CONSUMED</a:t>
             </a:r>
-            <a:endParaRPr lang="en-US" sz="620" dirty="0"/>
+            <a:endParaRPr lang="en-US" sz="640" dirty="0"/>
           </a:p>
         </p:txBody>
       </p:sp>
@@ -1580,8 +1580,8 @@
         </p:nvSpPr>
         <p:spPr>
           <a:xfrm>
-            <a:off x="3973068" y="1920240"/>
-            <a:ext cx="1255014" cy="310896"/>
+            <a:off x="3982212" y="2048256"/>
+            <a:ext cx="1236726" cy="347472"/>
           </a:xfrm>
           <a:prstGeom prst="rect">
             <a:avLst/>
@@ -1597,7 +1597,7 @@
               <a:buNone/>
             </a:pPr>
             <a:r>
-              <a:rPr lang="en-US" sz="1800" b="1" dirty="0">
+              <a:rPr lang="en-US" sz="2000" b="1" dirty="0">
                 <a:solidFill>
                   <a:srgbClr val="1A1A1A"/>
                 </a:solidFill>
@@ -1607,7 +1607,7 @@
               </a:rPr>
               <a:t>5.0%</a:t>
             </a:r>
-            <a:endParaRPr lang="en-US" sz="1800" dirty="0"/>
+            <a:endParaRPr lang="en-US" sz="2000" dirty="0"/>
           </a:p>
         </p:txBody>
       </p:sp>
@@ -1619,8 +1619,8 @@
         </p:nvSpPr>
         <p:spPr>
           <a:xfrm>
-            <a:off x="3973068" y="2249424"/>
-            <a:ext cx="1255014" cy="256032"/>
+            <a:off x="3982212" y="2432304"/>
+            <a:ext cx="1236726" cy="256032"/>
           </a:xfrm>
           <a:prstGeom prst="rect">
             <a:avLst/>
@@ -1639,7 +1639,7 @@
               <a:buNone/>
             </a:pPr>
             <a:r>
-              <a:rPr lang="en-US" sz="680" dirty="0">
+              <a:rPr lang="en-US" sz="700" dirty="0">
                 <a:solidFill>
                   <a:srgbClr val="6E6E6E"/>
                 </a:solidFill>
@@ -1649,7 +1649,7 @@
               </a:rPr>
               <a:t>of the annual plan</a:t>
             </a:r>
-            <a:endParaRPr lang="en-US" sz="680" dirty="0"/>
+            <a:endParaRPr lang="en-US" sz="700" dirty="0"/>
           </a:p>
         </p:txBody>
       </p:sp>
@@ -1661,8 +1661,8 @@
         </p:nvSpPr>
         <p:spPr>
           <a:xfrm>
-            <a:off x="5484114" y="1627632"/>
-            <a:ext cx="1511046" cy="932688"/>
+            <a:off x="5484114" y="1719072"/>
+            <a:ext cx="1511046" cy="1042416"/>
           </a:xfrm>
           <a:prstGeom prst="rect">
             <a:avLst/>
@@ -1681,8 +1681,8 @@
         </p:nvSpPr>
         <p:spPr>
           <a:xfrm>
-            <a:off x="5484114" y="1627632"/>
-            <a:ext cx="1511046" cy="25603"/>
+            <a:off x="5484114" y="1719072"/>
+            <a:ext cx="1511046" cy="27432"/>
           </a:xfrm>
           <a:prstGeom prst="rect">
             <a:avLst/>
@@ -1701,8 +1701,8 @@
         </p:nvSpPr>
         <p:spPr>
           <a:xfrm>
-            <a:off x="5612130" y="1737360"/>
-            <a:ext cx="1255014" cy="146304"/>
+            <a:off x="5621274" y="1847088"/>
+            <a:ext cx="1236726" cy="146304"/>
           </a:xfrm>
           <a:prstGeom prst="rect">
             <a:avLst/>
@@ -1718,7 +1718,7 @@
               <a:buNone/>
             </a:pPr>
             <a:r>
-              <a:rPr lang="en-US" sz="620" b="1" spc="80" kern="0" dirty="0">
+              <a:rPr lang="en-US" sz="640" b="1" spc="80" kern="0" dirty="0">
                 <a:solidFill>
                   <a:srgbClr val="6E6E6E"/>
                 </a:solidFill>
@@ -1728,7 +1728,7 @@
               </a:rPr>
               <a:t>JULY VARIANCE</a:t>
             </a:r>
-            <a:endParaRPr lang="en-US" sz="620" dirty="0"/>
+            <a:endParaRPr lang="en-US" sz="640" dirty="0"/>
           </a:p>
         </p:txBody>
       </p:sp>
@@ -1740,8 +1740,8 @@
         </p:nvSpPr>
         <p:spPr>
           <a:xfrm>
-            <a:off x="5612130" y="1920240"/>
-            <a:ext cx="1255014" cy="310896"/>
+            <a:off x="5621274" y="2048256"/>
+            <a:ext cx="1236726" cy="347472"/>
           </a:xfrm>
           <a:prstGeom prst="rect">
             <a:avLst/>
@@ -1757,7 +1757,7 @@
               <a:buNone/>
             </a:pPr>
             <a:r>
-              <a:rPr lang="en-US" sz="1800" b="1" dirty="0">
+              <a:rPr lang="en-US" sz="2000" b="1" dirty="0">
                 <a:solidFill>
                   <a:srgbClr val="1A1A1A"/>
                 </a:solidFill>
@@ -1767,7 +1767,7 @@
               </a:rPr>
               <a:t>$17.5k</a:t>
             </a:r>
-            <a:endParaRPr lang="en-US" sz="1800" dirty="0"/>
+            <a:endParaRPr lang="en-US" sz="2000" dirty="0"/>
           </a:p>
         </p:txBody>
       </p:sp>
@@ -1779,8 +1779,8 @@
         </p:nvSpPr>
         <p:spPr>
           <a:xfrm>
-            <a:off x="5612130" y="2249424"/>
-            <a:ext cx="1255014" cy="256032"/>
+            <a:off x="5621274" y="2432304"/>
+            <a:ext cx="1236726" cy="256032"/>
           </a:xfrm>
           <a:prstGeom prst="rect">
             <a:avLst/>
@@ -1799,7 +1799,7 @@
               <a:buNone/>
             </a:pPr>
             <a:r>
-              <a:rPr lang="en-US" sz="680" dirty="0">
+              <a:rPr lang="en-US" sz="700" dirty="0">
                 <a:solidFill>
                   <a:srgbClr val="6E6E6E"/>
                 </a:solidFill>
@@ -1809,7 +1809,7 @@
               </a:rPr>
               <a:t>ahead of profile</a:t>
             </a:r>
-            <a:endParaRPr lang="en-US" sz="680" dirty="0"/>
+            <a:endParaRPr lang="en-US" sz="700" dirty="0"/>
           </a:p>
         </p:txBody>
       </p:sp>
@@ -1821,7 +1821,7 @@
         </p:nvSpPr>
         <p:spPr>
           <a:xfrm>
-            <a:off x="566928" y="2779776"/>
+            <a:off x="566928" y="3017520"/>
             <a:ext cx="6428232" cy="164592"/>
           </a:xfrm>
           <a:prstGeom prst="rect">
@@ -1838,7 +1838,7 @@
               <a:buNone/>
             </a:pPr>
             <a:r>
-              <a:rPr lang="en-US" sz="740" b="1" spc="120" kern="0" dirty="0">
+              <a:rPr lang="en-US" sz="760" b="1" spc="120" kern="0" dirty="0">
                 <a:solidFill>
                   <a:srgbClr val="1A1A1A"/>
                 </a:solidFill>
@@ -1848,7 +1848,7 @@
               </a:rPr>
               <a:t>POSITION AT 31 JULY 2026</a:t>
             </a:r>
-            <a:endParaRPr lang="en-US" sz="740" dirty="0"/>
+            <a:endParaRPr lang="en-US" sz="760" dirty="0"/>
           </a:p>
         </p:txBody>
       </p:sp>
@@ -1860,7 +1860,7 @@
         </p:nvSpPr>
         <p:spPr>
           <a:xfrm>
-            <a:off x="566928" y="2953512"/>
+            <a:off x="566928" y="3191256"/>
             <a:ext cx="6428232" cy="7315"/>
           </a:xfrm>
           <a:prstGeom prst="rect">
@@ -1880,8 +1880,8 @@
         </p:nvSpPr>
         <p:spPr>
           <a:xfrm>
-            <a:off x="658368" y="3090672"/>
-            <a:ext cx="2743200" cy="292608"/>
+            <a:off x="658368" y="3346704"/>
+            <a:ext cx="2743200" cy="347472"/>
           </a:xfrm>
           <a:prstGeom prst="rect">
             <a:avLst/>
@@ -1896,7 +1896,7 @@
             <a:pPr algn="l" indent="0" marL="0">
               <a:buNone/>
             </a:pPr>
-            <a:endParaRPr lang="en-US" sz="740" dirty="0"/>
+            <a:endParaRPr lang="en-US" sz="760" dirty="0"/>
           </a:p>
         </p:txBody>
       </p:sp>
@@ -1908,8 +1908,8 @@
         </p:nvSpPr>
         <p:spPr>
           <a:xfrm>
-            <a:off x="3310128" y="3090672"/>
-            <a:ext cx="1143000" cy="292608"/>
+            <a:off x="3310128" y="3346704"/>
+            <a:ext cx="1143000" cy="347472"/>
           </a:xfrm>
           <a:prstGeom prst="rect">
             <a:avLst/>
@@ -1925,7 +1925,7 @@
               <a:buNone/>
             </a:pPr>
             <a:r>
-              <a:rPr lang="en-US" sz="740" b="1" spc="80" kern="0" dirty="0">
+              <a:rPr lang="en-US" sz="760" b="1" spc="80" kern="0" dirty="0">
                 <a:solidFill>
                   <a:srgbClr val="6E6E6E"/>
                 </a:solidFill>
@@ -1933,9 +1933,9 @@
                 <a:ea typeface="Arial" pitchFamily="34" charset="-122"/>
                 <a:cs typeface="Arial" pitchFamily="34" charset="-120"/>
               </a:rPr>
-              <a:t>July budget</a:t>
-            </a:r>
-            <a:endParaRPr lang="en-US" sz="740" dirty="0"/>
+              <a:t>July Budget</a:t>
+            </a:r>
+            <a:endParaRPr lang="en-US" sz="760" dirty="0"/>
           </a:p>
         </p:txBody>
       </p:sp>
@@ -1947,8 +1947,8 @@
         </p:nvSpPr>
         <p:spPr>
           <a:xfrm>
-            <a:off x="4544568" y="3090672"/>
-            <a:ext cx="1143000" cy="292608"/>
+            <a:off x="4544568" y="3346704"/>
+            <a:ext cx="1143000" cy="347472"/>
           </a:xfrm>
           <a:prstGeom prst="rect">
             <a:avLst/>
@@ -1964,7 +1964,7 @@
               <a:buNone/>
             </a:pPr>
             <a:r>
-              <a:rPr lang="en-US" sz="740" b="1" spc="80" kern="0" dirty="0">
+              <a:rPr lang="en-US" sz="760" b="1" spc="80" kern="0" dirty="0">
                 <a:solidFill>
                   <a:srgbClr val="6E6E6E"/>
                 </a:solidFill>
@@ -1972,9 +1972,9 @@
                 <a:ea typeface="Arial" pitchFamily="34" charset="-122"/>
                 <a:cs typeface="Arial" pitchFamily="34" charset="-120"/>
               </a:rPr>
-              <a:t>July actual</a:t>
-            </a:r>
-            <a:endParaRPr lang="en-US" sz="740" dirty="0"/>
+              <a:t>July Actual</a:t>
+            </a:r>
+            <a:endParaRPr lang="en-US" sz="760" dirty="0"/>
           </a:p>
         </p:txBody>
       </p:sp>
@@ -1986,8 +1986,8 @@
         </p:nvSpPr>
         <p:spPr>
           <a:xfrm>
-            <a:off x="5779008" y="3090672"/>
-            <a:ext cx="1124712" cy="292608"/>
+            <a:off x="5779008" y="3346704"/>
+            <a:ext cx="1124712" cy="347472"/>
           </a:xfrm>
           <a:prstGeom prst="rect">
             <a:avLst/>
@@ -2003,7 +2003,7 @@
               <a:buNone/>
             </a:pPr>
             <a:r>
-              <a:rPr lang="en-US" sz="740" b="1" spc="80" kern="0" dirty="0">
+              <a:rPr lang="en-US" sz="760" b="1" spc="80" kern="0" dirty="0">
                 <a:solidFill>
                   <a:srgbClr val="6E6E6E"/>
                 </a:solidFill>
@@ -2013,7 +2013,7 @@
               </a:rPr>
               <a:t>Variance</a:t>
             </a:r>
-            <a:endParaRPr lang="en-US" sz="740" dirty="0"/>
+            <a:endParaRPr lang="en-US" sz="760" dirty="0"/>
           </a:p>
         </p:txBody>
       </p:sp>
@@ -2025,7 +2025,7 @@
         </p:nvSpPr>
         <p:spPr>
           <a:xfrm>
-            <a:off x="566928" y="3383280"/>
+            <a:off x="566928" y="3694176"/>
             <a:ext cx="6428232" cy="10973"/>
           </a:xfrm>
           <a:prstGeom prst="rect">
@@ -2045,8 +2045,8 @@
         </p:nvSpPr>
         <p:spPr>
           <a:xfrm>
-            <a:off x="658368" y="3419856"/>
-            <a:ext cx="2743200" cy="292608"/>
+            <a:off x="658368" y="3730752"/>
+            <a:ext cx="2743200" cy="347472"/>
           </a:xfrm>
           <a:prstGeom prst="rect">
             <a:avLst/>
@@ -2062,7 +2062,7 @@
               <a:buNone/>
             </a:pPr>
             <a:r>
-              <a:rPr lang="en-US" sz="920" dirty="0">
+              <a:rPr lang="en-US" sz="980" dirty="0">
                 <a:solidFill>
                   <a:srgbClr val="1A1A1A"/>
                 </a:solidFill>
@@ -2072,7 +2072,7 @@
               </a:rPr>
               <a:t>Personnel</a:t>
             </a:r>
-            <a:endParaRPr lang="en-US" sz="920" dirty="0"/>
+            <a:endParaRPr lang="en-US" sz="980" dirty="0"/>
           </a:p>
         </p:txBody>
       </p:sp>
@@ -2084,8 +2084,8 @@
         </p:nvSpPr>
         <p:spPr>
           <a:xfrm>
-            <a:off x="3310128" y="3419856"/>
-            <a:ext cx="1143000" cy="292608"/>
+            <a:off x="3310128" y="3730752"/>
+            <a:ext cx="1143000" cy="347472"/>
           </a:xfrm>
           <a:prstGeom prst="rect">
             <a:avLst/>
@@ -2101,7 +2101,7 @@
               <a:buNone/>
             </a:pPr>
             <a:r>
-              <a:rPr lang="en-US" sz="920" dirty="0">
+              <a:rPr lang="en-US" sz="980" dirty="0">
                 <a:solidFill>
                   <a:srgbClr val="1A1A1A"/>
                 </a:solidFill>
@@ -2111,7 +2111,7 @@
               </a:rPr>
               <a:t>$300</a:t>
             </a:r>
-            <a:endParaRPr lang="en-US" sz="920" dirty="0"/>
+            <a:endParaRPr lang="en-US" sz="980" dirty="0"/>
           </a:p>
         </p:txBody>
       </p:sp>
@@ -2123,8 +2123,8 @@
         </p:nvSpPr>
         <p:spPr>
           <a:xfrm>
-            <a:off x="4544568" y="3419856"/>
-            <a:ext cx="1143000" cy="292608"/>
+            <a:off x="4544568" y="3730752"/>
+            <a:ext cx="1143000" cy="347472"/>
           </a:xfrm>
           <a:prstGeom prst="rect">
             <a:avLst/>
@@ -2140,7 +2140,7 @@
               <a:buNone/>
             </a:pPr>
             <a:r>
-              <a:rPr lang="en-US" sz="920" dirty="0">
+              <a:rPr lang="en-US" sz="980" dirty="0">
                 <a:solidFill>
                   <a:srgbClr val="1A1A1A"/>
                 </a:solidFill>
@@ -2150,7 +2150,7 @@
               </a:rPr>
               <a:t>$6,031</a:t>
             </a:r>
-            <a:endParaRPr lang="en-US" sz="920" dirty="0"/>
+            <a:endParaRPr lang="en-US" sz="980" dirty="0"/>
           </a:p>
         </p:txBody>
       </p:sp>
@@ -2162,8 +2162,8 @@
         </p:nvSpPr>
         <p:spPr>
           <a:xfrm>
-            <a:off x="5779008" y="3419856"/>
-            <a:ext cx="1124712" cy="292608"/>
+            <a:off x="5779008" y="3730752"/>
+            <a:ext cx="1124712" cy="347472"/>
           </a:xfrm>
           <a:prstGeom prst="rect">
             <a:avLst/>
@@ -2179,7 +2179,7 @@
               <a:buNone/>
             </a:pPr>
             <a:r>
-              <a:rPr lang="en-US" sz="920" dirty="0">
+              <a:rPr lang="en-US" sz="980" dirty="0">
                 <a:solidFill>
                   <a:srgbClr val="D31145"/>
                 </a:solidFill>
@@ -2189,7 +2189,7 @@
               </a:rPr>
               <a:t>($5,731)</a:t>
             </a:r>
-            <a:endParaRPr lang="en-US" sz="920" dirty="0"/>
+            <a:endParaRPr lang="en-US" sz="980" dirty="0"/>
           </a:p>
         </p:txBody>
       </p:sp>
@@ -2201,7 +2201,7 @@
         </p:nvSpPr>
         <p:spPr>
           <a:xfrm>
-            <a:off x="566928" y="3712464"/>
+            <a:off x="566928" y="4078224"/>
             <a:ext cx="6428232" cy="5486"/>
           </a:xfrm>
           <a:prstGeom prst="rect">
@@ -2221,8 +2221,8 @@
         </p:nvSpPr>
         <p:spPr>
           <a:xfrm>
-            <a:off x="658368" y="3749040"/>
-            <a:ext cx="2743200" cy="292608"/>
+            <a:off x="658368" y="4114800"/>
+            <a:ext cx="2743200" cy="347472"/>
           </a:xfrm>
           <a:prstGeom prst="rect">
             <a:avLst/>
@@ -2238,7 +2238,7 @@
               <a:buNone/>
             </a:pPr>
             <a:r>
-              <a:rPr lang="en-US" sz="920" dirty="0">
+              <a:rPr lang="en-US" sz="980" dirty="0">
                 <a:solidFill>
                   <a:srgbClr val="1A1A1A"/>
                 </a:solidFill>
@@ -2248,7 +2248,7 @@
               </a:rPr>
               <a:t>Operating</a:t>
             </a:r>
-            <a:endParaRPr lang="en-US" sz="920" dirty="0"/>
+            <a:endParaRPr lang="en-US" sz="980" dirty="0"/>
           </a:p>
         </p:txBody>
       </p:sp>
@@ -2260,8 +2260,8 @@
         </p:nvSpPr>
         <p:spPr>
           <a:xfrm>
-            <a:off x="3310128" y="3749040"/>
-            <a:ext cx="1143000" cy="292608"/>
+            <a:off x="3310128" y="4114800"/>
+            <a:ext cx="1143000" cy="347472"/>
           </a:xfrm>
           <a:prstGeom prst="rect">
             <a:avLst/>
@@ -2277,7 +2277,7 @@
               <a:buNone/>
             </a:pPr>
             <a:r>
-              <a:rPr lang="en-US" sz="920" dirty="0">
+              <a:rPr lang="en-US" sz="980" dirty="0">
                 <a:solidFill>
                   <a:srgbClr val="1A1A1A"/>
                 </a:solidFill>
@@ -2287,7 +2287,7 @@
               </a:rPr>
               <a:t>$22,715</a:t>
             </a:r>
-            <a:endParaRPr lang="en-US" sz="920" dirty="0"/>
+            <a:endParaRPr lang="en-US" sz="980" dirty="0"/>
           </a:p>
         </p:txBody>
       </p:sp>
@@ -2299,8 +2299,8 @@
         </p:nvSpPr>
         <p:spPr>
           <a:xfrm>
-            <a:off x="4544568" y="3749040"/>
-            <a:ext cx="1143000" cy="292608"/>
+            <a:off x="4544568" y="4114800"/>
+            <a:ext cx="1143000" cy="347472"/>
           </a:xfrm>
           <a:prstGeom prst="rect">
             <a:avLst/>
@@ -2316,7 +2316,7 @@
               <a:buNone/>
             </a:pPr>
             <a:r>
-              <a:rPr lang="en-US" sz="920" dirty="0">
+              <a:rPr lang="en-US" sz="980" dirty="0">
                 <a:solidFill>
                   <a:srgbClr val="1A1A1A"/>
                 </a:solidFill>
@@ -2326,7 +2326,7 @@
               </a:rPr>
               <a:t>$34,504</a:t>
             </a:r>
-            <a:endParaRPr lang="en-US" sz="920" dirty="0"/>
+            <a:endParaRPr lang="en-US" sz="980" dirty="0"/>
           </a:p>
         </p:txBody>
       </p:sp>
@@ -2338,8 +2338,8 @@
         </p:nvSpPr>
         <p:spPr>
           <a:xfrm>
-            <a:off x="5779008" y="3749040"/>
-            <a:ext cx="1124712" cy="292608"/>
+            <a:off x="5779008" y="4114800"/>
+            <a:ext cx="1124712" cy="347472"/>
           </a:xfrm>
           <a:prstGeom prst="rect">
             <a:avLst/>
@@ -2355,7 +2355,7 @@
               <a:buNone/>
             </a:pPr>
             <a:r>
-              <a:rPr lang="en-US" sz="920" dirty="0">
+              <a:rPr lang="en-US" sz="980" dirty="0">
                 <a:solidFill>
                   <a:srgbClr val="D31145"/>
                 </a:solidFill>
@@ -2365,7 +2365,7 @@
               </a:rPr>
               <a:t>($11,789)</a:t>
             </a:r>
-            <a:endParaRPr lang="en-US" sz="920" dirty="0"/>
+            <a:endParaRPr lang="en-US" sz="980" dirty="0"/>
           </a:p>
         </p:txBody>
       </p:sp>
@@ -2377,7 +2377,7 @@
         </p:nvSpPr>
         <p:spPr>
           <a:xfrm>
-            <a:off x="566928" y="4041648"/>
+            <a:off x="566928" y="4462272"/>
             <a:ext cx="6428232" cy="5486"/>
           </a:xfrm>
           <a:prstGeom prst="rect">
@@ -2397,8 +2397,8 @@
         </p:nvSpPr>
         <p:spPr>
           <a:xfrm>
-            <a:off x="566928" y="4078224"/>
-            <a:ext cx="6428232" cy="292608"/>
+            <a:off x="566928" y="4498848"/>
+            <a:ext cx="6428232" cy="347472"/>
           </a:xfrm>
           <a:prstGeom prst="rect">
             <a:avLst/>
@@ -2417,8 +2417,8 @@
         </p:nvSpPr>
         <p:spPr>
           <a:xfrm>
-            <a:off x="658368" y="4078224"/>
-            <a:ext cx="2743200" cy="292608"/>
+            <a:off x="658368" y="4498848"/>
+            <a:ext cx="2743200" cy="347472"/>
           </a:xfrm>
           <a:prstGeom prst="rect">
             <a:avLst/>
@@ -2434,7 +2434,7 @@
               <a:buNone/>
             </a:pPr>
             <a:r>
-              <a:rPr lang="en-US" sz="920" b="1" dirty="0">
+              <a:rPr lang="en-US" sz="980" b="1" dirty="0">
                 <a:solidFill>
                   <a:srgbClr val="1A1A1A"/>
                 </a:solidFill>
@@ -2444,7 +2444,7 @@
               </a:rPr>
               <a:t>TOTAL</a:t>
             </a:r>
-            <a:endParaRPr lang="en-US" sz="920" dirty="0"/>
+            <a:endParaRPr lang="en-US" sz="980" dirty="0"/>
           </a:p>
         </p:txBody>
       </p:sp>
@@ -2456,8 +2456,8 @@
         </p:nvSpPr>
         <p:spPr>
           <a:xfrm>
-            <a:off x="3310128" y="4078224"/>
-            <a:ext cx="1143000" cy="292608"/>
+            <a:off x="3310128" y="4498848"/>
+            <a:ext cx="1143000" cy="347472"/>
           </a:xfrm>
           <a:prstGeom prst="rect">
             <a:avLst/>
@@ -2473,7 +2473,7 @@
               <a:buNone/>
             </a:pPr>
             <a:r>
-              <a:rPr lang="en-US" sz="920" b="1" dirty="0">
+              <a:rPr lang="en-US" sz="980" b="1" dirty="0">
                 <a:solidFill>
                   <a:srgbClr val="1A1A1A"/>
                 </a:solidFill>
@@ -2483,7 +2483,7 @@
               </a:rPr>
               <a:t>$23,015</a:t>
             </a:r>
-            <a:endParaRPr lang="en-US" sz="920" dirty="0"/>
+            <a:endParaRPr lang="en-US" sz="980" dirty="0"/>
           </a:p>
         </p:txBody>
       </p:sp>
@@ -2495,8 +2495,8 @@
         </p:nvSpPr>
         <p:spPr>
           <a:xfrm>
-            <a:off x="4544568" y="4078224"/>
-            <a:ext cx="1143000" cy="292608"/>
+            <a:off x="4544568" y="4498848"/>
+            <a:ext cx="1143000" cy="347472"/>
           </a:xfrm>
           <a:prstGeom prst="rect">
             <a:avLst/>
@@ -2512,7 +2512,7 @@
               <a:buNone/>
             </a:pPr>
             <a:r>
-              <a:rPr lang="en-US" sz="920" b="1" dirty="0">
+              <a:rPr lang="en-US" sz="980" b="1" dirty="0">
                 <a:solidFill>
                   <a:srgbClr val="1A1A1A"/>
                 </a:solidFill>
@@ -2522,7 +2522,7 @@
               </a:rPr>
               <a:t>$40,535</a:t>
             </a:r>
-            <a:endParaRPr lang="en-US" sz="920" dirty="0"/>
+            <a:endParaRPr lang="en-US" sz="980" dirty="0"/>
           </a:p>
         </p:txBody>
       </p:sp>
@@ -2534,8 +2534,8 @@
         </p:nvSpPr>
         <p:spPr>
           <a:xfrm>
-            <a:off x="5779008" y="4078224"/>
-            <a:ext cx="1124712" cy="292608"/>
+            <a:off x="5779008" y="4498848"/>
+            <a:ext cx="1124712" cy="347472"/>
           </a:xfrm>
           <a:prstGeom prst="rect">
             <a:avLst/>
@@ -2551,7 +2551,7 @@
               <a:buNone/>
             </a:pPr>
             <a:r>
-              <a:rPr lang="en-US" sz="920" b="1" dirty="0">
+              <a:rPr lang="en-US" sz="980" b="1" dirty="0">
                 <a:solidFill>
                   <a:srgbClr val="D31145"/>
                 </a:solidFill>
@@ -2561,7 +2561,7 @@
               </a:rPr>
               <a:t>($17,520)</a:t>
             </a:r>
-            <a:endParaRPr lang="en-US" sz="920" dirty="0"/>
+            <a:endParaRPr lang="en-US" sz="980" dirty="0"/>
           </a:p>
         </p:txBody>
       </p:sp>
@@ -2573,7 +2573,7 @@
         </p:nvSpPr>
         <p:spPr>
           <a:xfrm>
-            <a:off x="566928" y="4370832"/>
+            <a:off x="566928" y="4846320"/>
             <a:ext cx="6428232" cy="10973"/>
           </a:xfrm>
           <a:prstGeom prst="rect">
@@ -2593,7 +2593,7 @@
         </p:nvSpPr>
         <p:spPr>
           <a:xfrm>
-            <a:off x="566928" y="4572000"/>
+            <a:off x="566928" y="4974336"/>
             <a:ext cx="6428232" cy="164592"/>
           </a:xfrm>
           <a:prstGeom prst="rect">
@@ -2610,7 +2610,7 @@
               <a:buNone/>
             </a:pPr>
             <a:r>
-              <a:rPr lang="en-US" sz="740" b="1" spc="120" kern="0" dirty="0">
+              <a:rPr lang="en-US" sz="760" b="1" spc="120" kern="0" dirty="0">
                 <a:solidFill>
                   <a:srgbClr val="1A1A1A"/>
                 </a:solidFill>
@@ -2620,7 +2620,7 @@
               </a:rPr>
               <a:t>MONTH 1 ASSESSMENT</a:t>
             </a:r>
-            <a:endParaRPr lang="en-US" sz="740" dirty="0"/>
+            <a:endParaRPr lang="en-US" sz="760" dirty="0"/>
           </a:p>
         </p:txBody>
       </p:sp>
@@ -2632,7 +2632,7 @@
         </p:nvSpPr>
         <p:spPr>
           <a:xfrm>
-            <a:off x="566928" y="4745736"/>
+            <a:off x="566928" y="5148072"/>
             <a:ext cx="6428232" cy="7315"/>
           </a:xfrm>
           <a:prstGeom prst="rect">
@@ -2652,8 +2652,8 @@
         </p:nvSpPr>
         <p:spPr>
           <a:xfrm>
-            <a:off x="566928" y="4882896"/>
-            <a:ext cx="6428232" cy="859536"/>
+            <a:off x="566928" y="5303520"/>
+            <a:ext cx="6428232" cy="329184"/>
           </a:xfrm>
           <a:prstGeom prst="rect">
             <a:avLst/>
@@ -2667,12 +2667,12 @@
           <a:p>
             <a:pPr algn="l" indent="0" marL="0">
               <a:lnSpc>
-                <a:spcPct val="124000"/>
+                <a:spcPct val="126000"/>
               </a:lnSpc>
               <a:buNone/>
             </a:pPr>
             <a:r>
-              <a:rPr lang="en-US" sz="900" dirty="0">
+              <a:rPr lang="en-US" sz="960" dirty="0">
                 <a:solidFill>
                   <a:srgbClr val="1A1A1A"/>
                 </a:solidFill>
@@ -2680,9 +2680,9 @@
                 <a:ea typeface="Arial" pitchFamily="34" charset="-122"/>
                 <a:cs typeface="Arial" pitchFamily="34" charset="-120"/>
               </a:rPr>
-              <a:t>July expenditure was $17.5k ahead of the SAP monthly profile. This is assessed primarily as an expenditure timing and phasing variance rather than an emerging structural overspend. July was effectively a preparation period ahead of the FY26/27 delivery programme, with no programmed NZALC courses conducted during the month. The first three activities commence on 8, 24 and 31 August, and July expenditure is broadly consistent with the preparation, movement, procurement and enabling activity required ahead of them.</a:t>
-            </a:r>
-            <a:endParaRPr lang="en-US" sz="900" dirty="0"/>
+              <a:t>July expenditure was $17.5k ahead of profile, assessed primarily as a timing and phasing variance rather than structural overspend.</a:t>
+            </a:r>
+            <a:endParaRPr lang="en-US" sz="960" dirty="0"/>
           </a:p>
         </p:txBody>
       </p:sp>
@@ -2694,8 +2694,8 @@
         </p:nvSpPr>
         <p:spPr>
           <a:xfrm>
-            <a:off x="566928" y="5779008"/>
-            <a:ext cx="6428232" cy="457200"/>
+            <a:off x="566928" y="5815584"/>
+            <a:ext cx="6428232" cy="566928"/>
           </a:xfrm>
           <a:prstGeom prst="rect">
             <a:avLst/>
@@ -2709,12 +2709,12 @@
           <a:p>
             <a:pPr algn="l" indent="0" marL="0">
               <a:lnSpc>
-                <a:spcPct val="124000"/>
+                <a:spcPct val="126000"/>
               </a:lnSpc>
               <a:buNone/>
             </a:pPr>
             <a:r>
-              <a:rPr lang="en-US" sz="900" dirty="0">
+              <a:rPr lang="en-US" sz="960" dirty="0">
                 <a:solidFill>
                   <a:srgbClr val="1A1A1A"/>
                 </a:solidFill>
@@ -2722,9 +2722,9 @@
                 <a:ea typeface="Arial" pitchFamily="34" charset="-122"/>
                 <a:cs typeface="Arial" pitchFamily="34" charset="-120"/>
               </a:rPr>
-              <a:t>The FY26/27 budget has been increased by $50k for Winsborough support, bringing the SAP full year plan to $811.6k. That uplift is correctly reflected in SAP, and the full year plan otherwise reconciles to the NZALC budget.</a:t>
-            </a:r>
-            <a:endParaRPr lang="en-US" sz="900" dirty="0"/>
+              <a:t>July was a preparation month ahead of the FY26/27 delivery programme. No courses were conducted, with the first three activities commencing 8, 24 and 31 August. Expenditure is broadly consistent with preparation and enabling activity ahead of these courses.</a:t>
+            </a:r>
+            <a:endParaRPr lang="en-US" sz="960" dirty="0"/>
           </a:p>
         </p:txBody>
       </p:sp>
@@ -2736,165 +2736,8 @@
         </p:nvSpPr>
         <p:spPr>
           <a:xfrm>
-            <a:off x="566928" y="6309360"/>
-            <a:ext cx="6428232" cy="164592"/>
-          </a:xfrm>
-          <a:prstGeom prst="rect">
-            <a:avLst/>
-          </a:prstGeom>
-          <a:noFill/>
-          <a:ln/>
-        </p:spPr>
-        <p:txBody>
-          <a:bodyPr wrap="square" lIns="0" tIns="0" rIns="0" bIns="0" rtlCol="0" anchor="ctr"/>
-          <a:lstStyle/>
-          <a:p>
-            <a:pPr algn="l" indent="0" marL="0">
-              <a:buNone/>
-            </a:pPr>
-            <a:r>
-              <a:rPr lang="en-US" sz="740" b="1" spc="120" kern="0" dirty="0">
-                <a:solidFill>
-                  <a:srgbClr val="1A1A1A"/>
-                </a:solidFill>
-                <a:latin typeface="Arial" pitchFamily="34" charset="0"/>
-                <a:ea typeface="Arial" pitchFamily="34" charset="-122"/>
-                <a:cs typeface="Arial" pitchFamily="34" charset="-120"/>
-              </a:rPr>
-              <a:t>UNDER WATCH</a:t>
-            </a:r>
-            <a:endParaRPr lang="en-US" sz="740" dirty="0"/>
-          </a:p>
-        </p:txBody>
-      </p:sp>
-      <p:sp>
-        <p:nvSpPr>
-          <p:cNvPr id="59" name="Shape 56"/>
-          <p:cNvSpPr/>
-          <p:nvPr/>
-        </p:nvSpPr>
-        <p:spPr>
-          <a:xfrm>
-            <a:off x="566928" y="6483096"/>
-            <a:ext cx="6428232" cy="7315"/>
-          </a:xfrm>
-          <a:prstGeom prst="rect">
-            <a:avLst/>
-          </a:prstGeom>
-          <a:solidFill>
-            <a:srgbClr val="C8C8C8"/>
-          </a:solidFill>
-          <a:ln/>
-        </p:spPr>
-      </p:sp>
-      <p:sp>
-        <p:nvSpPr>
-          <p:cNvPr id="60" name="Shape 57"/>
-          <p:cNvSpPr/>
-          <p:nvPr/>
-        </p:nvSpPr>
-        <p:spPr>
-          <a:xfrm>
-            <a:off x="566928" y="6620256"/>
-            <a:ext cx="32004" cy="566928"/>
-          </a:xfrm>
-          <a:prstGeom prst="rect">
-            <a:avLst/>
-          </a:prstGeom>
-          <a:solidFill>
-            <a:srgbClr val="B3A650"/>
-          </a:solidFill>
-          <a:ln/>
-        </p:spPr>
-      </p:sp>
-      <p:sp>
-        <p:nvSpPr>
-          <p:cNvPr id="61" name="Text 58"/>
-          <p:cNvSpPr/>
-          <p:nvPr/>
-        </p:nvSpPr>
-        <p:spPr>
-          <a:xfrm>
-            <a:off x="713232" y="6620256"/>
-            <a:ext cx="5330952" cy="182880"/>
-          </a:xfrm>
-          <a:prstGeom prst="rect">
-            <a:avLst/>
-          </a:prstGeom>
-          <a:noFill/>
-          <a:ln/>
-        </p:spPr>
-        <p:txBody>
-          <a:bodyPr wrap="square" lIns="0" tIns="0" rIns="0" bIns="0" rtlCol="0" anchor="ctr"/>
-          <a:lstStyle/>
-          <a:p>
-            <a:pPr algn="l" indent="0" marL="0">
-              <a:buNone/>
-            </a:pPr>
-            <a:r>
-              <a:rPr lang="en-US" sz="920" b="1" dirty="0">
-                <a:solidFill>
-                  <a:srgbClr val="1A1A1A"/>
-                </a:solidFill>
-                <a:latin typeface="Arial" pitchFamily="34" charset="0"/>
-                <a:ea typeface="Arial" pitchFamily="34" charset="-122"/>
-                <a:cs typeface="Arial" pitchFamily="34" charset="-120"/>
-              </a:rPr>
-              <a:t>Cost elements carrying no budget</a:t>
-            </a:r>
-            <a:endParaRPr lang="en-US" sz="920" dirty="0"/>
-          </a:p>
-        </p:txBody>
-      </p:sp>
-      <p:sp>
-        <p:nvSpPr>
-          <p:cNvPr id="62" name="Text 59"/>
-          <p:cNvSpPr/>
-          <p:nvPr/>
-        </p:nvSpPr>
-        <p:spPr>
-          <a:xfrm>
-            <a:off x="5989320" y="6620256"/>
-            <a:ext cx="1005840" cy="182880"/>
-          </a:xfrm>
-          <a:prstGeom prst="rect">
-            <a:avLst/>
-          </a:prstGeom>
-          <a:noFill/>
-          <a:ln/>
-        </p:spPr>
-        <p:txBody>
-          <a:bodyPr wrap="square" lIns="0" tIns="0" rIns="0" bIns="0" rtlCol="0" anchor="ctr"/>
-          <a:lstStyle/>
-          <a:p>
-            <a:pPr algn="r" indent="0" marL="0">
-              <a:buNone/>
-            </a:pPr>
-            <a:r>
-              <a:rPr lang="en-US" sz="960" b="1" dirty="0">
-                <a:solidFill>
-                  <a:srgbClr val="1A1A1A"/>
-                </a:solidFill>
-                <a:latin typeface="Arial" pitchFamily="34" charset="0"/>
-                <a:ea typeface="Arial" pitchFamily="34" charset="-122"/>
-                <a:cs typeface="Arial" pitchFamily="34" charset="-120"/>
-              </a:rPr>
-              <a:t>$6.1k</a:t>
-            </a:r>
-            <a:endParaRPr lang="en-US" sz="960" dirty="0"/>
-          </a:p>
-        </p:txBody>
-      </p:sp>
-      <p:sp>
-        <p:nvSpPr>
-          <p:cNvPr id="63" name="Text 60"/>
-          <p:cNvSpPr/>
-          <p:nvPr/>
-        </p:nvSpPr>
-        <p:spPr>
-          <a:xfrm>
-            <a:off x="713232" y="6812280"/>
-            <a:ext cx="6153912" cy="384048"/>
+            <a:off x="566928" y="6473952"/>
+            <a:ext cx="6428232" cy="274320"/>
           </a:xfrm>
           <a:prstGeom prst="rect">
             <a:avLst/>
@@ -2908,12 +2751,12 @@
           <a:p>
             <a:pPr algn="l" indent="0" marL="0">
               <a:lnSpc>
-                <a:spcPct val="124000"/>
+                <a:spcPct val="126000"/>
               </a:lnSpc>
               <a:buNone/>
             </a:pPr>
             <a:r>
-              <a:rPr lang="en-US" sz="840" dirty="0">
+              <a:rPr lang="en-US" sz="960" dirty="0">
                 <a:solidFill>
                   <a:srgbClr val="1A1A1A"/>
                 </a:solidFill>
@@ -2921,22 +2764,81 @@
                 <a:ea typeface="Arial" pitchFamily="34" charset="-122"/>
                 <a:cs typeface="Arial" pitchFamily="34" charset="-120"/>
               </a:rPr>
-              <a:t>Civilian overtime and sundry expenses were incurred against lines that hold nil for the year. This is a coding or budget-line question rather than a phasing one, and is to be resolved with the Financial Adviser.</a:t>
-            </a:r>
-            <a:endParaRPr lang="en-US" sz="840" dirty="0"/>
-          </a:p>
-        </p:txBody>
-      </p:sp>
-      <p:sp>
-        <p:nvSpPr>
-          <p:cNvPr id="64" name="Shape 61"/>
-          <p:cNvSpPr/>
-          <p:nvPr/>
-        </p:nvSpPr>
-        <p:spPr>
-          <a:xfrm>
-            <a:off x="566928" y="7278624"/>
-            <a:ext cx="32004" cy="402336"/>
+              <a:t>The FY budget includes the additional $50k Winsborough allocation, bringing the SAP full-year plan to $811.6k.</a:t>
+            </a:r>
+            <a:endParaRPr lang="en-US" sz="960" dirty="0"/>
+          </a:p>
+        </p:txBody>
+      </p:sp>
+      <p:sp>
+        <p:nvSpPr>
+          <p:cNvPr id="59" name="Text 56"/>
+          <p:cNvSpPr/>
+          <p:nvPr/>
+        </p:nvSpPr>
+        <p:spPr>
+          <a:xfrm>
+            <a:off x="566928" y="6858000"/>
+            <a:ext cx="6428232" cy="164592"/>
+          </a:xfrm>
+          <a:prstGeom prst="rect">
+            <a:avLst/>
+          </a:prstGeom>
+          <a:noFill/>
+          <a:ln/>
+        </p:spPr>
+        <p:txBody>
+          <a:bodyPr wrap="square" lIns="0" tIns="0" rIns="0" bIns="0" rtlCol="0" anchor="ctr"/>
+          <a:lstStyle/>
+          <a:p>
+            <a:pPr algn="l" indent="0" marL="0">
+              <a:buNone/>
+            </a:pPr>
+            <a:r>
+              <a:rPr lang="en-US" sz="760" b="1" spc="120" kern="0" dirty="0">
+                <a:solidFill>
+                  <a:srgbClr val="1A1A1A"/>
+                </a:solidFill>
+                <a:latin typeface="Arial" pitchFamily="34" charset="0"/>
+                <a:ea typeface="Arial" pitchFamily="34" charset="-122"/>
+                <a:cs typeface="Arial" pitchFamily="34" charset="-120"/>
+              </a:rPr>
+              <a:t>UNDER WATCH</a:t>
+            </a:r>
+            <a:endParaRPr lang="en-US" sz="760" dirty="0"/>
+          </a:p>
+        </p:txBody>
+      </p:sp>
+      <p:sp>
+        <p:nvSpPr>
+          <p:cNvPr id="60" name="Shape 57"/>
+          <p:cNvSpPr/>
+          <p:nvPr/>
+        </p:nvSpPr>
+        <p:spPr>
+          <a:xfrm>
+            <a:off x="566928" y="7031736"/>
+            <a:ext cx="6428232" cy="7315"/>
+          </a:xfrm>
+          <a:prstGeom prst="rect">
+            <a:avLst/>
+          </a:prstGeom>
+          <a:solidFill>
+            <a:srgbClr val="C8C8C8"/>
+          </a:solidFill>
+          <a:ln/>
+        </p:spPr>
+      </p:sp>
+      <p:sp>
+        <p:nvSpPr>
+          <p:cNvPr id="61" name="Shape 58"/>
+          <p:cNvSpPr/>
+          <p:nvPr/>
+        </p:nvSpPr>
+        <p:spPr>
+          <a:xfrm>
+            <a:off x="566928" y="7187184"/>
+            <a:ext cx="36576" cy="493776"/>
           </a:xfrm>
           <a:prstGeom prst="rect">
             <a:avLst/>
@@ -2949,14 +2851,14 @@
       </p:sp>
       <p:sp>
         <p:nvSpPr>
-          <p:cNvPr id="65" name="Text 62"/>
-          <p:cNvSpPr/>
-          <p:nvPr/>
-        </p:nvSpPr>
-        <p:spPr>
-          <a:xfrm>
-            <a:off x="713232" y="7278624"/>
-            <a:ext cx="5330952" cy="182880"/>
+          <p:cNvPr id="62" name="Text 59"/>
+          <p:cNvSpPr/>
+          <p:nvPr/>
+        </p:nvSpPr>
+        <p:spPr>
+          <a:xfrm>
+            <a:off x="731520" y="7187184"/>
+            <a:ext cx="4965192" cy="201168"/>
           </a:xfrm>
           <a:prstGeom prst="rect">
             <a:avLst/>
@@ -2972,7 +2874,7 @@
               <a:buNone/>
             </a:pPr>
             <a:r>
-              <a:rPr lang="en-US" sz="920" b="1" dirty="0">
+              <a:rPr lang="en-US" sz="960" b="1" dirty="0">
                 <a:solidFill>
                   <a:srgbClr val="1A1A1A"/>
                 </a:solidFill>
@@ -2980,22 +2882,22 @@
                 <a:ea typeface="Arial" pitchFamily="34" charset="-122"/>
                 <a:cs typeface="Arial" pitchFamily="34" charset="-120"/>
               </a:rPr>
-              <a:t>Civilian allowance run rate</a:t>
-            </a:r>
-            <a:endParaRPr lang="en-US" sz="920" dirty="0"/>
-          </a:p>
-        </p:txBody>
-      </p:sp>
-      <p:sp>
-        <p:nvSpPr>
-          <p:cNvPr id="66" name="Text 63"/>
-          <p:cNvSpPr/>
-          <p:nvPr/>
-        </p:nvSpPr>
-        <p:spPr>
-          <a:xfrm>
-            <a:off x="5989320" y="7278624"/>
-            <a:ext cx="1005840" cy="182880"/>
+              <a:t>Nil-budget cost lines</a:t>
+            </a:r>
+            <a:endParaRPr lang="en-US" sz="960" dirty="0"/>
+          </a:p>
+        </p:txBody>
+      </p:sp>
+      <p:sp>
+        <p:nvSpPr>
+          <p:cNvPr id="63" name="Text 60"/>
+          <p:cNvSpPr/>
+          <p:nvPr/>
+        </p:nvSpPr>
+        <p:spPr>
+          <a:xfrm>
+            <a:off x="5623560" y="7187184"/>
+            <a:ext cx="1371600" cy="201168"/>
           </a:xfrm>
           <a:prstGeom prst="rect">
             <a:avLst/>
@@ -3011,7 +2913,7 @@
               <a:buNone/>
             </a:pPr>
             <a:r>
-              <a:rPr lang="en-US" sz="960" b="1" dirty="0">
+              <a:rPr lang="en-US" sz="980" b="1" dirty="0">
                 <a:solidFill>
                   <a:srgbClr val="1A1A1A"/>
                 </a:solidFill>
@@ -3019,22 +2921,22 @@
                 <a:ea typeface="Arial" pitchFamily="34" charset="-122"/>
                 <a:cs typeface="Arial" pitchFamily="34" charset="-120"/>
               </a:rPr>
-              <a:t>53%</a:t>
-            </a:r>
-            <a:endParaRPr lang="en-US" sz="960" dirty="0"/>
-          </a:p>
-        </p:txBody>
-      </p:sp>
-      <p:sp>
-        <p:nvSpPr>
-          <p:cNvPr id="67" name="Text 64"/>
-          <p:cNvSpPr/>
-          <p:nvPr/>
-        </p:nvSpPr>
-        <p:spPr>
-          <a:xfrm>
-            <a:off x="713232" y="7470648"/>
-            <a:ext cx="6153912" cy="384048"/>
+              <a:t>$6.1k</a:t>
+            </a:r>
+            <a:endParaRPr lang="en-US" sz="980" dirty="0"/>
+          </a:p>
+        </p:txBody>
+      </p:sp>
+      <p:sp>
+        <p:nvSpPr>
+          <p:cNvPr id="64" name="Text 61"/>
+          <p:cNvSpPr/>
+          <p:nvPr/>
+        </p:nvSpPr>
+        <p:spPr>
+          <a:xfrm>
+            <a:off x="731520" y="7406640"/>
+            <a:ext cx="6099048" cy="274320"/>
           </a:xfrm>
           <a:prstGeom prst="rect">
             <a:avLst/>
@@ -3048,12 +2950,12 @@
           <a:p>
             <a:pPr algn="l" indent="0" marL="0">
               <a:lnSpc>
-                <a:spcPct val="124000"/>
+                <a:spcPct val="126000"/>
               </a:lnSpc>
               <a:buNone/>
             </a:pPr>
             <a:r>
-              <a:rPr lang="en-US" sz="840" dirty="0">
+              <a:rPr lang="en-US" sz="900" dirty="0">
                 <a:solidFill>
                   <a:srgbClr val="1A1A1A"/>
                 </a:solidFill>
@@ -3061,9 +2963,107 @@
                 <a:ea typeface="Arial" pitchFamily="34" charset="-122"/>
                 <a:cs typeface="Arial" pitchFamily="34" charset="-120"/>
               </a:rPr>
-              <a:t>Just over half the $5.3k annual line was drawn in month 1. The rate is to be confirmed before the position compounds.</a:t>
-            </a:r>
-            <a:endParaRPr lang="en-US" sz="840" dirty="0"/>
+              <a:t>Civilian overtime and sundry expenses require coding and budget-line confirmation with the Financial Adviser.</a:t>
+            </a:r>
+            <a:endParaRPr lang="en-US" sz="900" dirty="0"/>
+          </a:p>
+        </p:txBody>
+      </p:sp>
+      <p:sp>
+        <p:nvSpPr>
+          <p:cNvPr id="65" name="Shape 62"/>
+          <p:cNvSpPr/>
+          <p:nvPr/>
+        </p:nvSpPr>
+        <p:spPr>
+          <a:xfrm>
+            <a:off x="566928" y="7827264"/>
+            <a:ext cx="36576" cy="384048"/>
+          </a:xfrm>
+          <a:prstGeom prst="rect">
+            <a:avLst/>
+          </a:prstGeom>
+          <a:solidFill>
+            <a:srgbClr val="B3A650"/>
+          </a:solidFill>
+          <a:ln/>
+        </p:spPr>
+      </p:sp>
+      <p:sp>
+        <p:nvSpPr>
+          <p:cNvPr id="66" name="Text 63"/>
+          <p:cNvSpPr/>
+          <p:nvPr/>
+        </p:nvSpPr>
+        <p:spPr>
+          <a:xfrm>
+            <a:off x="731520" y="7827264"/>
+            <a:ext cx="4965192" cy="201168"/>
+          </a:xfrm>
+          <a:prstGeom prst="rect">
+            <a:avLst/>
+          </a:prstGeom>
+          <a:noFill/>
+          <a:ln/>
+        </p:spPr>
+        <p:txBody>
+          <a:bodyPr wrap="square" lIns="0" tIns="0" rIns="0" bIns="0" rtlCol="0" anchor="ctr"/>
+          <a:lstStyle/>
+          <a:p>
+            <a:pPr algn="l" indent="0" marL="0">
+              <a:buNone/>
+            </a:pPr>
+            <a:r>
+              <a:rPr lang="en-US" sz="960" b="1" dirty="0">
+                <a:solidFill>
+                  <a:srgbClr val="1A1A1A"/>
+                </a:solidFill>
+                <a:latin typeface="Arial" pitchFamily="34" charset="0"/>
+                <a:ea typeface="Arial" pitchFamily="34" charset="-122"/>
+                <a:cs typeface="Arial" pitchFamily="34" charset="-120"/>
+              </a:rPr>
+              <a:t>Civilian allowances</a:t>
+            </a:r>
+            <a:endParaRPr lang="en-US" sz="960" dirty="0"/>
+          </a:p>
+        </p:txBody>
+      </p:sp>
+      <p:sp>
+        <p:nvSpPr>
+          <p:cNvPr id="67" name="Text 64"/>
+          <p:cNvSpPr/>
+          <p:nvPr/>
+        </p:nvSpPr>
+        <p:spPr>
+          <a:xfrm>
+            <a:off x="5623560" y="7827264"/>
+            <a:ext cx="1371600" cy="201168"/>
+          </a:xfrm>
+          <a:prstGeom prst="rect">
+            <a:avLst/>
+          </a:prstGeom>
+          <a:noFill/>
+          <a:ln/>
+        </p:spPr>
+        <p:txBody>
+          <a:bodyPr wrap="square" lIns="0" tIns="0" rIns="0" bIns="0" rtlCol="0" anchor="ctr"/>
+          <a:lstStyle/>
+          <a:p>
+            <a:pPr algn="r" indent="0" marL="0">
+              <a:buNone/>
+            </a:pPr>
+            <a:r>
+              <a:rPr lang="en-US" sz="980" b="1" dirty="0">
+                <a:solidFill>
+                  <a:srgbClr val="1A1A1A"/>
+                </a:solidFill>
+                <a:latin typeface="Arial" pitchFamily="34" charset="0"/>
+                <a:ea typeface="Arial" pitchFamily="34" charset="-122"/>
+                <a:cs typeface="Arial" pitchFamily="34" charset="-120"/>
+              </a:rPr>
+              <a:t>53% consumed</a:t>
+            </a:r>
+            <a:endParaRPr lang="en-US" sz="980" dirty="0"/>
           </a:p>
         </p:txBody>
       </p:sp>
@@ -3075,67 +3075,8 @@
         </p:nvSpPr>
         <p:spPr>
           <a:xfrm>
-            <a:off x="566928" y="7827264"/>
-            <a:ext cx="6428232" cy="164592"/>
-          </a:xfrm>
-          <a:prstGeom prst="rect">
-            <a:avLst/>
-          </a:prstGeom>
-          <a:noFill/>
-          <a:ln/>
-        </p:spPr>
-        <p:txBody>
-          <a:bodyPr wrap="square" lIns="0" tIns="0" rIns="0" bIns="0" rtlCol="0" anchor="ctr"/>
-          <a:lstStyle/>
-          <a:p>
-            <a:pPr algn="l" indent="0" marL="0">
-              <a:buNone/>
-            </a:pPr>
-            <a:r>
-              <a:rPr lang="en-US" sz="740" b="1" spc="120" kern="0" dirty="0">
-                <a:solidFill>
-                  <a:srgbClr val="1A1A1A"/>
-                </a:solidFill>
-                <a:latin typeface="Arial" pitchFamily="34" charset="0"/>
-                <a:ea typeface="Arial" pitchFamily="34" charset="-122"/>
-                <a:cs typeface="Arial" pitchFamily="34" charset="-120"/>
-              </a:rPr>
-              <a:t>OUTLOOK</a:t>
-            </a:r>
-            <a:endParaRPr lang="en-US" sz="740" dirty="0"/>
-          </a:p>
-        </p:txBody>
-      </p:sp>
-      <p:sp>
-        <p:nvSpPr>
-          <p:cNvPr id="69" name="Shape 66"/>
-          <p:cNvSpPr/>
-          <p:nvPr/>
-        </p:nvSpPr>
-        <p:spPr>
-          <a:xfrm>
-            <a:off x="566928" y="8001000"/>
-            <a:ext cx="6428232" cy="7315"/>
-          </a:xfrm>
-          <a:prstGeom prst="rect">
-            <a:avLst/>
-          </a:prstGeom>
-          <a:solidFill>
-            <a:srgbClr val="C8C8C8"/>
-          </a:solidFill>
-          <a:ln/>
-        </p:spPr>
-      </p:sp>
-      <p:sp>
-        <p:nvSpPr>
-          <p:cNvPr id="70" name="Text 67"/>
-          <p:cNvSpPr/>
-          <p:nvPr/>
-        </p:nvSpPr>
-        <p:spPr>
-          <a:xfrm>
-            <a:off x="566928" y="8138160"/>
-            <a:ext cx="6428232" cy="512064"/>
+            <a:off x="731520" y="8046720"/>
+            <a:ext cx="6099048" cy="274320"/>
           </a:xfrm>
           <a:prstGeom prst="rect">
             <a:avLst/>
@@ -3149,7 +3090,7 @@
           <a:p>
             <a:pPr algn="l" indent="0" marL="0">
               <a:lnSpc>
-                <a:spcPct val="124000"/>
+                <a:spcPct val="126000"/>
               </a:lnSpc>
               <a:buNone/>
             </a:pPr>
@@ -3162,7 +3103,7 @@
                 <a:ea typeface="Arial" pitchFamily="34" charset="-122"/>
                 <a:cs typeface="Arial" pitchFamily="34" charset="-120"/>
               </a:rPr>
-              <a:t>At the completion of Month 1 there is no clear indication of underlying FY budget pressure. The July variance will be monitored through August, with the combined July and August position providing a more meaningful assessment of expenditure against the programmed delivery profile.</a:t>
+              <a:t>Run rate to be confirmed before Month 2.</a:t>
             </a:r>
             <a:endParaRPr lang="en-US" sz="900" dirty="0"/>
           </a:p>
@@ -3170,13 +3111,13 @@
       </p:sp>
       <p:sp>
         <p:nvSpPr>
-          <p:cNvPr id="71" name="Text 68"/>
-          <p:cNvSpPr/>
-          <p:nvPr/>
-        </p:nvSpPr>
-        <p:spPr>
-          <a:xfrm>
-            <a:off x="566928" y="8723376"/>
+          <p:cNvPr id="69" name="Text 66"/>
+          <p:cNvSpPr/>
+          <p:nvPr/>
+        </p:nvSpPr>
+        <p:spPr>
+          <a:xfrm>
+            <a:off x="566928" y="8449056"/>
             <a:ext cx="6428232" cy="164592"/>
           </a:xfrm>
           <a:prstGeom prst="rect">
@@ -3193,7 +3134,7 @@
               <a:buNone/>
             </a:pPr>
             <a:r>
-              <a:rPr lang="en-US" sz="740" b="1" spc="120" kern="0" dirty="0">
+              <a:rPr lang="en-US" sz="760" b="1" spc="120" kern="0" dirty="0">
                 <a:solidFill>
                   <a:srgbClr val="1A1A1A"/>
                 </a:solidFill>
@@ -3203,9 +3144,49 @@
               </a:rPr>
               <a:t>COMMAND ASSESSMENT</a:t>
             </a:r>
-            <a:endParaRPr lang="en-US" sz="740" dirty="0"/>
-          </a:p>
-        </p:txBody>
+            <a:endParaRPr lang="en-US" sz="760" dirty="0"/>
+          </a:p>
+        </p:txBody>
+      </p:sp>
+      <p:sp>
+        <p:nvSpPr>
+          <p:cNvPr id="70" name="Shape 67"/>
+          <p:cNvSpPr/>
+          <p:nvPr/>
+        </p:nvSpPr>
+        <p:spPr>
+          <a:xfrm>
+            <a:off x="566928" y="8622792"/>
+            <a:ext cx="6428232" cy="7315"/>
+          </a:xfrm>
+          <a:prstGeom prst="rect">
+            <a:avLst/>
+          </a:prstGeom>
+          <a:solidFill>
+            <a:srgbClr val="C8C8C8"/>
+          </a:solidFill>
+          <a:ln/>
+        </p:spPr>
+      </p:sp>
+      <p:sp>
+        <p:nvSpPr>
+          <p:cNvPr id="71" name="Shape 68"/>
+          <p:cNvSpPr/>
+          <p:nvPr/>
+        </p:nvSpPr>
+        <p:spPr>
+          <a:xfrm>
+            <a:off x="566928" y="8778240"/>
+            <a:ext cx="6428232" cy="987552"/>
+          </a:xfrm>
+          <a:prstGeom prst="rect">
+            <a:avLst/>
+          </a:prstGeom>
+          <a:solidFill>
+            <a:srgbClr val="1A1A1A"/>
+          </a:solidFill>
+          <a:ln/>
+        </p:spPr>
       </p:sp>
       <p:sp>
         <p:nvSpPr>
@@ -3215,48 +3196,8 @@
         </p:nvSpPr>
         <p:spPr>
           <a:xfrm>
-            <a:off x="566928" y="8897112"/>
-            <a:ext cx="6428232" cy="7315"/>
-          </a:xfrm>
-          <a:prstGeom prst="rect">
-            <a:avLst/>
-          </a:prstGeom>
-          <a:solidFill>
-            <a:srgbClr val="C8C8C8"/>
-          </a:solidFill>
-          <a:ln/>
-        </p:spPr>
-      </p:sp>
-      <p:sp>
-        <p:nvSpPr>
-          <p:cNvPr id="73" name="Shape 70"/>
-          <p:cNvSpPr/>
-          <p:nvPr/>
-        </p:nvSpPr>
-        <p:spPr>
-          <a:xfrm>
-            <a:off x="566928" y="9034272"/>
-            <a:ext cx="6428232" cy="877824"/>
-          </a:xfrm>
-          <a:prstGeom prst="rect">
-            <a:avLst/>
-          </a:prstGeom>
-          <a:solidFill>
-            <a:srgbClr val="1A1A1A"/>
-          </a:solidFill>
-          <a:ln/>
-        </p:spPr>
-      </p:sp>
-      <p:sp>
-        <p:nvSpPr>
-          <p:cNvPr id="74" name="Shape 71"/>
-          <p:cNvSpPr/>
-          <p:nvPr/>
-        </p:nvSpPr>
-        <p:spPr>
-          <a:xfrm>
-            <a:off x="566928" y="9034272"/>
-            <a:ext cx="45720" cy="877824"/>
+            <a:off x="566928" y="8778240"/>
+            <a:ext cx="50292" cy="987552"/>
           </a:xfrm>
           <a:prstGeom prst="rect">
             <a:avLst/>
@@ -3269,14 +3210,14 @@
       </p:sp>
       <p:sp>
         <p:nvSpPr>
-          <p:cNvPr id="75" name="Text 72"/>
-          <p:cNvSpPr/>
-          <p:nvPr/>
-        </p:nvSpPr>
-        <p:spPr>
-          <a:xfrm>
-            <a:off x="822960" y="9162288"/>
-            <a:ext cx="5916168" cy="640080"/>
+          <p:cNvPr id="73" name="Text 70"/>
+          <p:cNvSpPr/>
+          <p:nvPr/>
+        </p:nvSpPr>
+        <p:spPr>
+          <a:xfrm>
+            <a:off x="859536" y="8942832"/>
+            <a:ext cx="5843016" cy="694944"/>
           </a:xfrm>
           <a:prstGeom prst="rect">
             <a:avLst/>
@@ -3290,12 +3231,12 @@
           <a:p>
             <a:pPr algn="l" indent="0" marL="0">
               <a:lnSpc>
-                <a:spcPct val="124000"/>
+                <a:spcPct val="128000"/>
               </a:lnSpc>
               <a:buNone/>
             </a:pPr>
             <a:r>
-              <a:rPr lang="en-US" sz="920" dirty="0">
+              <a:rPr lang="en-US" sz="980" dirty="0">
                 <a:solidFill>
                   <a:srgbClr val="FFFFFF"/>
                 </a:solidFill>
@@ -3303,15 +3244,15 @@
                 <a:ea typeface="Arial" pitchFamily="34" charset="-122"/>
                 <a:cs typeface="Arial" pitchFamily="34" charset="-120"/>
               </a:rPr>
-              <a:t>FY26/27 budget remains on track. July expenditure is $17.5k ahead of the monthly profile; this is assessed predominantly as front-loaded expenditure associated with preparation for the August course programme rather than a structural overspend. Current expenditure represents approximately 5 per cent of the annual budget, with no immediate corrective action required beyond continued monitoring.</a:t>
-            </a:r>
-            <a:endParaRPr lang="en-US" sz="920" dirty="0"/>
-          </a:p>
-        </p:txBody>
-      </p:sp>
-      <p:sp>
-        <p:nvSpPr>
-          <p:cNvPr id="76" name="Shape 73"/>
+              <a:t>FY26/27 remains on track. July's $17.5k adverse variance is assessed predominantly as front-loaded expenditure supporting the August course programme, rather than an emerging budget pressure. No corrective action is required at this stage beyond monitoring the combined July and August position.</a:t>
+            </a:r>
+            <a:endParaRPr lang="en-US" sz="980" dirty="0"/>
+          </a:p>
+        </p:txBody>
+      </p:sp>
+      <p:sp>
+        <p:nvSpPr>
+          <p:cNvPr id="74" name="Shape 71"/>
           <p:cNvSpPr/>
           <p:nvPr/>
         </p:nvSpPr>
@@ -3331,7 +3272,7 @@
       </p:sp>
       <p:sp>
         <p:nvSpPr>
-          <p:cNvPr id="77" name="Text 74"/>
+          <p:cNvPr id="75" name="Text 72"/>
           <p:cNvSpPr/>
           <p:nvPr/>
         </p:nvSpPr>
@@ -3370,7 +3311,7 @@
       </p:sp>
       <p:sp>
         <p:nvSpPr>
-          <p:cNvPr id="78" name="Text 75"/>
+          <p:cNvPr id="76" name="Text 73"/>
           <p:cNvSpPr/>
           <p:nvPr/>
         </p:nvSpPr>

</xml_diff>

<commit_message>
Remove the month 1 assessment section
Renames Command Assessment to Month 1 Command Assessment, which now
carries the reasoning alone. The Winsborough uplift moves onto the FY
budget tile so the only fact the removed section held is not lost.
Remaining sections take the reclaimed space.

Co-Authored-By: Claude Fable 5 <noreply@anthropic.com>
Claude-Session: https://claude.ai/code/session_01YLo1WfwUDkbwfJEF3ZNVbB
</commit_message>
<xml_diff>
--- a/output/nzalc-month1-comdt-update.pptx
+++ b/output/nzalc-month1-comdt-update.pptx
@@ -1181,8 +1181,8 @@
         </p:nvSpPr>
         <p:spPr>
           <a:xfrm>
-            <a:off x="566928" y="1719072"/>
-            <a:ext cx="1511046" cy="1042416"/>
+            <a:off x="566928" y="1828800"/>
+            <a:ext cx="1511046" cy="1133856"/>
           </a:xfrm>
           <a:prstGeom prst="rect">
             <a:avLst/>
@@ -1201,7 +1201,7 @@
         </p:nvSpPr>
         <p:spPr>
           <a:xfrm>
-            <a:off x="566928" y="1719072"/>
+            <a:off x="566928" y="1828800"/>
             <a:ext cx="1511046" cy="27432"/>
           </a:xfrm>
           <a:prstGeom prst="rect">
@@ -1221,7 +1221,7 @@
         </p:nvSpPr>
         <p:spPr>
           <a:xfrm>
-            <a:off x="704088" y="1847088"/>
+            <a:off x="704088" y="1956816"/>
             <a:ext cx="1236726" cy="146304"/>
           </a:xfrm>
           <a:prstGeom prst="rect">
@@ -1260,7 +1260,7 @@
         </p:nvSpPr>
         <p:spPr>
           <a:xfrm>
-            <a:off x="704088" y="2048256"/>
+            <a:off x="704088" y="2176272"/>
             <a:ext cx="1236726" cy="347472"/>
           </a:xfrm>
           <a:prstGeom prst="rect">
@@ -1299,8 +1299,8 @@
         </p:nvSpPr>
         <p:spPr>
           <a:xfrm>
-            <a:off x="704088" y="2432304"/>
-            <a:ext cx="1236726" cy="256032"/>
+            <a:off x="704088" y="2578608"/>
+            <a:ext cx="1236726" cy="329184"/>
           </a:xfrm>
           <a:prstGeom prst="rect">
             <a:avLst/>
@@ -1327,7 +1327,7 @@
                 <a:ea typeface="Arial" pitchFamily="34" charset="-122"/>
                 <a:cs typeface="Arial" pitchFamily="34" charset="-120"/>
               </a:rPr>
-              <a:t>SAP full-year plan</a:t>
+              <a:t>SAP full-year plan, includes $50k Winsborough</a:t>
             </a:r>
             <a:endParaRPr lang="en-US" sz="700" dirty="0"/>
           </a:p>
@@ -1341,8 +1341,8 @@
         </p:nvSpPr>
         <p:spPr>
           <a:xfrm>
-            <a:off x="2205990" y="1719072"/>
-            <a:ext cx="1511046" cy="1042416"/>
+            <a:off x="2205990" y="1828800"/>
+            <a:ext cx="1511046" cy="1133856"/>
           </a:xfrm>
           <a:prstGeom prst="rect">
             <a:avLst/>
@@ -1361,7 +1361,7 @@
         </p:nvSpPr>
         <p:spPr>
           <a:xfrm>
-            <a:off x="2205990" y="1719072"/>
+            <a:off x="2205990" y="1828800"/>
             <a:ext cx="1511046" cy="27432"/>
           </a:xfrm>
           <a:prstGeom prst="rect">
@@ -1381,7 +1381,7 @@
         </p:nvSpPr>
         <p:spPr>
           <a:xfrm>
-            <a:off x="2343150" y="1847088"/>
+            <a:off x="2343150" y="1956816"/>
             <a:ext cx="1236726" cy="146304"/>
           </a:xfrm>
           <a:prstGeom prst="rect">
@@ -1420,7 +1420,7 @@
         </p:nvSpPr>
         <p:spPr>
           <a:xfrm>
-            <a:off x="2343150" y="2048256"/>
+            <a:off x="2343150" y="2176272"/>
             <a:ext cx="1236726" cy="347472"/>
           </a:xfrm>
           <a:prstGeom prst="rect">
@@ -1459,8 +1459,8 @@
         </p:nvSpPr>
         <p:spPr>
           <a:xfrm>
-            <a:off x="2343150" y="2432304"/>
-            <a:ext cx="1236726" cy="256032"/>
+            <a:off x="2343150" y="2578608"/>
+            <a:ext cx="1236726" cy="329184"/>
           </a:xfrm>
           <a:prstGeom prst="rect">
             <a:avLst/>
@@ -1501,8 +1501,8 @@
         </p:nvSpPr>
         <p:spPr>
           <a:xfrm>
-            <a:off x="3845052" y="1719072"/>
-            <a:ext cx="1511046" cy="1042416"/>
+            <a:off x="3845052" y="1828800"/>
+            <a:ext cx="1511046" cy="1133856"/>
           </a:xfrm>
           <a:prstGeom prst="rect">
             <a:avLst/>
@@ -1521,7 +1521,7 @@
         </p:nvSpPr>
         <p:spPr>
           <a:xfrm>
-            <a:off x="3845052" y="1719072"/>
+            <a:off x="3845052" y="1828800"/>
             <a:ext cx="1511046" cy="27432"/>
           </a:xfrm>
           <a:prstGeom prst="rect">
@@ -1541,7 +1541,7 @@
         </p:nvSpPr>
         <p:spPr>
           <a:xfrm>
-            <a:off x="3982212" y="1847088"/>
+            <a:off x="3982212" y="1956816"/>
             <a:ext cx="1236726" cy="146304"/>
           </a:xfrm>
           <a:prstGeom prst="rect">
@@ -1580,7 +1580,7 @@
         </p:nvSpPr>
         <p:spPr>
           <a:xfrm>
-            <a:off x="3982212" y="2048256"/>
+            <a:off x="3982212" y="2176272"/>
             <a:ext cx="1236726" cy="347472"/>
           </a:xfrm>
           <a:prstGeom prst="rect">
@@ -1619,8 +1619,8 @@
         </p:nvSpPr>
         <p:spPr>
           <a:xfrm>
-            <a:off x="3982212" y="2432304"/>
-            <a:ext cx="1236726" cy="256032"/>
+            <a:off x="3982212" y="2578608"/>
+            <a:ext cx="1236726" cy="329184"/>
           </a:xfrm>
           <a:prstGeom prst="rect">
             <a:avLst/>
@@ -1661,8 +1661,8 @@
         </p:nvSpPr>
         <p:spPr>
           <a:xfrm>
-            <a:off x="5484114" y="1719072"/>
-            <a:ext cx="1511046" cy="1042416"/>
+            <a:off x="5484114" y="1828800"/>
+            <a:ext cx="1511046" cy="1133856"/>
           </a:xfrm>
           <a:prstGeom prst="rect">
             <a:avLst/>
@@ -1681,7 +1681,7 @@
         </p:nvSpPr>
         <p:spPr>
           <a:xfrm>
-            <a:off x="5484114" y="1719072"/>
+            <a:off x="5484114" y="1828800"/>
             <a:ext cx="1511046" cy="27432"/>
           </a:xfrm>
           <a:prstGeom prst="rect">
@@ -1701,7 +1701,7 @@
         </p:nvSpPr>
         <p:spPr>
           <a:xfrm>
-            <a:off x="5621274" y="1847088"/>
+            <a:off x="5621274" y="1956816"/>
             <a:ext cx="1236726" cy="146304"/>
           </a:xfrm>
           <a:prstGeom prst="rect">
@@ -1740,7 +1740,7 @@
         </p:nvSpPr>
         <p:spPr>
           <a:xfrm>
-            <a:off x="5621274" y="2048256"/>
+            <a:off x="5621274" y="2176272"/>
             <a:ext cx="1236726" cy="347472"/>
           </a:xfrm>
           <a:prstGeom prst="rect">
@@ -1779,8 +1779,8 @@
         </p:nvSpPr>
         <p:spPr>
           <a:xfrm>
-            <a:off x="5621274" y="2432304"/>
-            <a:ext cx="1236726" cy="256032"/>
+            <a:off x="5621274" y="2578608"/>
+            <a:ext cx="1236726" cy="329184"/>
           </a:xfrm>
           <a:prstGeom prst="rect">
             <a:avLst/>
@@ -1821,7 +1821,7 @@
         </p:nvSpPr>
         <p:spPr>
           <a:xfrm>
-            <a:off x="566928" y="3017520"/>
+            <a:off x="566928" y="3438144"/>
             <a:ext cx="6428232" cy="164592"/>
           </a:xfrm>
           <a:prstGeom prst="rect">
@@ -1860,7 +1860,7 @@
         </p:nvSpPr>
         <p:spPr>
           <a:xfrm>
-            <a:off x="566928" y="3191256"/>
+            <a:off x="566928" y="3611880"/>
             <a:ext cx="6428232" cy="7315"/>
           </a:xfrm>
           <a:prstGeom prst="rect">
@@ -1880,8 +1880,8 @@
         </p:nvSpPr>
         <p:spPr>
           <a:xfrm>
-            <a:off x="658368" y="3346704"/>
-            <a:ext cx="2743200" cy="347472"/>
+            <a:off x="658368" y="3767328"/>
+            <a:ext cx="2743200" cy="402336"/>
           </a:xfrm>
           <a:prstGeom prst="rect">
             <a:avLst/>
@@ -1908,8 +1908,8 @@
         </p:nvSpPr>
         <p:spPr>
           <a:xfrm>
-            <a:off x="3310128" y="3346704"/>
-            <a:ext cx="1143000" cy="347472"/>
+            <a:off x="3310128" y="3767328"/>
+            <a:ext cx="1143000" cy="402336"/>
           </a:xfrm>
           <a:prstGeom prst="rect">
             <a:avLst/>
@@ -1947,8 +1947,8 @@
         </p:nvSpPr>
         <p:spPr>
           <a:xfrm>
-            <a:off x="4544568" y="3346704"/>
-            <a:ext cx="1143000" cy="347472"/>
+            <a:off x="4544568" y="3767328"/>
+            <a:ext cx="1143000" cy="402336"/>
           </a:xfrm>
           <a:prstGeom prst="rect">
             <a:avLst/>
@@ -1986,8 +1986,8 @@
         </p:nvSpPr>
         <p:spPr>
           <a:xfrm>
-            <a:off x="5779008" y="3346704"/>
-            <a:ext cx="1124712" cy="347472"/>
+            <a:off x="5779008" y="3767328"/>
+            <a:ext cx="1124712" cy="402336"/>
           </a:xfrm>
           <a:prstGeom prst="rect">
             <a:avLst/>
@@ -2025,7 +2025,7 @@
         </p:nvSpPr>
         <p:spPr>
           <a:xfrm>
-            <a:off x="566928" y="3694176"/>
+            <a:off x="566928" y="4169664"/>
             <a:ext cx="6428232" cy="10973"/>
           </a:xfrm>
           <a:prstGeom prst="rect">
@@ -2045,8 +2045,8 @@
         </p:nvSpPr>
         <p:spPr>
           <a:xfrm>
-            <a:off x="658368" y="3730752"/>
-            <a:ext cx="2743200" cy="347472"/>
+            <a:off x="658368" y="4206240"/>
+            <a:ext cx="2743200" cy="402336"/>
           </a:xfrm>
           <a:prstGeom prst="rect">
             <a:avLst/>
@@ -2084,8 +2084,8 @@
         </p:nvSpPr>
         <p:spPr>
           <a:xfrm>
-            <a:off x="3310128" y="3730752"/>
-            <a:ext cx="1143000" cy="347472"/>
+            <a:off x="3310128" y="4206240"/>
+            <a:ext cx="1143000" cy="402336"/>
           </a:xfrm>
           <a:prstGeom prst="rect">
             <a:avLst/>
@@ -2123,8 +2123,8 @@
         </p:nvSpPr>
         <p:spPr>
           <a:xfrm>
-            <a:off x="4544568" y="3730752"/>
-            <a:ext cx="1143000" cy="347472"/>
+            <a:off x="4544568" y="4206240"/>
+            <a:ext cx="1143000" cy="402336"/>
           </a:xfrm>
           <a:prstGeom prst="rect">
             <a:avLst/>
@@ -2162,8 +2162,8 @@
         </p:nvSpPr>
         <p:spPr>
           <a:xfrm>
-            <a:off x="5779008" y="3730752"/>
-            <a:ext cx="1124712" cy="347472"/>
+            <a:off x="5779008" y="4206240"/>
+            <a:ext cx="1124712" cy="402336"/>
           </a:xfrm>
           <a:prstGeom prst="rect">
             <a:avLst/>
@@ -2201,7 +2201,7 @@
         </p:nvSpPr>
         <p:spPr>
           <a:xfrm>
-            <a:off x="566928" y="4078224"/>
+            <a:off x="566928" y="4608576"/>
             <a:ext cx="6428232" cy="5486"/>
           </a:xfrm>
           <a:prstGeom prst="rect">
@@ -2221,8 +2221,8 @@
         </p:nvSpPr>
         <p:spPr>
           <a:xfrm>
-            <a:off x="658368" y="4114800"/>
-            <a:ext cx="2743200" cy="347472"/>
+            <a:off x="658368" y="4645152"/>
+            <a:ext cx="2743200" cy="402336"/>
           </a:xfrm>
           <a:prstGeom prst="rect">
             <a:avLst/>
@@ -2260,8 +2260,8 @@
         </p:nvSpPr>
         <p:spPr>
           <a:xfrm>
-            <a:off x="3310128" y="4114800"/>
-            <a:ext cx="1143000" cy="347472"/>
+            <a:off x="3310128" y="4645152"/>
+            <a:ext cx="1143000" cy="402336"/>
           </a:xfrm>
           <a:prstGeom prst="rect">
             <a:avLst/>
@@ -2299,8 +2299,8 @@
         </p:nvSpPr>
         <p:spPr>
           <a:xfrm>
-            <a:off x="4544568" y="4114800"/>
-            <a:ext cx="1143000" cy="347472"/>
+            <a:off x="4544568" y="4645152"/>
+            <a:ext cx="1143000" cy="402336"/>
           </a:xfrm>
           <a:prstGeom prst="rect">
             <a:avLst/>
@@ -2338,8 +2338,8 @@
         </p:nvSpPr>
         <p:spPr>
           <a:xfrm>
-            <a:off x="5779008" y="4114800"/>
-            <a:ext cx="1124712" cy="347472"/>
+            <a:off x="5779008" y="4645152"/>
+            <a:ext cx="1124712" cy="402336"/>
           </a:xfrm>
           <a:prstGeom prst="rect">
             <a:avLst/>
@@ -2377,7 +2377,7 @@
         </p:nvSpPr>
         <p:spPr>
           <a:xfrm>
-            <a:off x="566928" y="4462272"/>
+            <a:off x="566928" y="5047488"/>
             <a:ext cx="6428232" cy="5486"/>
           </a:xfrm>
           <a:prstGeom prst="rect">
@@ -2397,8 +2397,8 @@
         </p:nvSpPr>
         <p:spPr>
           <a:xfrm>
-            <a:off x="566928" y="4498848"/>
-            <a:ext cx="6428232" cy="347472"/>
+            <a:off x="566928" y="5084064"/>
+            <a:ext cx="6428232" cy="402336"/>
           </a:xfrm>
           <a:prstGeom prst="rect">
             <a:avLst/>
@@ -2417,8 +2417,8 @@
         </p:nvSpPr>
         <p:spPr>
           <a:xfrm>
-            <a:off x="658368" y="4498848"/>
-            <a:ext cx="2743200" cy="347472"/>
+            <a:off x="658368" y="5084064"/>
+            <a:ext cx="2743200" cy="402336"/>
           </a:xfrm>
           <a:prstGeom prst="rect">
             <a:avLst/>
@@ -2456,8 +2456,8 @@
         </p:nvSpPr>
         <p:spPr>
           <a:xfrm>
-            <a:off x="3310128" y="4498848"/>
-            <a:ext cx="1143000" cy="347472"/>
+            <a:off x="3310128" y="5084064"/>
+            <a:ext cx="1143000" cy="402336"/>
           </a:xfrm>
           <a:prstGeom prst="rect">
             <a:avLst/>
@@ -2495,8 +2495,8 @@
         </p:nvSpPr>
         <p:spPr>
           <a:xfrm>
-            <a:off x="4544568" y="4498848"/>
-            <a:ext cx="1143000" cy="347472"/>
+            <a:off x="4544568" y="5084064"/>
+            <a:ext cx="1143000" cy="402336"/>
           </a:xfrm>
           <a:prstGeom prst="rect">
             <a:avLst/>
@@ -2534,8 +2534,8 @@
         </p:nvSpPr>
         <p:spPr>
           <a:xfrm>
-            <a:off x="5779008" y="4498848"/>
-            <a:ext cx="1124712" cy="347472"/>
+            <a:off x="5779008" y="5084064"/>
+            <a:ext cx="1124712" cy="402336"/>
           </a:xfrm>
           <a:prstGeom prst="rect">
             <a:avLst/>
@@ -2573,7 +2573,7 @@
         </p:nvSpPr>
         <p:spPr>
           <a:xfrm>
-            <a:off x="566928" y="4846320"/>
+            <a:off x="566928" y="5486400"/>
             <a:ext cx="6428232" cy="10973"/>
           </a:xfrm>
           <a:prstGeom prst="rect">
@@ -2593,7 +2593,7 @@
         </p:nvSpPr>
         <p:spPr>
           <a:xfrm>
-            <a:off x="566928" y="4974336"/>
+            <a:off x="566928" y="5797296"/>
             <a:ext cx="6428232" cy="164592"/>
           </a:xfrm>
           <a:prstGeom prst="rect">
@@ -2618,7 +2618,7 @@
                 <a:ea typeface="Arial" pitchFamily="34" charset="-122"/>
                 <a:cs typeface="Arial" pitchFamily="34" charset="-120"/>
               </a:rPr>
-              <a:t>MONTH 1 ASSESSMENT</a:t>
+              <a:t>UNDER WATCH</a:t>
             </a:r>
             <a:endParaRPr lang="en-US" sz="760" dirty="0"/>
           </a:p>
@@ -2632,7 +2632,7 @@
         </p:nvSpPr>
         <p:spPr>
           <a:xfrm>
-            <a:off x="566928" y="5148072"/>
+            <a:off x="566928" y="5971032"/>
             <a:ext cx="6428232" cy="7315"/>
           </a:xfrm>
           <a:prstGeom prst="rect">
@@ -2646,14 +2646,112 @@
       </p:sp>
       <p:sp>
         <p:nvSpPr>
-          <p:cNvPr id="56" name="Text 53"/>
-          <p:cNvSpPr/>
-          <p:nvPr/>
-        </p:nvSpPr>
-        <p:spPr>
-          <a:xfrm>
-            <a:off x="566928" y="5303520"/>
-            <a:ext cx="6428232" cy="329184"/>
+          <p:cNvPr id="56" name="Shape 53"/>
+          <p:cNvSpPr/>
+          <p:nvPr/>
+        </p:nvSpPr>
+        <p:spPr>
+          <a:xfrm>
+            <a:off x="566928" y="6126480"/>
+            <a:ext cx="36576" cy="548640"/>
+          </a:xfrm>
+          <a:prstGeom prst="rect">
+            <a:avLst/>
+          </a:prstGeom>
+          <a:solidFill>
+            <a:srgbClr val="B3A650"/>
+          </a:solidFill>
+          <a:ln/>
+        </p:spPr>
+      </p:sp>
+      <p:sp>
+        <p:nvSpPr>
+          <p:cNvPr id="57" name="Text 54"/>
+          <p:cNvSpPr/>
+          <p:nvPr/>
+        </p:nvSpPr>
+        <p:spPr>
+          <a:xfrm>
+            <a:off x="731520" y="6126480"/>
+            <a:ext cx="4965192" cy="201168"/>
+          </a:xfrm>
+          <a:prstGeom prst="rect">
+            <a:avLst/>
+          </a:prstGeom>
+          <a:noFill/>
+          <a:ln/>
+        </p:spPr>
+        <p:txBody>
+          <a:bodyPr wrap="square" lIns="0" tIns="0" rIns="0" bIns="0" rtlCol="0" anchor="ctr"/>
+          <a:lstStyle/>
+          <a:p>
+            <a:pPr algn="l" indent="0" marL="0">
+              <a:buNone/>
+            </a:pPr>
+            <a:r>
+              <a:rPr lang="en-US" sz="960" b="1" dirty="0">
+                <a:solidFill>
+                  <a:srgbClr val="1A1A1A"/>
+                </a:solidFill>
+                <a:latin typeface="Arial" pitchFamily="34" charset="0"/>
+                <a:ea typeface="Arial" pitchFamily="34" charset="-122"/>
+                <a:cs typeface="Arial" pitchFamily="34" charset="-120"/>
+              </a:rPr>
+              <a:t>Nil-budget cost lines</a:t>
+            </a:r>
+            <a:endParaRPr lang="en-US" sz="960" dirty="0"/>
+          </a:p>
+        </p:txBody>
+      </p:sp>
+      <p:sp>
+        <p:nvSpPr>
+          <p:cNvPr id="58" name="Text 55"/>
+          <p:cNvSpPr/>
+          <p:nvPr/>
+        </p:nvSpPr>
+        <p:spPr>
+          <a:xfrm>
+            <a:off x="5623560" y="6126480"/>
+            <a:ext cx="1371600" cy="201168"/>
+          </a:xfrm>
+          <a:prstGeom prst="rect">
+            <a:avLst/>
+          </a:prstGeom>
+          <a:noFill/>
+          <a:ln/>
+        </p:spPr>
+        <p:txBody>
+          <a:bodyPr wrap="square" lIns="0" tIns="0" rIns="0" bIns="0" rtlCol="0" anchor="ctr"/>
+          <a:lstStyle/>
+          <a:p>
+            <a:pPr algn="r" indent="0" marL="0">
+              <a:buNone/>
+            </a:pPr>
+            <a:r>
+              <a:rPr lang="en-US" sz="980" b="1" dirty="0">
+                <a:solidFill>
+                  <a:srgbClr val="1A1A1A"/>
+                </a:solidFill>
+                <a:latin typeface="Arial" pitchFamily="34" charset="0"/>
+                <a:ea typeface="Arial" pitchFamily="34" charset="-122"/>
+                <a:cs typeface="Arial" pitchFamily="34" charset="-120"/>
+              </a:rPr>
+              <a:t>$6.1k</a:t>
+            </a:r>
+            <a:endParaRPr lang="en-US" sz="980" dirty="0"/>
+          </a:p>
+        </p:txBody>
+      </p:sp>
+      <p:sp>
+        <p:nvSpPr>
+          <p:cNvPr id="59" name="Text 56"/>
+          <p:cNvSpPr/>
+          <p:nvPr/>
+        </p:nvSpPr>
+        <p:spPr>
+          <a:xfrm>
+            <a:off x="731520" y="6345936"/>
+            <a:ext cx="6099048" cy="274320"/>
           </a:xfrm>
           <a:prstGeom prst="rect">
             <a:avLst/>
@@ -2672,7 +2770,7 @@
               <a:buNone/>
             </a:pPr>
             <a:r>
-              <a:rPr lang="en-US" sz="960" dirty="0">
+              <a:rPr lang="en-US" sz="900" dirty="0">
                 <a:solidFill>
                   <a:srgbClr val="1A1A1A"/>
                 </a:solidFill>
@@ -2680,7 +2778,66 @@
                 <a:ea typeface="Arial" pitchFamily="34" charset="-122"/>
                 <a:cs typeface="Arial" pitchFamily="34" charset="-120"/>
               </a:rPr>
-              <a:t>July expenditure was $17.5k ahead of profile, assessed primarily as a timing and phasing variance rather than structural overspend.</a:t>
+              <a:t>Civilian overtime and sundry expenses require coding and budget-line confirmation with the Financial Adviser.</a:t>
+            </a:r>
+            <a:endParaRPr lang="en-US" sz="900" dirty="0"/>
+          </a:p>
+        </p:txBody>
+      </p:sp>
+      <p:sp>
+        <p:nvSpPr>
+          <p:cNvPr id="60" name="Shape 57"/>
+          <p:cNvSpPr/>
+          <p:nvPr/>
+        </p:nvSpPr>
+        <p:spPr>
+          <a:xfrm>
+            <a:off x="566928" y="6876288"/>
+            <a:ext cx="36576" cy="438912"/>
+          </a:xfrm>
+          <a:prstGeom prst="rect">
+            <a:avLst/>
+          </a:prstGeom>
+          <a:solidFill>
+            <a:srgbClr val="B3A650"/>
+          </a:solidFill>
+          <a:ln/>
+        </p:spPr>
+      </p:sp>
+      <p:sp>
+        <p:nvSpPr>
+          <p:cNvPr id="61" name="Text 58"/>
+          <p:cNvSpPr/>
+          <p:nvPr/>
+        </p:nvSpPr>
+        <p:spPr>
+          <a:xfrm>
+            <a:off x="731520" y="6876288"/>
+            <a:ext cx="4965192" cy="201168"/>
+          </a:xfrm>
+          <a:prstGeom prst="rect">
+            <a:avLst/>
+          </a:prstGeom>
+          <a:noFill/>
+          <a:ln/>
+        </p:spPr>
+        <p:txBody>
+          <a:bodyPr wrap="square" lIns="0" tIns="0" rIns="0" bIns="0" rtlCol="0" anchor="ctr"/>
+          <a:lstStyle/>
+          <a:p>
+            <a:pPr algn="l" indent="0" marL="0">
+              <a:buNone/>
+            </a:pPr>
+            <a:r>
+              <a:rPr lang="en-US" sz="960" b="1" dirty="0">
+                <a:solidFill>
+                  <a:srgbClr val="1A1A1A"/>
+                </a:solidFill>
+                <a:latin typeface="Arial" pitchFamily="34" charset="0"/>
+                <a:ea typeface="Arial" pitchFamily="34" charset="-122"/>
+                <a:cs typeface="Arial" pitchFamily="34" charset="-120"/>
+              </a:rPr>
+              <a:t>Civilian allowances</a:t>
             </a:r>
             <a:endParaRPr lang="en-US" sz="960" dirty="0"/>
           </a:p>
@@ -2688,14 +2845,53 @@
       </p:sp>
       <p:sp>
         <p:nvSpPr>
-          <p:cNvPr id="57" name="Text 54"/>
-          <p:cNvSpPr/>
-          <p:nvPr/>
-        </p:nvSpPr>
-        <p:spPr>
-          <a:xfrm>
-            <a:off x="566928" y="5815584"/>
-            <a:ext cx="6428232" cy="566928"/>
+          <p:cNvPr id="62" name="Text 59"/>
+          <p:cNvSpPr/>
+          <p:nvPr/>
+        </p:nvSpPr>
+        <p:spPr>
+          <a:xfrm>
+            <a:off x="5623560" y="6876288"/>
+            <a:ext cx="1371600" cy="201168"/>
+          </a:xfrm>
+          <a:prstGeom prst="rect">
+            <a:avLst/>
+          </a:prstGeom>
+          <a:noFill/>
+          <a:ln/>
+        </p:spPr>
+        <p:txBody>
+          <a:bodyPr wrap="square" lIns="0" tIns="0" rIns="0" bIns="0" rtlCol="0" anchor="ctr"/>
+          <a:lstStyle/>
+          <a:p>
+            <a:pPr algn="r" indent="0" marL="0">
+              <a:buNone/>
+            </a:pPr>
+            <a:r>
+              <a:rPr lang="en-US" sz="980" b="1" dirty="0">
+                <a:solidFill>
+                  <a:srgbClr val="1A1A1A"/>
+                </a:solidFill>
+                <a:latin typeface="Arial" pitchFamily="34" charset="0"/>
+                <a:ea typeface="Arial" pitchFamily="34" charset="-122"/>
+                <a:cs typeface="Arial" pitchFamily="34" charset="-120"/>
+              </a:rPr>
+              <a:t>53% consumed</a:t>
+            </a:r>
+            <a:endParaRPr lang="en-US" sz="980" dirty="0"/>
+          </a:p>
+        </p:txBody>
+      </p:sp>
+      <p:sp>
+        <p:nvSpPr>
+          <p:cNvPr id="63" name="Text 60"/>
+          <p:cNvSpPr/>
+          <p:nvPr/>
+        </p:nvSpPr>
+        <p:spPr>
+          <a:xfrm>
+            <a:off x="731520" y="7095744"/>
+            <a:ext cx="6099048" cy="274320"/>
           </a:xfrm>
           <a:prstGeom prst="rect">
             <a:avLst/>
@@ -2714,7 +2910,7 @@
               <a:buNone/>
             </a:pPr>
             <a:r>
-              <a:rPr lang="en-US" sz="960" dirty="0">
+              <a:rPr lang="en-US" sz="900" dirty="0">
                 <a:solidFill>
                   <a:srgbClr val="1A1A1A"/>
                 </a:solidFill>
@@ -2722,41 +2918,38 @@
                 <a:ea typeface="Arial" pitchFamily="34" charset="-122"/>
                 <a:cs typeface="Arial" pitchFamily="34" charset="-120"/>
               </a:rPr>
-              <a:t>July was a preparation month ahead of the FY26/27 delivery programme. No courses were conducted, with the first three activities commencing 8, 24 and 31 August. Expenditure is broadly consistent with preparation and enabling activity ahead of these courses.</a:t>
-            </a:r>
-            <a:endParaRPr lang="en-US" sz="960" dirty="0"/>
-          </a:p>
-        </p:txBody>
-      </p:sp>
-      <p:sp>
-        <p:nvSpPr>
-          <p:cNvPr id="58" name="Text 55"/>
-          <p:cNvSpPr/>
-          <p:nvPr/>
-        </p:nvSpPr>
-        <p:spPr>
-          <a:xfrm>
-            <a:off x="566928" y="6473952"/>
-            <a:ext cx="6428232" cy="274320"/>
-          </a:xfrm>
-          <a:prstGeom prst="rect">
-            <a:avLst/>
-          </a:prstGeom>
-          <a:noFill/>
-          <a:ln/>
-        </p:spPr>
-        <p:txBody>
-          <a:bodyPr wrap="square" lIns="0" tIns="0" rIns="0" bIns="0" rtlCol="0" anchor="t"/>
+              <a:t>Run rate to be confirmed before Month 2.</a:t>
+            </a:r>
+            <a:endParaRPr lang="en-US" sz="900" dirty="0"/>
+          </a:p>
+        </p:txBody>
+      </p:sp>
+      <p:sp>
+        <p:nvSpPr>
+          <p:cNvPr id="64" name="Text 61"/>
+          <p:cNvSpPr/>
+          <p:nvPr/>
+        </p:nvSpPr>
+        <p:spPr>
+          <a:xfrm>
+            <a:off x="566928" y="7918704"/>
+            <a:ext cx="6428232" cy="164592"/>
+          </a:xfrm>
+          <a:prstGeom prst="rect">
+            <a:avLst/>
+          </a:prstGeom>
+          <a:noFill/>
+          <a:ln/>
+        </p:spPr>
+        <p:txBody>
+          <a:bodyPr wrap="square" lIns="0" tIns="0" rIns="0" bIns="0" rtlCol="0" anchor="ctr"/>
           <a:lstStyle/>
           <a:p>
             <a:pPr algn="l" indent="0" marL="0">
-              <a:lnSpc>
-                <a:spcPct val="126000"/>
-              </a:lnSpc>
-              <a:buNone/>
-            </a:pPr>
-            <a:r>
-              <a:rPr lang="en-US" sz="960" dirty="0">
+              <a:buNone/>
+            </a:pPr>
+            <a:r>
+              <a:rPr lang="en-US" sz="760" b="1" spc="120" kern="0" dirty="0">
                 <a:solidFill>
                   <a:srgbClr val="1A1A1A"/>
                 </a:solidFill>
@@ -2764,46 +2957,7 @@
                 <a:ea typeface="Arial" pitchFamily="34" charset="-122"/>
                 <a:cs typeface="Arial" pitchFamily="34" charset="-120"/>
               </a:rPr>
-              <a:t>The FY budget includes the additional $50k Winsborough allocation, bringing the SAP full-year plan to $811.6k.</a:t>
-            </a:r>
-            <a:endParaRPr lang="en-US" sz="960" dirty="0"/>
-          </a:p>
-        </p:txBody>
-      </p:sp>
-      <p:sp>
-        <p:nvSpPr>
-          <p:cNvPr id="59" name="Text 56"/>
-          <p:cNvSpPr/>
-          <p:nvPr/>
-        </p:nvSpPr>
-        <p:spPr>
-          <a:xfrm>
-            <a:off x="566928" y="6858000"/>
-            <a:ext cx="6428232" cy="164592"/>
-          </a:xfrm>
-          <a:prstGeom prst="rect">
-            <a:avLst/>
-          </a:prstGeom>
-          <a:noFill/>
-          <a:ln/>
-        </p:spPr>
-        <p:txBody>
-          <a:bodyPr wrap="square" lIns="0" tIns="0" rIns="0" bIns="0" rtlCol="0" anchor="ctr"/>
-          <a:lstStyle/>
-          <a:p>
-            <a:pPr algn="l" indent="0" marL="0">
-              <a:buNone/>
-            </a:pPr>
-            <a:r>
-              <a:rPr lang="en-US" sz="760" b="1" spc="120" kern="0" dirty="0">
-                <a:solidFill>
-                  <a:srgbClr val="1A1A1A"/>
-                </a:solidFill>
-                <a:latin typeface="Arial" pitchFamily="34" charset="0"/>
-                <a:ea typeface="Arial" pitchFamily="34" charset="-122"/>
-                <a:cs typeface="Arial" pitchFamily="34" charset="-120"/>
-              </a:rPr>
-              <a:t>UNDER WATCH</a:t>
+              <a:t>MONTH 1 COMMAND ASSESSMENT</a:t>
             </a:r>
             <a:endParaRPr lang="en-US" sz="760" dirty="0"/>
           </a:p>
@@ -2811,13 +2965,13 @@
       </p:sp>
       <p:sp>
         <p:nvSpPr>
-          <p:cNvPr id="60" name="Shape 57"/>
-          <p:cNvSpPr/>
-          <p:nvPr/>
-        </p:nvSpPr>
-        <p:spPr>
-          <a:xfrm>
-            <a:off x="566928" y="7031736"/>
+          <p:cNvPr id="65" name="Shape 62"/>
+          <p:cNvSpPr/>
+          <p:nvPr/>
+        </p:nvSpPr>
+        <p:spPr>
+          <a:xfrm>
+            <a:off x="566928" y="8092440"/>
             <a:ext cx="6428232" cy="7315"/>
           </a:xfrm>
           <a:prstGeom prst="rect">
@@ -2831,14 +2985,34 @@
       </p:sp>
       <p:sp>
         <p:nvSpPr>
-          <p:cNvPr id="61" name="Shape 58"/>
-          <p:cNvSpPr/>
-          <p:nvPr/>
-        </p:nvSpPr>
-        <p:spPr>
-          <a:xfrm>
-            <a:off x="566928" y="7187184"/>
-            <a:ext cx="36576" cy="493776"/>
+          <p:cNvPr id="66" name="Shape 63"/>
+          <p:cNvSpPr/>
+          <p:nvPr/>
+        </p:nvSpPr>
+        <p:spPr>
+          <a:xfrm>
+            <a:off x="566928" y="8247888"/>
+            <a:ext cx="6428232" cy="1225296"/>
+          </a:xfrm>
+          <a:prstGeom prst="rect">
+            <a:avLst/>
+          </a:prstGeom>
+          <a:solidFill>
+            <a:srgbClr val="1A1A1A"/>
+          </a:solidFill>
+          <a:ln/>
+        </p:spPr>
+      </p:sp>
+      <p:sp>
+        <p:nvSpPr>
+          <p:cNvPr id="67" name="Shape 64"/>
+          <p:cNvSpPr/>
+          <p:nvPr/>
+        </p:nvSpPr>
+        <p:spPr>
+          <a:xfrm>
+            <a:off x="566928" y="8247888"/>
+            <a:ext cx="50292" cy="1225296"/>
           </a:xfrm>
           <a:prstGeom prst="rect">
             <a:avLst/>
@@ -2851,373 +3025,14 @@
       </p:sp>
       <p:sp>
         <p:nvSpPr>
-          <p:cNvPr id="62" name="Text 59"/>
-          <p:cNvSpPr/>
-          <p:nvPr/>
-        </p:nvSpPr>
-        <p:spPr>
-          <a:xfrm>
-            <a:off x="731520" y="7187184"/>
-            <a:ext cx="4965192" cy="201168"/>
-          </a:xfrm>
-          <a:prstGeom prst="rect">
-            <a:avLst/>
-          </a:prstGeom>
-          <a:noFill/>
-          <a:ln/>
-        </p:spPr>
-        <p:txBody>
-          <a:bodyPr wrap="square" lIns="0" tIns="0" rIns="0" bIns="0" rtlCol="0" anchor="ctr"/>
-          <a:lstStyle/>
-          <a:p>
-            <a:pPr algn="l" indent="0" marL="0">
-              <a:buNone/>
-            </a:pPr>
-            <a:r>
-              <a:rPr lang="en-US" sz="960" b="1" dirty="0">
-                <a:solidFill>
-                  <a:srgbClr val="1A1A1A"/>
-                </a:solidFill>
-                <a:latin typeface="Arial" pitchFamily="34" charset="0"/>
-                <a:ea typeface="Arial" pitchFamily="34" charset="-122"/>
-                <a:cs typeface="Arial" pitchFamily="34" charset="-120"/>
-              </a:rPr>
-              <a:t>Nil-budget cost lines</a:t>
-            </a:r>
-            <a:endParaRPr lang="en-US" sz="960" dirty="0"/>
-          </a:p>
-        </p:txBody>
-      </p:sp>
-      <p:sp>
-        <p:nvSpPr>
-          <p:cNvPr id="63" name="Text 60"/>
-          <p:cNvSpPr/>
-          <p:nvPr/>
-        </p:nvSpPr>
-        <p:spPr>
-          <a:xfrm>
-            <a:off x="5623560" y="7187184"/>
-            <a:ext cx="1371600" cy="201168"/>
-          </a:xfrm>
-          <a:prstGeom prst="rect">
-            <a:avLst/>
-          </a:prstGeom>
-          <a:noFill/>
-          <a:ln/>
-        </p:spPr>
-        <p:txBody>
-          <a:bodyPr wrap="square" lIns="0" tIns="0" rIns="0" bIns="0" rtlCol="0" anchor="ctr"/>
-          <a:lstStyle/>
-          <a:p>
-            <a:pPr algn="r" indent="0" marL="0">
-              <a:buNone/>
-            </a:pPr>
-            <a:r>
-              <a:rPr lang="en-US" sz="980" b="1" dirty="0">
-                <a:solidFill>
-                  <a:srgbClr val="1A1A1A"/>
-                </a:solidFill>
-                <a:latin typeface="Arial" pitchFamily="34" charset="0"/>
-                <a:ea typeface="Arial" pitchFamily="34" charset="-122"/>
-                <a:cs typeface="Arial" pitchFamily="34" charset="-120"/>
-              </a:rPr>
-              <a:t>$6.1k</a:t>
-            </a:r>
-            <a:endParaRPr lang="en-US" sz="980" dirty="0"/>
-          </a:p>
-        </p:txBody>
-      </p:sp>
-      <p:sp>
-        <p:nvSpPr>
-          <p:cNvPr id="64" name="Text 61"/>
-          <p:cNvSpPr/>
-          <p:nvPr/>
-        </p:nvSpPr>
-        <p:spPr>
-          <a:xfrm>
-            <a:off x="731520" y="7406640"/>
-            <a:ext cx="6099048" cy="274320"/>
-          </a:xfrm>
-          <a:prstGeom prst="rect">
-            <a:avLst/>
-          </a:prstGeom>
-          <a:noFill/>
-          <a:ln/>
-        </p:spPr>
-        <p:txBody>
-          <a:bodyPr wrap="square" lIns="0" tIns="0" rIns="0" bIns="0" rtlCol="0" anchor="t"/>
-          <a:lstStyle/>
-          <a:p>
-            <a:pPr algn="l" indent="0" marL="0">
-              <a:lnSpc>
-                <a:spcPct val="126000"/>
-              </a:lnSpc>
-              <a:buNone/>
-            </a:pPr>
-            <a:r>
-              <a:rPr lang="en-US" sz="900" dirty="0">
-                <a:solidFill>
-                  <a:srgbClr val="1A1A1A"/>
-                </a:solidFill>
-                <a:latin typeface="Arial" pitchFamily="34" charset="0"/>
-                <a:ea typeface="Arial" pitchFamily="34" charset="-122"/>
-                <a:cs typeface="Arial" pitchFamily="34" charset="-120"/>
-              </a:rPr>
-              <a:t>Civilian overtime and sundry expenses require coding and budget-line confirmation with the Financial Adviser.</a:t>
-            </a:r>
-            <a:endParaRPr lang="en-US" sz="900" dirty="0"/>
-          </a:p>
-        </p:txBody>
-      </p:sp>
-      <p:sp>
-        <p:nvSpPr>
-          <p:cNvPr id="65" name="Shape 62"/>
-          <p:cNvSpPr/>
-          <p:nvPr/>
-        </p:nvSpPr>
-        <p:spPr>
-          <a:xfrm>
-            <a:off x="566928" y="7827264"/>
-            <a:ext cx="36576" cy="384048"/>
-          </a:xfrm>
-          <a:prstGeom prst="rect">
-            <a:avLst/>
-          </a:prstGeom>
-          <a:solidFill>
-            <a:srgbClr val="B3A650"/>
-          </a:solidFill>
-          <a:ln/>
-        </p:spPr>
-      </p:sp>
-      <p:sp>
-        <p:nvSpPr>
-          <p:cNvPr id="66" name="Text 63"/>
-          <p:cNvSpPr/>
-          <p:nvPr/>
-        </p:nvSpPr>
-        <p:spPr>
-          <a:xfrm>
-            <a:off x="731520" y="7827264"/>
-            <a:ext cx="4965192" cy="201168"/>
-          </a:xfrm>
-          <a:prstGeom prst="rect">
-            <a:avLst/>
-          </a:prstGeom>
-          <a:noFill/>
-          <a:ln/>
-        </p:spPr>
-        <p:txBody>
-          <a:bodyPr wrap="square" lIns="0" tIns="0" rIns="0" bIns="0" rtlCol="0" anchor="ctr"/>
-          <a:lstStyle/>
-          <a:p>
-            <a:pPr algn="l" indent="0" marL="0">
-              <a:buNone/>
-            </a:pPr>
-            <a:r>
-              <a:rPr lang="en-US" sz="960" b="1" dirty="0">
-                <a:solidFill>
-                  <a:srgbClr val="1A1A1A"/>
-                </a:solidFill>
-                <a:latin typeface="Arial" pitchFamily="34" charset="0"/>
-                <a:ea typeface="Arial" pitchFamily="34" charset="-122"/>
-                <a:cs typeface="Arial" pitchFamily="34" charset="-120"/>
-              </a:rPr>
-              <a:t>Civilian allowances</a:t>
-            </a:r>
-            <a:endParaRPr lang="en-US" sz="960" dirty="0"/>
-          </a:p>
-        </p:txBody>
-      </p:sp>
-      <p:sp>
-        <p:nvSpPr>
-          <p:cNvPr id="67" name="Text 64"/>
-          <p:cNvSpPr/>
-          <p:nvPr/>
-        </p:nvSpPr>
-        <p:spPr>
-          <a:xfrm>
-            <a:off x="5623560" y="7827264"/>
-            <a:ext cx="1371600" cy="201168"/>
-          </a:xfrm>
-          <a:prstGeom prst="rect">
-            <a:avLst/>
-          </a:prstGeom>
-          <a:noFill/>
-          <a:ln/>
-        </p:spPr>
-        <p:txBody>
-          <a:bodyPr wrap="square" lIns="0" tIns="0" rIns="0" bIns="0" rtlCol="0" anchor="ctr"/>
-          <a:lstStyle/>
-          <a:p>
-            <a:pPr algn="r" indent="0" marL="0">
-              <a:buNone/>
-            </a:pPr>
-            <a:r>
-              <a:rPr lang="en-US" sz="980" b="1" dirty="0">
-                <a:solidFill>
-                  <a:srgbClr val="1A1A1A"/>
-                </a:solidFill>
-                <a:latin typeface="Arial" pitchFamily="34" charset="0"/>
-                <a:ea typeface="Arial" pitchFamily="34" charset="-122"/>
-                <a:cs typeface="Arial" pitchFamily="34" charset="-120"/>
-              </a:rPr>
-              <a:t>53% consumed</a:t>
-            </a:r>
-            <a:endParaRPr lang="en-US" sz="980" dirty="0"/>
-          </a:p>
-        </p:txBody>
-      </p:sp>
-      <p:sp>
-        <p:nvSpPr>
           <p:cNvPr id="68" name="Text 65"/>
           <p:cNvSpPr/>
           <p:nvPr/>
         </p:nvSpPr>
         <p:spPr>
           <a:xfrm>
-            <a:off x="731520" y="8046720"/>
-            <a:ext cx="6099048" cy="274320"/>
-          </a:xfrm>
-          <a:prstGeom prst="rect">
-            <a:avLst/>
-          </a:prstGeom>
-          <a:noFill/>
-          <a:ln/>
-        </p:spPr>
-        <p:txBody>
-          <a:bodyPr wrap="square" lIns="0" tIns="0" rIns="0" bIns="0" rtlCol="0" anchor="t"/>
-          <a:lstStyle/>
-          <a:p>
-            <a:pPr algn="l" indent="0" marL="0">
-              <a:lnSpc>
-                <a:spcPct val="126000"/>
-              </a:lnSpc>
-              <a:buNone/>
-            </a:pPr>
-            <a:r>
-              <a:rPr lang="en-US" sz="900" dirty="0">
-                <a:solidFill>
-                  <a:srgbClr val="1A1A1A"/>
-                </a:solidFill>
-                <a:latin typeface="Arial" pitchFamily="34" charset="0"/>
-                <a:ea typeface="Arial" pitchFamily="34" charset="-122"/>
-                <a:cs typeface="Arial" pitchFamily="34" charset="-120"/>
-              </a:rPr>
-              <a:t>Run rate to be confirmed before Month 2.</a:t>
-            </a:r>
-            <a:endParaRPr lang="en-US" sz="900" dirty="0"/>
-          </a:p>
-        </p:txBody>
-      </p:sp>
-      <p:sp>
-        <p:nvSpPr>
-          <p:cNvPr id="69" name="Text 66"/>
-          <p:cNvSpPr/>
-          <p:nvPr/>
-        </p:nvSpPr>
-        <p:spPr>
-          <a:xfrm>
-            <a:off x="566928" y="8449056"/>
-            <a:ext cx="6428232" cy="164592"/>
-          </a:xfrm>
-          <a:prstGeom prst="rect">
-            <a:avLst/>
-          </a:prstGeom>
-          <a:noFill/>
-          <a:ln/>
-        </p:spPr>
-        <p:txBody>
-          <a:bodyPr wrap="square" lIns="0" tIns="0" rIns="0" bIns="0" rtlCol="0" anchor="ctr"/>
-          <a:lstStyle/>
-          <a:p>
-            <a:pPr algn="l" indent="0" marL="0">
-              <a:buNone/>
-            </a:pPr>
-            <a:r>
-              <a:rPr lang="en-US" sz="760" b="1" spc="120" kern="0" dirty="0">
-                <a:solidFill>
-                  <a:srgbClr val="1A1A1A"/>
-                </a:solidFill>
-                <a:latin typeface="Arial" pitchFamily="34" charset="0"/>
-                <a:ea typeface="Arial" pitchFamily="34" charset="-122"/>
-                <a:cs typeface="Arial" pitchFamily="34" charset="-120"/>
-              </a:rPr>
-              <a:t>COMMAND ASSESSMENT</a:t>
-            </a:r>
-            <a:endParaRPr lang="en-US" sz="760" dirty="0"/>
-          </a:p>
-        </p:txBody>
-      </p:sp>
-      <p:sp>
-        <p:nvSpPr>
-          <p:cNvPr id="70" name="Shape 67"/>
-          <p:cNvSpPr/>
-          <p:nvPr/>
-        </p:nvSpPr>
-        <p:spPr>
-          <a:xfrm>
-            <a:off x="566928" y="8622792"/>
-            <a:ext cx="6428232" cy="7315"/>
-          </a:xfrm>
-          <a:prstGeom prst="rect">
-            <a:avLst/>
-          </a:prstGeom>
-          <a:solidFill>
-            <a:srgbClr val="C8C8C8"/>
-          </a:solidFill>
-          <a:ln/>
-        </p:spPr>
-      </p:sp>
-      <p:sp>
-        <p:nvSpPr>
-          <p:cNvPr id="71" name="Shape 68"/>
-          <p:cNvSpPr/>
-          <p:nvPr/>
-        </p:nvSpPr>
-        <p:spPr>
-          <a:xfrm>
-            <a:off x="566928" y="8778240"/>
-            <a:ext cx="6428232" cy="987552"/>
-          </a:xfrm>
-          <a:prstGeom prst="rect">
-            <a:avLst/>
-          </a:prstGeom>
-          <a:solidFill>
-            <a:srgbClr val="1A1A1A"/>
-          </a:solidFill>
-          <a:ln/>
-        </p:spPr>
-      </p:sp>
-      <p:sp>
-        <p:nvSpPr>
-          <p:cNvPr id="72" name="Shape 69"/>
-          <p:cNvSpPr/>
-          <p:nvPr/>
-        </p:nvSpPr>
-        <p:spPr>
-          <a:xfrm>
-            <a:off x="566928" y="8778240"/>
-            <a:ext cx="50292" cy="987552"/>
-          </a:xfrm>
-          <a:prstGeom prst="rect">
-            <a:avLst/>
-          </a:prstGeom>
-          <a:solidFill>
-            <a:srgbClr val="B3A650"/>
-          </a:solidFill>
-          <a:ln/>
-        </p:spPr>
-      </p:sp>
-      <p:sp>
-        <p:nvSpPr>
-          <p:cNvPr id="73" name="Text 70"/>
-          <p:cNvSpPr/>
-          <p:nvPr/>
-        </p:nvSpPr>
-        <p:spPr>
-          <a:xfrm>
-            <a:off x="859536" y="8942832"/>
-            <a:ext cx="5843016" cy="694944"/>
+            <a:off x="877824" y="8467344"/>
+            <a:ext cx="5806440" cy="822960"/>
           </a:xfrm>
           <a:prstGeom prst="rect">
             <a:avLst/>
@@ -3236,7 +3051,7 @@
               <a:buNone/>
             </a:pPr>
             <a:r>
-              <a:rPr lang="en-US" sz="980" dirty="0">
+              <a:rPr lang="en-US" sz="1040" dirty="0">
                 <a:solidFill>
                   <a:srgbClr val="FFFFFF"/>
                 </a:solidFill>
@@ -3246,13 +3061,13 @@
               </a:rPr>
               <a:t>FY26/27 remains on track. July's $17.5k adverse variance is assessed predominantly as front-loaded expenditure supporting the August course programme, rather than an emerging budget pressure. No corrective action is required at this stage beyond monitoring the combined July and August position.</a:t>
             </a:r>
-            <a:endParaRPr lang="en-US" sz="980" dirty="0"/>
-          </a:p>
-        </p:txBody>
-      </p:sp>
-      <p:sp>
-        <p:nvSpPr>
-          <p:cNvPr id="74" name="Shape 71"/>
+            <a:endParaRPr lang="en-US" sz="1040" dirty="0"/>
+          </a:p>
+        </p:txBody>
+      </p:sp>
+      <p:sp>
+        <p:nvSpPr>
+          <p:cNvPr id="69" name="Shape 66"/>
           <p:cNvSpPr/>
           <p:nvPr/>
         </p:nvSpPr>
@@ -3272,7 +3087,7 @@
       </p:sp>
       <p:sp>
         <p:nvSpPr>
-          <p:cNvPr id="75" name="Text 72"/>
+          <p:cNvPr id="70" name="Text 67"/>
           <p:cNvSpPr/>
           <p:nvPr/>
         </p:nvSpPr>
@@ -3311,7 +3126,7 @@
       </p:sp>
       <p:sp>
         <p:nvSpPr>
-          <p:cNvPr id="76" name="Text 73"/>
+          <p:cNvPr id="71" name="Text 68"/>
           <p:cNvSpPr/>
           <p:nvPr/>
         </p:nvSpPr>

</xml_diff>

<commit_message>
Remove the under watch section from the COMDT one pager
Leaves three registers: headline figures, position at 31 July, and the
month 1 command assessment. Type and intervals opened out so the page
reads as composed rather than sparse.

Co-Authored-By: Claude Fable 5 <noreply@anthropic.com>
Claude-Session: https://claude.ai/code/session_01YLo1WfwUDkbwfJEF3ZNVbB
</commit_message>
<xml_diff>
--- a/output/nzalc-month1-comdt-update.pptx
+++ b/output/nzalc-month1-comdt-update.pptx
@@ -1181,8 +1181,8 @@
         </p:nvSpPr>
         <p:spPr>
           <a:xfrm>
-            <a:off x="566928" y="1828800"/>
-            <a:ext cx="1511046" cy="1133856"/>
+            <a:off x="566928" y="1938528"/>
+            <a:ext cx="1511046" cy="1280160"/>
           </a:xfrm>
           <a:prstGeom prst="rect">
             <a:avLst/>
@@ -1201,7 +1201,7 @@
         </p:nvSpPr>
         <p:spPr>
           <a:xfrm>
-            <a:off x="566928" y="1828800"/>
+            <a:off x="566928" y="1938528"/>
             <a:ext cx="1511046" cy="27432"/>
           </a:xfrm>
           <a:prstGeom prst="rect">
@@ -1221,7 +1221,7 @@
         </p:nvSpPr>
         <p:spPr>
           <a:xfrm>
-            <a:off x="704088" y="1956816"/>
+            <a:off x="713232" y="2084832"/>
             <a:ext cx="1236726" cy="146304"/>
           </a:xfrm>
           <a:prstGeom prst="rect">
@@ -1260,8 +1260,8 @@
         </p:nvSpPr>
         <p:spPr>
           <a:xfrm>
-            <a:off x="704088" y="2176272"/>
-            <a:ext cx="1236726" cy="347472"/>
+            <a:off x="713232" y="2322576"/>
+            <a:ext cx="1218438" cy="384048"/>
           </a:xfrm>
           <a:prstGeom prst="rect">
             <a:avLst/>
@@ -1277,7 +1277,7 @@
               <a:buNone/>
             </a:pPr>
             <a:r>
-              <a:rPr lang="en-US" sz="2000" b="1" dirty="0">
+              <a:rPr lang="en-US" sz="2200" b="1" dirty="0">
                 <a:solidFill>
                   <a:srgbClr val="1A1A1A"/>
                 </a:solidFill>
@@ -1287,7 +1287,7 @@
               </a:rPr>
               <a:t>$811.6k</a:t>
             </a:r>
-            <a:endParaRPr lang="en-US" sz="2000" dirty="0"/>
+            <a:endParaRPr lang="en-US" sz="2200" dirty="0"/>
           </a:p>
         </p:txBody>
       </p:sp>
@@ -1299,8 +1299,8 @@
         </p:nvSpPr>
         <p:spPr>
           <a:xfrm>
-            <a:off x="704088" y="2578608"/>
-            <a:ext cx="1236726" cy="329184"/>
+            <a:off x="713232" y="2798064"/>
+            <a:ext cx="1218438" cy="329184"/>
           </a:xfrm>
           <a:prstGeom prst="rect">
             <a:avLst/>
@@ -1341,8 +1341,8 @@
         </p:nvSpPr>
         <p:spPr>
           <a:xfrm>
-            <a:off x="2205990" y="1828800"/>
-            <a:ext cx="1511046" cy="1133856"/>
+            <a:off x="2205990" y="1938528"/>
+            <a:ext cx="1511046" cy="1280160"/>
           </a:xfrm>
           <a:prstGeom prst="rect">
             <a:avLst/>
@@ -1361,7 +1361,7 @@
         </p:nvSpPr>
         <p:spPr>
           <a:xfrm>
-            <a:off x="2205990" y="1828800"/>
+            <a:off x="2205990" y="1938528"/>
             <a:ext cx="1511046" cy="27432"/>
           </a:xfrm>
           <a:prstGeom prst="rect">
@@ -1381,7 +1381,7 @@
         </p:nvSpPr>
         <p:spPr>
           <a:xfrm>
-            <a:off x="2343150" y="1956816"/>
+            <a:off x="2352294" y="2084832"/>
             <a:ext cx="1236726" cy="146304"/>
           </a:xfrm>
           <a:prstGeom prst="rect">
@@ -1420,8 +1420,8 @@
         </p:nvSpPr>
         <p:spPr>
           <a:xfrm>
-            <a:off x="2343150" y="2176272"/>
-            <a:ext cx="1236726" cy="347472"/>
+            <a:off x="2352294" y="2322576"/>
+            <a:ext cx="1218438" cy="384048"/>
           </a:xfrm>
           <a:prstGeom prst="rect">
             <a:avLst/>
@@ -1437,7 +1437,7 @@
               <a:buNone/>
             </a:pPr>
             <a:r>
-              <a:rPr lang="en-US" sz="2000" b="1" dirty="0">
+              <a:rPr lang="en-US" sz="2200" b="1" dirty="0">
                 <a:solidFill>
                   <a:srgbClr val="1A1A1A"/>
                 </a:solidFill>
@@ -1447,7 +1447,7 @@
               </a:rPr>
               <a:t>$40.5k</a:t>
             </a:r>
-            <a:endParaRPr lang="en-US" sz="2000" dirty="0"/>
+            <a:endParaRPr lang="en-US" sz="2200" dirty="0"/>
           </a:p>
         </p:txBody>
       </p:sp>
@@ -1459,8 +1459,8 @@
         </p:nvSpPr>
         <p:spPr>
           <a:xfrm>
-            <a:off x="2343150" y="2578608"/>
-            <a:ext cx="1236726" cy="329184"/>
+            <a:off x="2352294" y="2798064"/>
+            <a:ext cx="1218438" cy="329184"/>
           </a:xfrm>
           <a:prstGeom prst="rect">
             <a:avLst/>
@@ -1501,8 +1501,8 @@
         </p:nvSpPr>
         <p:spPr>
           <a:xfrm>
-            <a:off x="3845052" y="1828800"/>
-            <a:ext cx="1511046" cy="1133856"/>
+            <a:off x="3845052" y="1938528"/>
+            <a:ext cx="1511046" cy="1280160"/>
           </a:xfrm>
           <a:prstGeom prst="rect">
             <a:avLst/>
@@ -1521,7 +1521,7 @@
         </p:nvSpPr>
         <p:spPr>
           <a:xfrm>
-            <a:off x="3845052" y="1828800"/>
+            <a:off x="3845052" y="1938528"/>
             <a:ext cx="1511046" cy="27432"/>
           </a:xfrm>
           <a:prstGeom prst="rect">
@@ -1541,7 +1541,7 @@
         </p:nvSpPr>
         <p:spPr>
           <a:xfrm>
-            <a:off x="3982212" y="1956816"/>
+            <a:off x="3991356" y="2084832"/>
             <a:ext cx="1236726" cy="146304"/>
           </a:xfrm>
           <a:prstGeom prst="rect">
@@ -1580,8 +1580,8 @@
         </p:nvSpPr>
         <p:spPr>
           <a:xfrm>
-            <a:off x="3982212" y="2176272"/>
-            <a:ext cx="1236726" cy="347472"/>
+            <a:off x="3991356" y="2322576"/>
+            <a:ext cx="1218438" cy="384048"/>
           </a:xfrm>
           <a:prstGeom prst="rect">
             <a:avLst/>
@@ -1597,7 +1597,7 @@
               <a:buNone/>
             </a:pPr>
             <a:r>
-              <a:rPr lang="en-US" sz="2000" b="1" dirty="0">
+              <a:rPr lang="en-US" sz="2200" b="1" dirty="0">
                 <a:solidFill>
                   <a:srgbClr val="1A1A1A"/>
                 </a:solidFill>
@@ -1607,7 +1607,7 @@
               </a:rPr>
               <a:t>5.0%</a:t>
             </a:r>
-            <a:endParaRPr lang="en-US" sz="2000" dirty="0"/>
+            <a:endParaRPr lang="en-US" sz="2200" dirty="0"/>
           </a:p>
         </p:txBody>
       </p:sp>
@@ -1619,8 +1619,8 @@
         </p:nvSpPr>
         <p:spPr>
           <a:xfrm>
-            <a:off x="3982212" y="2578608"/>
-            <a:ext cx="1236726" cy="329184"/>
+            <a:off x="3991356" y="2798064"/>
+            <a:ext cx="1218438" cy="329184"/>
           </a:xfrm>
           <a:prstGeom prst="rect">
             <a:avLst/>
@@ -1661,8 +1661,8 @@
         </p:nvSpPr>
         <p:spPr>
           <a:xfrm>
-            <a:off x="5484114" y="1828800"/>
-            <a:ext cx="1511046" cy="1133856"/>
+            <a:off x="5484114" y="1938528"/>
+            <a:ext cx="1511046" cy="1280160"/>
           </a:xfrm>
           <a:prstGeom prst="rect">
             <a:avLst/>
@@ -1681,7 +1681,7 @@
         </p:nvSpPr>
         <p:spPr>
           <a:xfrm>
-            <a:off x="5484114" y="1828800"/>
+            <a:off x="5484114" y="1938528"/>
             <a:ext cx="1511046" cy="27432"/>
           </a:xfrm>
           <a:prstGeom prst="rect">
@@ -1701,7 +1701,7 @@
         </p:nvSpPr>
         <p:spPr>
           <a:xfrm>
-            <a:off x="5621274" y="1956816"/>
+            <a:off x="5630418" y="2084832"/>
             <a:ext cx="1236726" cy="146304"/>
           </a:xfrm>
           <a:prstGeom prst="rect">
@@ -1740,8 +1740,8 @@
         </p:nvSpPr>
         <p:spPr>
           <a:xfrm>
-            <a:off x="5621274" y="2176272"/>
-            <a:ext cx="1236726" cy="347472"/>
+            <a:off x="5630418" y="2322576"/>
+            <a:ext cx="1218438" cy="384048"/>
           </a:xfrm>
           <a:prstGeom prst="rect">
             <a:avLst/>
@@ -1757,7 +1757,7 @@
               <a:buNone/>
             </a:pPr>
             <a:r>
-              <a:rPr lang="en-US" sz="2000" b="1" dirty="0">
+              <a:rPr lang="en-US" sz="2200" b="1" dirty="0">
                 <a:solidFill>
                   <a:srgbClr val="1A1A1A"/>
                 </a:solidFill>
@@ -1767,7 +1767,7 @@
               </a:rPr>
               <a:t>$17.5k</a:t>
             </a:r>
-            <a:endParaRPr lang="en-US" sz="2000" dirty="0"/>
+            <a:endParaRPr lang="en-US" sz="2200" dirty="0"/>
           </a:p>
         </p:txBody>
       </p:sp>
@@ -1779,8 +1779,8 @@
         </p:nvSpPr>
         <p:spPr>
           <a:xfrm>
-            <a:off x="5621274" y="2578608"/>
-            <a:ext cx="1236726" cy="329184"/>
+            <a:off x="5630418" y="2798064"/>
+            <a:ext cx="1218438" cy="329184"/>
           </a:xfrm>
           <a:prstGeom prst="rect">
             <a:avLst/>
@@ -1821,7 +1821,7 @@
         </p:nvSpPr>
         <p:spPr>
           <a:xfrm>
-            <a:off x="566928" y="3438144"/>
+            <a:off x="566928" y="3931920"/>
             <a:ext cx="6428232" cy="164592"/>
           </a:xfrm>
           <a:prstGeom prst="rect">
@@ -1860,7 +1860,7 @@
         </p:nvSpPr>
         <p:spPr>
           <a:xfrm>
-            <a:off x="566928" y="3611880"/>
+            <a:off x="566928" y="4105656"/>
             <a:ext cx="6428232" cy="7315"/>
           </a:xfrm>
           <a:prstGeom prst="rect">
@@ -1880,8 +1880,8 @@
         </p:nvSpPr>
         <p:spPr>
           <a:xfrm>
-            <a:off x="658368" y="3767328"/>
-            <a:ext cx="2743200" cy="402336"/>
+            <a:off x="658368" y="4261104"/>
+            <a:ext cx="2743200" cy="512064"/>
           </a:xfrm>
           <a:prstGeom prst="rect">
             <a:avLst/>
@@ -1896,137 +1896,764 @@
             <a:pPr algn="l" indent="0" marL="0">
               <a:buNone/>
             </a:pPr>
+            <a:endParaRPr lang="en-US" sz="780" dirty="0"/>
+          </a:p>
+        </p:txBody>
+      </p:sp>
+      <p:sp>
+        <p:nvSpPr>
+          <p:cNvPr id="34" name="Text 31"/>
+          <p:cNvSpPr/>
+          <p:nvPr/>
+        </p:nvSpPr>
+        <p:spPr>
+          <a:xfrm>
+            <a:off x="3310128" y="4261104"/>
+            <a:ext cx="1143000" cy="512064"/>
+          </a:xfrm>
+          <a:prstGeom prst="rect">
+            <a:avLst/>
+          </a:prstGeom>
+          <a:noFill/>
+          <a:ln/>
+        </p:spPr>
+        <p:txBody>
+          <a:bodyPr wrap="square" lIns="0" tIns="0" rIns="0" bIns="0" rtlCol="0" anchor="ctr"/>
+          <a:lstStyle/>
+          <a:p>
+            <a:pPr algn="r" indent="0" marL="0">
+              <a:buNone/>
+            </a:pPr>
+            <a:r>
+              <a:rPr lang="en-US" sz="780" b="1" spc="80" kern="0" dirty="0">
+                <a:solidFill>
+                  <a:srgbClr val="6E6E6E"/>
+                </a:solidFill>
+                <a:latin typeface="Arial" pitchFamily="34" charset="0"/>
+                <a:ea typeface="Arial" pitchFamily="34" charset="-122"/>
+                <a:cs typeface="Arial" pitchFamily="34" charset="-120"/>
+              </a:rPr>
+              <a:t>July Budget</a:t>
+            </a:r>
+            <a:endParaRPr lang="en-US" sz="780" dirty="0"/>
+          </a:p>
+        </p:txBody>
+      </p:sp>
+      <p:sp>
+        <p:nvSpPr>
+          <p:cNvPr id="35" name="Text 32"/>
+          <p:cNvSpPr/>
+          <p:nvPr/>
+        </p:nvSpPr>
+        <p:spPr>
+          <a:xfrm>
+            <a:off x="4544568" y="4261104"/>
+            <a:ext cx="1143000" cy="512064"/>
+          </a:xfrm>
+          <a:prstGeom prst="rect">
+            <a:avLst/>
+          </a:prstGeom>
+          <a:noFill/>
+          <a:ln/>
+        </p:spPr>
+        <p:txBody>
+          <a:bodyPr wrap="square" lIns="0" tIns="0" rIns="0" bIns="0" rtlCol="0" anchor="ctr"/>
+          <a:lstStyle/>
+          <a:p>
+            <a:pPr algn="r" indent="0" marL="0">
+              <a:buNone/>
+            </a:pPr>
+            <a:r>
+              <a:rPr lang="en-US" sz="780" b="1" spc="80" kern="0" dirty="0">
+                <a:solidFill>
+                  <a:srgbClr val="6E6E6E"/>
+                </a:solidFill>
+                <a:latin typeface="Arial" pitchFamily="34" charset="0"/>
+                <a:ea typeface="Arial" pitchFamily="34" charset="-122"/>
+                <a:cs typeface="Arial" pitchFamily="34" charset="-120"/>
+              </a:rPr>
+              <a:t>July Actual</a:t>
+            </a:r>
+            <a:endParaRPr lang="en-US" sz="780" dirty="0"/>
+          </a:p>
+        </p:txBody>
+      </p:sp>
+      <p:sp>
+        <p:nvSpPr>
+          <p:cNvPr id="36" name="Text 33"/>
+          <p:cNvSpPr/>
+          <p:nvPr/>
+        </p:nvSpPr>
+        <p:spPr>
+          <a:xfrm>
+            <a:off x="5779008" y="4261104"/>
+            <a:ext cx="1124712" cy="512064"/>
+          </a:xfrm>
+          <a:prstGeom prst="rect">
+            <a:avLst/>
+          </a:prstGeom>
+          <a:noFill/>
+          <a:ln/>
+        </p:spPr>
+        <p:txBody>
+          <a:bodyPr wrap="square" lIns="0" tIns="0" rIns="0" bIns="0" rtlCol="0" anchor="ctr"/>
+          <a:lstStyle/>
+          <a:p>
+            <a:pPr algn="r" indent="0" marL="0">
+              <a:buNone/>
+            </a:pPr>
+            <a:r>
+              <a:rPr lang="en-US" sz="780" b="1" spc="80" kern="0" dirty="0">
+                <a:solidFill>
+                  <a:srgbClr val="6E6E6E"/>
+                </a:solidFill>
+                <a:latin typeface="Arial" pitchFamily="34" charset="0"/>
+                <a:ea typeface="Arial" pitchFamily="34" charset="-122"/>
+                <a:cs typeface="Arial" pitchFamily="34" charset="-120"/>
+              </a:rPr>
+              <a:t>Variance</a:t>
+            </a:r>
+            <a:endParaRPr lang="en-US" sz="780" dirty="0"/>
+          </a:p>
+        </p:txBody>
+      </p:sp>
+      <p:sp>
+        <p:nvSpPr>
+          <p:cNvPr id="37" name="Shape 34"/>
+          <p:cNvSpPr/>
+          <p:nvPr/>
+        </p:nvSpPr>
+        <p:spPr>
+          <a:xfrm>
+            <a:off x="566928" y="4773168"/>
+            <a:ext cx="6428232" cy="10973"/>
+          </a:xfrm>
+          <a:prstGeom prst="rect">
+            <a:avLst/>
+          </a:prstGeom>
+          <a:solidFill>
+            <a:srgbClr val="1A1A1A"/>
+          </a:solidFill>
+          <a:ln/>
+        </p:spPr>
+      </p:sp>
+      <p:sp>
+        <p:nvSpPr>
+          <p:cNvPr id="38" name="Text 35"/>
+          <p:cNvSpPr/>
+          <p:nvPr/>
+        </p:nvSpPr>
+        <p:spPr>
+          <a:xfrm>
+            <a:off x="658368" y="4809744"/>
+            <a:ext cx="2743200" cy="512064"/>
+          </a:xfrm>
+          <a:prstGeom prst="rect">
+            <a:avLst/>
+          </a:prstGeom>
+          <a:noFill/>
+          <a:ln/>
+        </p:spPr>
+        <p:txBody>
+          <a:bodyPr wrap="square" lIns="0" tIns="0" rIns="0" bIns="0" rtlCol="0" anchor="ctr"/>
+          <a:lstStyle/>
+          <a:p>
+            <a:pPr algn="l" indent="0" marL="0">
+              <a:buNone/>
+            </a:pPr>
+            <a:r>
+              <a:rPr lang="en-US" sz="1060" dirty="0">
+                <a:solidFill>
+                  <a:srgbClr val="1A1A1A"/>
+                </a:solidFill>
+                <a:latin typeface="Arial" pitchFamily="34" charset="0"/>
+                <a:ea typeface="Arial" pitchFamily="34" charset="-122"/>
+                <a:cs typeface="Arial" pitchFamily="34" charset="-120"/>
+              </a:rPr>
+              <a:t>Personnel</a:t>
+            </a:r>
+            <a:endParaRPr lang="en-US" sz="1060" dirty="0"/>
+          </a:p>
+        </p:txBody>
+      </p:sp>
+      <p:sp>
+        <p:nvSpPr>
+          <p:cNvPr id="39" name="Text 36"/>
+          <p:cNvSpPr/>
+          <p:nvPr/>
+        </p:nvSpPr>
+        <p:spPr>
+          <a:xfrm>
+            <a:off x="3310128" y="4809744"/>
+            <a:ext cx="1143000" cy="512064"/>
+          </a:xfrm>
+          <a:prstGeom prst="rect">
+            <a:avLst/>
+          </a:prstGeom>
+          <a:noFill/>
+          <a:ln/>
+        </p:spPr>
+        <p:txBody>
+          <a:bodyPr wrap="square" lIns="0" tIns="0" rIns="0" bIns="0" rtlCol="0" anchor="ctr"/>
+          <a:lstStyle/>
+          <a:p>
+            <a:pPr algn="r" indent="0" marL="0">
+              <a:buNone/>
+            </a:pPr>
+            <a:r>
+              <a:rPr lang="en-US" sz="1060" dirty="0">
+                <a:solidFill>
+                  <a:srgbClr val="1A1A1A"/>
+                </a:solidFill>
+                <a:latin typeface="Arial" pitchFamily="34" charset="0"/>
+                <a:ea typeface="Arial" pitchFamily="34" charset="-122"/>
+                <a:cs typeface="Arial" pitchFamily="34" charset="-120"/>
+              </a:rPr>
+              <a:t>$300</a:t>
+            </a:r>
+            <a:endParaRPr lang="en-US" sz="1060" dirty="0"/>
+          </a:p>
+        </p:txBody>
+      </p:sp>
+      <p:sp>
+        <p:nvSpPr>
+          <p:cNvPr id="40" name="Text 37"/>
+          <p:cNvSpPr/>
+          <p:nvPr/>
+        </p:nvSpPr>
+        <p:spPr>
+          <a:xfrm>
+            <a:off x="4544568" y="4809744"/>
+            <a:ext cx="1143000" cy="512064"/>
+          </a:xfrm>
+          <a:prstGeom prst="rect">
+            <a:avLst/>
+          </a:prstGeom>
+          <a:noFill/>
+          <a:ln/>
+        </p:spPr>
+        <p:txBody>
+          <a:bodyPr wrap="square" lIns="0" tIns="0" rIns="0" bIns="0" rtlCol="0" anchor="ctr"/>
+          <a:lstStyle/>
+          <a:p>
+            <a:pPr algn="r" indent="0" marL="0">
+              <a:buNone/>
+            </a:pPr>
+            <a:r>
+              <a:rPr lang="en-US" sz="1060" dirty="0">
+                <a:solidFill>
+                  <a:srgbClr val="1A1A1A"/>
+                </a:solidFill>
+                <a:latin typeface="Arial" pitchFamily="34" charset="0"/>
+                <a:ea typeface="Arial" pitchFamily="34" charset="-122"/>
+                <a:cs typeface="Arial" pitchFamily="34" charset="-120"/>
+              </a:rPr>
+              <a:t>$6,031</a:t>
+            </a:r>
+            <a:endParaRPr lang="en-US" sz="1060" dirty="0"/>
+          </a:p>
+        </p:txBody>
+      </p:sp>
+      <p:sp>
+        <p:nvSpPr>
+          <p:cNvPr id="41" name="Text 38"/>
+          <p:cNvSpPr/>
+          <p:nvPr/>
+        </p:nvSpPr>
+        <p:spPr>
+          <a:xfrm>
+            <a:off x="5779008" y="4809744"/>
+            <a:ext cx="1124712" cy="512064"/>
+          </a:xfrm>
+          <a:prstGeom prst="rect">
+            <a:avLst/>
+          </a:prstGeom>
+          <a:noFill/>
+          <a:ln/>
+        </p:spPr>
+        <p:txBody>
+          <a:bodyPr wrap="square" lIns="0" tIns="0" rIns="0" bIns="0" rtlCol="0" anchor="ctr"/>
+          <a:lstStyle/>
+          <a:p>
+            <a:pPr algn="r" indent="0" marL="0">
+              <a:buNone/>
+            </a:pPr>
+            <a:r>
+              <a:rPr lang="en-US" sz="1060" dirty="0">
+                <a:solidFill>
+                  <a:srgbClr val="D31145"/>
+                </a:solidFill>
+                <a:latin typeface="Arial" pitchFamily="34" charset="0"/>
+                <a:ea typeface="Arial" pitchFamily="34" charset="-122"/>
+                <a:cs typeface="Arial" pitchFamily="34" charset="-120"/>
+              </a:rPr>
+              <a:t>($5,731)</a:t>
+            </a:r>
+            <a:endParaRPr lang="en-US" sz="1060" dirty="0"/>
+          </a:p>
+        </p:txBody>
+      </p:sp>
+      <p:sp>
+        <p:nvSpPr>
+          <p:cNvPr id="42" name="Shape 39"/>
+          <p:cNvSpPr/>
+          <p:nvPr/>
+        </p:nvSpPr>
+        <p:spPr>
+          <a:xfrm>
+            <a:off x="566928" y="5321808"/>
+            <a:ext cx="6428232" cy="5486"/>
+          </a:xfrm>
+          <a:prstGeom prst="rect">
+            <a:avLst/>
+          </a:prstGeom>
+          <a:solidFill>
+            <a:srgbClr val="C8C8C8"/>
+          </a:solidFill>
+          <a:ln/>
+        </p:spPr>
+      </p:sp>
+      <p:sp>
+        <p:nvSpPr>
+          <p:cNvPr id="43" name="Text 40"/>
+          <p:cNvSpPr/>
+          <p:nvPr/>
+        </p:nvSpPr>
+        <p:spPr>
+          <a:xfrm>
+            <a:off x="658368" y="5358384"/>
+            <a:ext cx="2743200" cy="512064"/>
+          </a:xfrm>
+          <a:prstGeom prst="rect">
+            <a:avLst/>
+          </a:prstGeom>
+          <a:noFill/>
+          <a:ln/>
+        </p:spPr>
+        <p:txBody>
+          <a:bodyPr wrap="square" lIns="0" tIns="0" rIns="0" bIns="0" rtlCol="0" anchor="ctr"/>
+          <a:lstStyle/>
+          <a:p>
+            <a:pPr algn="l" indent="0" marL="0">
+              <a:buNone/>
+            </a:pPr>
+            <a:r>
+              <a:rPr lang="en-US" sz="1060" dirty="0">
+                <a:solidFill>
+                  <a:srgbClr val="1A1A1A"/>
+                </a:solidFill>
+                <a:latin typeface="Arial" pitchFamily="34" charset="0"/>
+                <a:ea typeface="Arial" pitchFamily="34" charset="-122"/>
+                <a:cs typeface="Arial" pitchFamily="34" charset="-120"/>
+              </a:rPr>
+              <a:t>Operating</a:t>
+            </a:r>
+            <a:endParaRPr lang="en-US" sz="1060" dirty="0"/>
+          </a:p>
+        </p:txBody>
+      </p:sp>
+      <p:sp>
+        <p:nvSpPr>
+          <p:cNvPr id="44" name="Text 41"/>
+          <p:cNvSpPr/>
+          <p:nvPr/>
+        </p:nvSpPr>
+        <p:spPr>
+          <a:xfrm>
+            <a:off x="3310128" y="5358384"/>
+            <a:ext cx="1143000" cy="512064"/>
+          </a:xfrm>
+          <a:prstGeom prst="rect">
+            <a:avLst/>
+          </a:prstGeom>
+          <a:noFill/>
+          <a:ln/>
+        </p:spPr>
+        <p:txBody>
+          <a:bodyPr wrap="square" lIns="0" tIns="0" rIns="0" bIns="0" rtlCol="0" anchor="ctr"/>
+          <a:lstStyle/>
+          <a:p>
+            <a:pPr algn="r" indent="0" marL="0">
+              <a:buNone/>
+            </a:pPr>
+            <a:r>
+              <a:rPr lang="en-US" sz="1060" dirty="0">
+                <a:solidFill>
+                  <a:srgbClr val="1A1A1A"/>
+                </a:solidFill>
+                <a:latin typeface="Arial" pitchFamily="34" charset="0"/>
+                <a:ea typeface="Arial" pitchFamily="34" charset="-122"/>
+                <a:cs typeface="Arial" pitchFamily="34" charset="-120"/>
+              </a:rPr>
+              <a:t>$22,715</a:t>
+            </a:r>
+            <a:endParaRPr lang="en-US" sz="1060" dirty="0"/>
+          </a:p>
+        </p:txBody>
+      </p:sp>
+      <p:sp>
+        <p:nvSpPr>
+          <p:cNvPr id="45" name="Text 42"/>
+          <p:cNvSpPr/>
+          <p:nvPr/>
+        </p:nvSpPr>
+        <p:spPr>
+          <a:xfrm>
+            <a:off x="4544568" y="5358384"/>
+            <a:ext cx="1143000" cy="512064"/>
+          </a:xfrm>
+          <a:prstGeom prst="rect">
+            <a:avLst/>
+          </a:prstGeom>
+          <a:noFill/>
+          <a:ln/>
+        </p:spPr>
+        <p:txBody>
+          <a:bodyPr wrap="square" lIns="0" tIns="0" rIns="0" bIns="0" rtlCol="0" anchor="ctr"/>
+          <a:lstStyle/>
+          <a:p>
+            <a:pPr algn="r" indent="0" marL="0">
+              <a:buNone/>
+            </a:pPr>
+            <a:r>
+              <a:rPr lang="en-US" sz="1060" dirty="0">
+                <a:solidFill>
+                  <a:srgbClr val="1A1A1A"/>
+                </a:solidFill>
+                <a:latin typeface="Arial" pitchFamily="34" charset="0"/>
+                <a:ea typeface="Arial" pitchFamily="34" charset="-122"/>
+                <a:cs typeface="Arial" pitchFamily="34" charset="-120"/>
+              </a:rPr>
+              <a:t>$34,504</a:t>
+            </a:r>
+            <a:endParaRPr lang="en-US" sz="1060" dirty="0"/>
+          </a:p>
+        </p:txBody>
+      </p:sp>
+      <p:sp>
+        <p:nvSpPr>
+          <p:cNvPr id="46" name="Text 43"/>
+          <p:cNvSpPr/>
+          <p:nvPr/>
+        </p:nvSpPr>
+        <p:spPr>
+          <a:xfrm>
+            <a:off x="5779008" y="5358384"/>
+            <a:ext cx="1124712" cy="512064"/>
+          </a:xfrm>
+          <a:prstGeom prst="rect">
+            <a:avLst/>
+          </a:prstGeom>
+          <a:noFill/>
+          <a:ln/>
+        </p:spPr>
+        <p:txBody>
+          <a:bodyPr wrap="square" lIns="0" tIns="0" rIns="0" bIns="0" rtlCol="0" anchor="ctr"/>
+          <a:lstStyle/>
+          <a:p>
+            <a:pPr algn="r" indent="0" marL="0">
+              <a:buNone/>
+            </a:pPr>
+            <a:r>
+              <a:rPr lang="en-US" sz="1060" dirty="0">
+                <a:solidFill>
+                  <a:srgbClr val="D31145"/>
+                </a:solidFill>
+                <a:latin typeface="Arial" pitchFamily="34" charset="0"/>
+                <a:ea typeface="Arial" pitchFamily="34" charset="-122"/>
+                <a:cs typeface="Arial" pitchFamily="34" charset="-120"/>
+              </a:rPr>
+              <a:t>($11,789)</a:t>
+            </a:r>
+            <a:endParaRPr lang="en-US" sz="1060" dirty="0"/>
+          </a:p>
+        </p:txBody>
+      </p:sp>
+      <p:sp>
+        <p:nvSpPr>
+          <p:cNvPr id="47" name="Shape 44"/>
+          <p:cNvSpPr/>
+          <p:nvPr/>
+        </p:nvSpPr>
+        <p:spPr>
+          <a:xfrm>
+            <a:off x="566928" y="5870448"/>
+            <a:ext cx="6428232" cy="5486"/>
+          </a:xfrm>
+          <a:prstGeom prst="rect">
+            <a:avLst/>
+          </a:prstGeom>
+          <a:solidFill>
+            <a:srgbClr val="C8C8C8"/>
+          </a:solidFill>
+          <a:ln/>
+        </p:spPr>
+      </p:sp>
+      <p:sp>
+        <p:nvSpPr>
+          <p:cNvPr id="48" name="Shape 45"/>
+          <p:cNvSpPr/>
+          <p:nvPr/>
+        </p:nvSpPr>
+        <p:spPr>
+          <a:xfrm>
+            <a:off x="566928" y="5907024"/>
+            <a:ext cx="6428232" cy="512064"/>
+          </a:xfrm>
+          <a:prstGeom prst="rect">
+            <a:avLst/>
+          </a:prstGeom>
+          <a:solidFill>
+            <a:srgbClr val="F5F5F3"/>
+          </a:solidFill>
+          <a:ln/>
+        </p:spPr>
+      </p:sp>
+      <p:sp>
+        <p:nvSpPr>
+          <p:cNvPr id="49" name="Text 46"/>
+          <p:cNvSpPr/>
+          <p:nvPr/>
+        </p:nvSpPr>
+        <p:spPr>
+          <a:xfrm>
+            <a:off x="658368" y="5907024"/>
+            <a:ext cx="2743200" cy="512064"/>
+          </a:xfrm>
+          <a:prstGeom prst="rect">
+            <a:avLst/>
+          </a:prstGeom>
+          <a:noFill/>
+          <a:ln/>
+        </p:spPr>
+        <p:txBody>
+          <a:bodyPr wrap="square" lIns="0" tIns="0" rIns="0" bIns="0" rtlCol="0" anchor="ctr"/>
+          <a:lstStyle/>
+          <a:p>
+            <a:pPr algn="l" indent="0" marL="0">
+              <a:buNone/>
+            </a:pPr>
+            <a:r>
+              <a:rPr lang="en-US" sz="1060" b="1" dirty="0">
+                <a:solidFill>
+                  <a:srgbClr val="1A1A1A"/>
+                </a:solidFill>
+                <a:latin typeface="Arial" pitchFamily="34" charset="0"/>
+                <a:ea typeface="Arial" pitchFamily="34" charset="-122"/>
+                <a:cs typeface="Arial" pitchFamily="34" charset="-120"/>
+              </a:rPr>
+              <a:t>TOTAL</a:t>
+            </a:r>
+            <a:endParaRPr lang="en-US" sz="1060" dirty="0"/>
+          </a:p>
+        </p:txBody>
+      </p:sp>
+      <p:sp>
+        <p:nvSpPr>
+          <p:cNvPr id="50" name="Text 47"/>
+          <p:cNvSpPr/>
+          <p:nvPr/>
+        </p:nvSpPr>
+        <p:spPr>
+          <a:xfrm>
+            <a:off x="3310128" y="5907024"/>
+            <a:ext cx="1143000" cy="512064"/>
+          </a:xfrm>
+          <a:prstGeom prst="rect">
+            <a:avLst/>
+          </a:prstGeom>
+          <a:noFill/>
+          <a:ln/>
+        </p:spPr>
+        <p:txBody>
+          <a:bodyPr wrap="square" lIns="0" tIns="0" rIns="0" bIns="0" rtlCol="0" anchor="ctr"/>
+          <a:lstStyle/>
+          <a:p>
+            <a:pPr algn="r" indent="0" marL="0">
+              <a:buNone/>
+            </a:pPr>
+            <a:r>
+              <a:rPr lang="en-US" sz="1060" b="1" dirty="0">
+                <a:solidFill>
+                  <a:srgbClr val="1A1A1A"/>
+                </a:solidFill>
+                <a:latin typeface="Arial" pitchFamily="34" charset="0"/>
+                <a:ea typeface="Arial" pitchFamily="34" charset="-122"/>
+                <a:cs typeface="Arial" pitchFamily="34" charset="-120"/>
+              </a:rPr>
+              <a:t>$23,015</a:t>
+            </a:r>
+            <a:endParaRPr lang="en-US" sz="1060" dirty="0"/>
+          </a:p>
+        </p:txBody>
+      </p:sp>
+      <p:sp>
+        <p:nvSpPr>
+          <p:cNvPr id="51" name="Text 48"/>
+          <p:cNvSpPr/>
+          <p:nvPr/>
+        </p:nvSpPr>
+        <p:spPr>
+          <a:xfrm>
+            <a:off x="4544568" y="5907024"/>
+            <a:ext cx="1143000" cy="512064"/>
+          </a:xfrm>
+          <a:prstGeom prst="rect">
+            <a:avLst/>
+          </a:prstGeom>
+          <a:noFill/>
+          <a:ln/>
+        </p:spPr>
+        <p:txBody>
+          <a:bodyPr wrap="square" lIns="0" tIns="0" rIns="0" bIns="0" rtlCol="0" anchor="ctr"/>
+          <a:lstStyle/>
+          <a:p>
+            <a:pPr algn="r" indent="0" marL="0">
+              <a:buNone/>
+            </a:pPr>
+            <a:r>
+              <a:rPr lang="en-US" sz="1060" b="1" dirty="0">
+                <a:solidFill>
+                  <a:srgbClr val="1A1A1A"/>
+                </a:solidFill>
+                <a:latin typeface="Arial" pitchFamily="34" charset="0"/>
+                <a:ea typeface="Arial" pitchFamily="34" charset="-122"/>
+                <a:cs typeface="Arial" pitchFamily="34" charset="-120"/>
+              </a:rPr>
+              <a:t>$40,535</a:t>
+            </a:r>
+            <a:endParaRPr lang="en-US" sz="1060" dirty="0"/>
+          </a:p>
+        </p:txBody>
+      </p:sp>
+      <p:sp>
+        <p:nvSpPr>
+          <p:cNvPr id="52" name="Text 49"/>
+          <p:cNvSpPr/>
+          <p:nvPr/>
+        </p:nvSpPr>
+        <p:spPr>
+          <a:xfrm>
+            <a:off x="5779008" y="5907024"/>
+            <a:ext cx="1124712" cy="512064"/>
+          </a:xfrm>
+          <a:prstGeom prst="rect">
+            <a:avLst/>
+          </a:prstGeom>
+          <a:noFill/>
+          <a:ln/>
+        </p:spPr>
+        <p:txBody>
+          <a:bodyPr wrap="square" lIns="0" tIns="0" rIns="0" bIns="0" rtlCol="0" anchor="ctr"/>
+          <a:lstStyle/>
+          <a:p>
+            <a:pPr algn="r" indent="0" marL="0">
+              <a:buNone/>
+            </a:pPr>
+            <a:r>
+              <a:rPr lang="en-US" sz="1060" b="1" dirty="0">
+                <a:solidFill>
+                  <a:srgbClr val="D31145"/>
+                </a:solidFill>
+                <a:latin typeface="Arial" pitchFamily="34" charset="0"/>
+                <a:ea typeface="Arial" pitchFamily="34" charset="-122"/>
+                <a:cs typeface="Arial" pitchFamily="34" charset="-120"/>
+              </a:rPr>
+              <a:t>($17,520)</a:t>
+            </a:r>
+            <a:endParaRPr lang="en-US" sz="1060" dirty="0"/>
+          </a:p>
+        </p:txBody>
+      </p:sp>
+      <p:sp>
+        <p:nvSpPr>
+          <p:cNvPr id="53" name="Shape 50"/>
+          <p:cNvSpPr/>
+          <p:nvPr/>
+        </p:nvSpPr>
+        <p:spPr>
+          <a:xfrm>
+            <a:off x="566928" y="6419088"/>
+            <a:ext cx="6428232" cy="10973"/>
+          </a:xfrm>
+          <a:prstGeom prst="rect">
+            <a:avLst/>
+          </a:prstGeom>
+          <a:solidFill>
+            <a:srgbClr val="1A1A1A"/>
+          </a:solidFill>
+          <a:ln/>
+        </p:spPr>
+      </p:sp>
+      <p:sp>
+        <p:nvSpPr>
+          <p:cNvPr id="54" name="Text 51"/>
+          <p:cNvSpPr/>
+          <p:nvPr/>
+        </p:nvSpPr>
+        <p:spPr>
+          <a:xfrm>
+            <a:off x="566928" y="7260336"/>
+            <a:ext cx="6428232" cy="164592"/>
+          </a:xfrm>
+          <a:prstGeom prst="rect">
+            <a:avLst/>
+          </a:prstGeom>
+          <a:noFill/>
+          <a:ln/>
+        </p:spPr>
+        <p:txBody>
+          <a:bodyPr wrap="square" lIns="0" tIns="0" rIns="0" bIns="0" rtlCol="0" anchor="ctr"/>
+          <a:lstStyle/>
+          <a:p>
+            <a:pPr algn="l" indent="0" marL="0">
+              <a:buNone/>
+            </a:pPr>
+            <a:r>
+              <a:rPr lang="en-US" sz="760" b="1" spc="120" kern="0" dirty="0">
+                <a:solidFill>
+                  <a:srgbClr val="1A1A1A"/>
+                </a:solidFill>
+                <a:latin typeface="Arial" pitchFamily="34" charset="0"/>
+                <a:ea typeface="Arial" pitchFamily="34" charset="-122"/>
+                <a:cs typeface="Arial" pitchFamily="34" charset="-120"/>
+              </a:rPr>
+              <a:t>MONTH 1 COMMAND ASSESSMENT</a:t>
+            </a:r>
             <a:endParaRPr lang="en-US" sz="760" dirty="0"/>
           </a:p>
         </p:txBody>
       </p:sp>
       <p:sp>
         <p:nvSpPr>
-          <p:cNvPr id="34" name="Text 31"/>
-          <p:cNvSpPr/>
-          <p:nvPr/>
-        </p:nvSpPr>
-        <p:spPr>
-          <a:xfrm>
-            <a:off x="3310128" y="3767328"/>
-            <a:ext cx="1143000" cy="402336"/>
-          </a:xfrm>
-          <a:prstGeom prst="rect">
-            <a:avLst/>
-          </a:prstGeom>
-          <a:noFill/>
-          <a:ln/>
-        </p:spPr>
-        <p:txBody>
-          <a:bodyPr wrap="square" lIns="0" tIns="0" rIns="0" bIns="0" rtlCol="0" anchor="ctr"/>
-          <a:lstStyle/>
-          <a:p>
-            <a:pPr algn="r" indent="0" marL="0">
-              <a:buNone/>
-            </a:pPr>
-            <a:r>
-              <a:rPr lang="en-US" sz="760" b="1" spc="80" kern="0" dirty="0">
-                <a:solidFill>
-                  <a:srgbClr val="6E6E6E"/>
-                </a:solidFill>
-                <a:latin typeface="Arial" pitchFamily="34" charset="0"/>
-                <a:ea typeface="Arial" pitchFamily="34" charset="-122"/>
-                <a:cs typeface="Arial" pitchFamily="34" charset="-120"/>
-              </a:rPr>
-              <a:t>July Budget</a:t>
-            </a:r>
-            <a:endParaRPr lang="en-US" sz="760" dirty="0"/>
-          </a:p>
-        </p:txBody>
-      </p:sp>
-      <p:sp>
-        <p:nvSpPr>
-          <p:cNvPr id="35" name="Text 32"/>
-          <p:cNvSpPr/>
-          <p:nvPr/>
-        </p:nvSpPr>
-        <p:spPr>
-          <a:xfrm>
-            <a:off x="4544568" y="3767328"/>
-            <a:ext cx="1143000" cy="402336"/>
-          </a:xfrm>
-          <a:prstGeom prst="rect">
-            <a:avLst/>
-          </a:prstGeom>
-          <a:noFill/>
-          <a:ln/>
-        </p:spPr>
-        <p:txBody>
-          <a:bodyPr wrap="square" lIns="0" tIns="0" rIns="0" bIns="0" rtlCol="0" anchor="ctr"/>
-          <a:lstStyle/>
-          <a:p>
-            <a:pPr algn="r" indent="0" marL="0">
-              <a:buNone/>
-            </a:pPr>
-            <a:r>
-              <a:rPr lang="en-US" sz="760" b="1" spc="80" kern="0" dirty="0">
-                <a:solidFill>
-                  <a:srgbClr val="6E6E6E"/>
-                </a:solidFill>
-                <a:latin typeface="Arial" pitchFamily="34" charset="0"/>
-                <a:ea typeface="Arial" pitchFamily="34" charset="-122"/>
-                <a:cs typeface="Arial" pitchFamily="34" charset="-120"/>
-              </a:rPr>
-              <a:t>July Actual</a:t>
-            </a:r>
-            <a:endParaRPr lang="en-US" sz="760" dirty="0"/>
-          </a:p>
-        </p:txBody>
-      </p:sp>
-      <p:sp>
-        <p:nvSpPr>
-          <p:cNvPr id="36" name="Text 33"/>
-          <p:cNvSpPr/>
-          <p:nvPr/>
-        </p:nvSpPr>
-        <p:spPr>
-          <a:xfrm>
-            <a:off x="5779008" y="3767328"/>
-            <a:ext cx="1124712" cy="402336"/>
-          </a:xfrm>
-          <a:prstGeom prst="rect">
-            <a:avLst/>
-          </a:prstGeom>
-          <a:noFill/>
-          <a:ln/>
-        </p:spPr>
-        <p:txBody>
-          <a:bodyPr wrap="square" lIns="0" tIns="0" rIns="0" bIns="0" rtlCol="0" anchor="ctr"/>
-          <a:lstStyle/>
-          <a:p>
-            <a:pPr algn="r" indent="0" marL="0">
-              <a:buNone/>
-            </a:pPr>
-            <a:r>
-              <a:rPr lang="en-US" sz="760" b="1" spc="80" kern="0" dirty="0">
-                <a:solidFill>
-                  <a:srgbClr val="6E6E6E"/>
-                </a:solidFill>
-                <a:latin typeface="Arial" pitchFamily="34" charset="0"/>
-                <a:ea typeface="Arial" pitchFamily="34" charset="-122"/>
-                <a:cs typeface="Arial" pitchFamily="34" charset="-120"/>
-              </a:rPr>
-              <a:t>Variance</a:t>
-            </a:r>
-            <a:endParaRPr lang="en-US" sz="760" dirty="0"/>
-          </a:p>
-        </p:txBody>
-      </p:sp>
-      <p:sp>
-        <p:nvSpPr>
-          <p:cNvPr id="37" name="Shape 34"/>
-          <p:cNvSpPr/>
-          <p:nvPr/>
-        </p:nvSpPr>
-        <p:spPr>
-          <a:xfrm>
-            <a:off x="566928" y="4169664"/>
-            <a:ext cx="6428232" cy="10973"/>
+          <p:cNvPr id="55" name="Shape 52"/>
+          <p:cNvSpPr/>
+          <p:nvPr/>
+        </p:nvSpPr>
+        <p:spPr>
+          <a:xfrm>
+            <a:off x="566928" y="7434072"/>
+            <a:ext cx="6428232" cy="7315"/>
+          </a:xfrm>
+          <a:prstGeom prst="rect">
+            <a:avLst/>
+          </a:prstGeom>
+          <a:solidFill>
+            <a:srgbClr val="C8C8C8"/>
+          </a:solidFill>
+          <a:ln/>
+        </p:spPr>
+      </p:sp>
+      <p:sp>
+        <p:nvSpPr>
+          <p:cNvPr id="56" name="Shape 53"/>
+          <p:cNvSpPr/>
+          <p:nvPr/>
+        </p:nvSpPr>
+        <p:spPr>
+          <a:xfrm>
+            <a:off x="566928" y="7589520"/>
+            <a:ext cx="6428232" cy="1572768"/>
           </a:xfrm>
           <a:prstGeom prst="rect">
             <a:avLst/>
@@ -2039,621 +2666,14 @@
       </p:sp>
       <p:sp>
         <p:nvSpPr>
-          <p:cNvPr id="38" name="Text 35"/>
-          <p:cNvSpPr/>
-          <p:nvPr/>
-        </p:nvSpPr>
-        <p:spPr>
-          <a:xfrm>
-            <a:off x="658368" y="4206240"/>
-            <a:ext cx="2743200" cy="402336"/>
-          </a:xfrm>
-          <a:prstGeom prst="rect">
-            <a:avLst/>
-          </a:prstGeom>
-          <a:noFill/>
-          <a:ln/>
-        </p:spPr>
-        <p:txBody>
-          <a:bodyPr wrap="square" lIns="0" tIns="0" rIns="0" bIns="0" rtlCol="0" anchor="ctr"/>
-          <a:lstStyle/>
-          <a:p>
-            <a:pPr algn="l" indent="0" marL="0">
-              <a:buNone/>
-            </a:pPr>
-            <a:r>
-              <a:rPr lang="en-US" sz="980" dirty="0">
-                <a:solidFill>
-                  <a:srgbClr val="1A1A1A"/>
-                </a:solidFill>
-                <a:latin typeface="Arial" pitchFamily="34" charset="0"/>
-                <a:ea typeface="Arial" pitchFamily="34" charset="-122"/>
-                <a:cs typeface="Arial" pitchFamily="34" charset="-120"/>
-              </a:rPr>
-              <a:t>Personnel</a:t>
-            </a:r>
-            <a:endParaRPr lang="en-US" sz="980" dirty="0"/>
-          </a:p>
-        </p:txBody>
-      </p:sp>
-      <p:sp>
-        <p:nvSpPr>
-          <p:cNvPr id="39" name="Text 36"/>
-          <p:cNvSpPr/>
-          <p:nvPr/>
-        </p:nvSpPr>
-        <p:spPr>
-          <a:xfrm>
-            <a:off x="3310128" y="4206240"/>
-            <a:ext cx="1143000" cy="402336"/>
-          </a:xfrm>
-          <a:prstGeom prst="rect">
-            <a:avLst/>
-          </a:prstGeom>
-          <a:noFill/>
-          <a:ln/>
-        </p:spPr>
-        <p:txBody>
-          <a:bodyPr wrap="square" lIns="0" tIns="0" rIns="0" bIns="0" rtlCol="0" anchor="ctr"/>
-          <a:lstStyle/>
-          <a:p>
-            <a:pPr algn="r" indent="0" marL="0">
-              <a:buNone/>
-            </a:pPr>
-            <a:r>
-              <a:rPr lang="en-US" sz="980" dirty="0">
-                <a:solidFill>
-                  <a:srgbClr val="1A1A1A"/>
-                </a:solidFill>
-                <a:latin typeface="Arial" pitchFamily="34" charset="0"/>
-                <a:ea typeface="Arial" pitchFamily="34" charset="-122"/>
-                <a:cs typeface="Arial" pitchFamily="34" charset="-120"/>
-              </a:rPr>
-              <a:t>$300</a:t>
-            </a:r>
-            <a:endParaRPr lang="en-US" sz="980" dirty="0"/>
-          </a:p>
-        </p:txBody>
-      </p:sp>
-      <p:sp>
-        <p:nvSpPr>
-          <p:cNvPr id="40" name="Text 37"/>
-          <p:cNvSpPr/>
-          <p:nvPr/>
-        </p:nvSpPr>
-        <p:spPr>
-          <a:xfrm>
-            <a:off x="4544568" y="4206240"/>
-            <a:ext cx="1143000" cy="402336"/>
-          </a:xfrm>
-          <a:prstGeom prst="rect">
-            <a:avLst/>
-          </a:prstGeom>
-          <a:noFill/>
-          <a:ln/>
-        </p:spPr>
-        <p:txBody>
-          <a:bodyPr wrap="square" lIns="0" tIns="0" rIns="0" bIns="0" rtlCol="0" anchor="ctr"/>
-          <a:lstStyle/>
-          <a:p>
-            <a:pPr algn="r" indent="0" marL="0">
-              <a:buNone/>
-            </a:pPr>
-            <a:r>
-              <a:rPr lang="en-US" sz="980" dirty="0">
-                <a:solidFill>
-                  <a:srgbClr val="1A1A1A"/>
-                </a:solidFill>
-                <a:latin typeface="Arial" pitchFamily="34" charset="0"/>
-                <a:ea typeface="Arial" pitchFamily="34" charset="-122"/>
-                <a:cs typeface="Arial" pitchFamily="34" charset="-120"/>
-              </a:rPr>
-              <a:t>$6,031</a:t>
-            </a:r>
-            <a:endParaRPr lang="en-US" sz="980" dirty="0"/>
-          </a:p>
-        </p:txBody>
-      </p:sp>
-      <p:sp>
-        <p:nvSpPr>
-          <p:cNvPr id="41" name="Text 38"/>
-          <p:cNvSpPr/>
-          <p:nvPr/>
-        </p:nvSpPr>
-        <p:spPr>
-          <a:xfrm>
-            <a:off x="5779008" y="4206240"/>
-            <a:ext cx="1124712" cy="402336"/>
-          </a:xfrm>
-          <a:prstGeom prst="rect">
-            <a:avLst/>
-          </a:prstGeom>
-          <a:noFill/>
-          <a:ln/>
-        </p:spPr>
-        <p:txBody>
-          <a:bodyPr wrap="square" lIns="0" tIns="0" rIns="0" bIns="0" rtlCol="0" anchor="ctr"/>
-          <a:lstStyle/>
-          <a:p>
-            <a:pPr algn="r" indent="0" marL="0">
-              <a:buNone/>
-            </a:pPr>
-            <a:r>
-              <a:rPr lang="en-US" sz="980" dirty="0">
-                <a:solidFill>
-                  <a:srgbClr val="D31145"/>
-                </a:solidFill>
-                <a:latin typeface="Arial" pitchFamily="34" charset="0"/>
-                <a:ea typeface="Arial" pitchFamily="34" charset="-122"/>
-                <a:cs typeface="Arial" pitchFamily="34" charset="-120"/>
-              </a:rPr>
-              <a:t>($5,731)</a:t>
-            </a:r>
-            <a:endParaRPr lang="en-US" sz="980" dirty="0"/>
-          </a:p>
-        </p:txBody>
-      </p:sp>
-      <p:sp>
-        <p:nvSpPr>
-          <p:cNvPr id="42" name="Shape 39"/>
-          <p:cNvSpPr/>
-          <p:nvPr/>
-        </p:nvSpPr>
-        <p:spPr>
-          <a:xfrm>
-            <a:off x="566928" y="4608576"/>
-            <a:ext cx="6428232" cy="5486"/>
-          </a:xfrm>
-          <a:prstGeom prst="rect">
-            <a:avLst/>
-          </a:prstGeom>
-          <a:solidFill>
-            <a:srgbClr val="C8C8C8"/>
-          </a:solidFill>
-          <a:ln/>
-        </p:spPr>
-      </p:sp>
-      <p:sp>
-        <p:nvSpPr>
-          <p:cNvPr id="43" name="Text 40"/>
-          <p:cNvSpPr/>
-          <p:nvPr/>
-        </p:nvSpPr>
-        <p:spPr>
-          <a:xfrm>
-            <a:off x="658368" y="4645152"/>
-            <a:ext cx="2743200" cy="402336"/>
-          </a:xfrm>
-          <a:prstGeom prst="rect">
-            <a:avLst/>
-          </a:prstGeom>
-          <a:noFill/>
-          <a:ln/>
-        </p:spPr>
-        <p:txBody>
-          <a:bodyPr wrap="square" lIns="0" tIns="0" rIns="0" bIns="0" rtlCol="0" anchor="ctr"/>
-          <a:lstStyle/>
-          <a:p>
-            <a:pPr algn="l" indent="0" marL="0">
-              <a:buNone/>
-            </a:pPr>
-            <a:r>
-              <a:rPr lang="en-US" sz="980" dirty="0">
-                <a:solidFill>
-                  <a:srgbClr val="1A1A1A"/>
-                </a:solidFill>
-                <a:latin typeface="Arial" pitchFamily="34" charset="0"/>
-                <a:ea typeface="Arial" pitchFamily="34" charset="-122"/>
-                <a:cs typeface="Arial" pitchFamily="34" charset="-120"/>
-              </a:rPr>
-              <a:t>Operating</a:t>
-            </a:r>
-            <a:endParaRPr lang="en-US" sz="980" dirty="0"/>
-          </a:p>
-        </p:txBody>
-      </p:sp>
-      <p:sp>
-        <p:nvSpPr>
-          <p:cNvPr id="44" name="Text 41"/>
-          <p:cNvSpPr/>
-          <p:nvPr/>
-        </p:nvSpPr>
-        <p:spPr>
-          <a:xfrm>
-            <a:off x="3310128" y="4645152"/>
-            <a:ext cx="1143000" cy="402336"/>
-          </a:xfrm>
-          <a:prstGeom prst="rect">
-            <a:avLst/>
-          </a:prstGeom>
-          <a:noFill/>
-          <a:ln/>
-        </p:spPr>
-        <p:txBody>
-          <a:bodyPr wrap="square" lIns="0" tIns="0" rIns="0" bIns="0" rtlCol="0" anchor="ctr"/>
-          <a:lstStyle/>
-          <a:p>
-            <a:pPr algn="r" indent="0" marL="0">
-              <a:buNone/>
-            </a:pPr>
-            <a:r>
-              <a:rPr lang="en-US" sz="980" dirty="0">
-                <a:solidFill>
-                  <a:srgbClr val="1A1A1A"/>
-                </a:solidFill>
-                <a:latin typeface="Arial" pitchFamily="34" charset="0"/>
-                <a:ea typeface="Arial" pitchFamily="34" charset="-122"/>
-                <a:cs typeface="Arial" pitchFamily="34" charset="-120"/>
-              </a:rPr>
-              <a:t>$22,715</a:t>
-            </a:r>
-            <a:endParaRPr lang="en-US" sz="980" dirty="0"/>
-          </a:p>
-        </p:txBody>
-      </p:sp>
-      <p:sp>
-        <p:nvSpPr>
-          <p:cNvPr id="45" name="Text 42"/>
-          <p:cNvSpPr/>
-          <p:nvPr/>
-        </p:nvSpPr>
-        <p:spPr>
-          <a:xfrm>
-            <a:off x="4544568" y="4645152"/>
-            <a:ext cx="1143000" cy="402336"/>
-          </a:xfrm>
-          <a:prstGeom prst="rect">
-            <a:avLst/>
-          </a:prstGeom>
-          <a:noFill/>
-          <a:ln/>
-        </p:spPr>
-        <p:txBody>
-          <a:bodyPr wrap="square" lIns="0" tIns="0" rIns="0" bIns="0" rtlCol="0" anchor="ctr"/>
-          <a:lstStyle/>
-          <a:p>
-            <a:pPr algn="r" indent="0" marL="0">
-              <a:buNone/>
-            </a:pPr>
-            <a:r>
-              <a:rPr lang="en-US" sz="980" dirty="0">
-                <a:solidFill>
-                  <a:srgbClr val="1A1A1A"/>
-                </a:solidFill>
-                <a:latin typeface="Arial" pitchFamily="34" charset="0"/>
-                <a:ea typeface="Arial" pitchFamily="34" charset="-122"/>
-                <a:cs typeface="Arial" pitchFamily="34" charset="-120"/>
-              </a:rPr>
-              <a:t>$34,504</a:t>
-            </a:r>
-            <a:endParaRPr lang="en-US" sz="980" dirty="0"/>
-          </a:p>
-        </p:txBody>
-      </p:sp>
-      <p:sp>
-        <p:nvSpPr>
-          <p:cNvPr id="46" name="Text 43"/>
-          <p:cNvSpPr/>
-          <p:nvPr/>
-        </p:nvSpPr>
-        <p:spPr>
-          <a:xfrm>
-            <a:off x="5779008" y="4645152"/>
-            <a:ext cx="1124712" cy="402336"/>
-          </a:xfrm>
-          <a:prstGeom prst="rect">
-            <a:avLst/>
-          </a:prstGeom>
-          <a:noFill/>
-          <a:ln/>
-        </p:spPr>
-        <p:txBody>
-          <a:bodyPr wrap="square" lIns="0" tIns="0" rIns="0" bIns="0" rtlCol="0" anchor="ctr"/>
-          <a:lstStyle/>
-          <a:p>
-            <a:pPr algn="r" indent="0" marL="0">
-              <a:buNone/>
-            </a:pPr>
-            <a:r>
-              <a:rPr lang="en-US" sz="980" dirty="0">
-                <a:solidFill>
-                  <a:srgbClr val="D31145"/>
-                </a:solidFill>
-                <a:latin typeface="Arial" pitchFamily="34" charset="0"/>
-                <a:ea typeface="Arial" pitchFamily="34" charset="-122"/>
-                <a:cs typeface="Arial" pitchFamily="34" charset="-120"/>
-              </a:rPr>
-              <a:t>($11,789)</a:t>
-            </a:r>
-            <a:endParaRPr lang="en-US" sz="980" dirty="0"/>
-          </a:p>
-        </p:txBody>
-      </p:sp>
-      <p:sp>
-        <p:nvSpPr>
-          <p:cNvPr id="47" name="Shape 44"/>
-          <p:cNvSpPr/>
-          <p:nvPr/>
-        </p:nvSpPr>
-        <p:spPr>
-          <a:xfrm>
-            <a:off x="566928" y="5047488"/>
-            <a:ext cx="6428232" cy="5486"/>
-          </a:xfrm>
-          <a:prstGeom prst="rect">
-            <a:avLst/>
-          </a:prstGeom>
-          <a:solidFill>
-            <a:srgbClr val="C8C8C8"/>
-          </a:solidFill>
-          <a:ln/>
-        </p:spPr>
-      </p:sp>
-      <p:sp>
-        <p:nvSpPr>
-          <p:cNvPr id="48" name="Shape 45"/>
-          <p:cNvSpPr/>
-          <p:nvPr/>
-        </p:nvSpPr>
-        <p:spPr>
-          <a:xfrm>
-            <a:off x="566928" y="5084064"/>
-            <a:ext cx="6428232" cy="402336"/>
-          </a:xfrm>
-          <a:prstGeom prst="rect">
-            <a:avLst/>
-          </a:prstGeom>
-          <a:solidFill>
-            <a:srgbClr val="F5F5F3"/>
-          </a:solidFill>
-          <a:ln/>
-        </p:spPr>
-      </p:sp>
-      <p:sp>
-        <p:nvSpPr>
-          <p:cNvPr id="49" name="Text 46"/>
-          <p:cNvSpPr/>
-          <p:nvPr/>
-        </p:nvSpPr>
-        <p:spPr>
-          <a:xfrm>
-            <a:off x="658368" y="5084064"/>
-            <a:ext cx="2743200" cy="402336"/>
-          </a:xfrm>
-          <a:prstGeom prst="rect">
-            <a:avLst/>
-          </a:prstGeom>
-          <a:noFill/>
-          <a:ln/>
-        </p:spPr>
-        <p:txBody>
-          <a:bodyPr wrap="square" lIns="0" tIns="0" rIns="0" bIns="0" rtlCol="0" anchor="ctr"/>
-          <a:lstStyle/>
-          <a:p>
-            <a:pPr algn="l" indent="0" marL="0">
-              <a:buNone/>
-            </a:pPr>
-            <a:r>
-              <a:rPr lang="en-US" sz="980" b="1" dirty="0">
-                <a:solidFill>
-                  <a:srgbClr val="1A1A1A"/>
-                </a:solidFill>
-                <a:latin typeface="Arial" pitchFamily="34" charset="0"/>
-                <a:ea typeface="Arial" pitchFamily="34" charset="-122"/>
-                <a:cs typeface="Arial" pitchFamily="34" charset="-120"/>
-              </a:rPr>
-              <a:t>TOTAL</a:t>
-            </a:r>
-            <a:endParaRPr lang="en-US" sz="980" dirty="0"/>
-          </a:p>
-        </p:txBody>
-      </p:sp>
-      <p:sp>
-        <p:nvSpPr>
-          <p:cNvPr id="50" name="Text 47"/>
-          <p:cNvSpPr/>
-          <p:nvPr/>
-        </p:nvSpPr>
-        <p:spPr>
-          <a:xfrm>
-            <a:off x="3310128" y="5084064"/>
-            <a:ext cx="1143000" cy="402336"/>
-          </a:xfrm>
-          <a:prstGeom prst="rect">
-            <a:avLst/>
-          </a:prstGeom>
-          <a:noFill/>
-          <a:ln/>
-        </p:spPr>
-        <p:txBody>
-          <a:bodyPr wrap="square" lIns="0" tIns="0" rIns="0" bIns="0" rtlCol="0" anchor="ctr"/>
-          <a:lstStyle/>
-          <a:p>
-            <a:pPr algn="r" indent="0" marL="0">
-              <a:buNone/>
-            </a:pPr>
-            <a:r>
-              <a:rPr lang="en-US" sz="980" b="1" dirty="0">
-                <a:solidFill>
-                  <a:srgbClr val="1A1A1A"/>
-                </a:solidFill>
-                <a:latin typeface="Arial" pitchFamily="34" charset="0"/>
-                <a:ea typeface="Arial" pitchFamily="34" charset="-122"/>
-                <a:cs typeface="Arial" pitchFamily="34" charset="-120"/>
-              </a:rPr>
-              <a:t>$23,015</a:t>
-            </a:r>
-            <a:endParaRPr lang="en-US" sz="980" dirty="0"/>
-          </a:p>
-        </p:txBody>
-      </p:sp>
-      <p:sp>
-        <p:nvSpPr>
-          <p:cNvPr id="51" name="Text 48"/>
-          <p:cNvSpPr/>
-          <p:nvPr/>
-        </p:nvSpPr>
-        <p:spPr>
-          <a:xfrm>
-            <a:off x="4544568" y="5084064"/>
-            <a:ext cx="1143000" cy="402336"/>
-          </a:xfrm>
-          <a:prstGeom prst="rect">
-            <a:avLst/>
-          </a:prstGeom>
-          <a:noFill/>
-          <a:ln/>
-        </p:spPr>
-        <p:txBody>
-          <a:bodyPr wrap="square" lIns="0" tIns="0" rIns="0" bIns="0" rtlCol="0" anchor="ctr"/>
-          <a:lstStyle/>
-          <a:p>
-            <a:pPr algn="r" indent="0" marL="0">
-              <a:buNone/>
-            </a:pPr>
-            <a:r>
-              <a:rPr lang="en-US" sz="980" b="1" dirty="0">
-                <a:solidFill>
-                  <a:srgbClr val="1A1A1A"/>
-                </a:solidFill>
-                <a:latin typeface="Arial" pitchFamily="34" charset="0"/>
-                <a:ea typeface="Arial" pitchFamily="34" charset="-122"/>
-                <a:cs typeface="Arial" pitchFamily="34" charset="-120"/>
-              </a:rPr>
-              <a:t>$40,535</a:t>
-            </a:r>
-            <a:endParaRPr lang="en-US" sz="980" dirty="0"/>
-          </a:p>
-        </p:txBody>
-      </p:sp>
-      <p:sp>
-        <p:nvSpPr>
-          <p:cNvPr id="52" name="Text 49"/>
-          <p:cNvSpPr/>
-          <p:nvPr/>
-        </p:nvSpPr>
-        <p:spPr>
-          <a:xfrm>
-            <a:off x="5779008" y="5084064"/>
-            <a:ext cx="1124712" cy="402336"/>
-          </a:xfrm>
-          <a:prstGeom prst="rect">
-            <a:avLst/>
-          </a:prstGeom>
-          <a:noFill/>
-          <a:ln/>
-        </p:spPr>
-        <p:txBody>
-          <a:bodyPr wrap="square" lIns="0" tIns="0" rIns="0" bIns="0" rtlCol="0" anchor="ctr"/>
-          <a:lstStyle/>
-          <a:p>
-            <a:pPr algn="r" indent="0" marL="0">
-              <a:buNone/>
-            </a:pPr>
-            <a:r>
-              <a:rPr lang="en-US" sz="980" b="1" dirty="0">
-                <a:solidFill>
-                  <a:srgbClr val="D31145"/>
-                </a:solidFill>
-                <a:latin typeface="Arial" pitchFamily="34" charset="0"/>
-                <a:ea typeface="Arial" pitchFamily="34" charset="-122"/>
-                <a:cs typeface="Arial" pitchFamily="34" charset="-120"/>
-              </a:rPr>
-              <a:t>($17,520)</a:t>
-            </a:r>
-            <a:endParaRPr lang="en-US" sz="980" dirty="0"/>
-          </a:p>
-        </p:txBody>
-      </p:sp>
-      <p:sp>
-        <p:nvSpPr>
-          <p:cNvPr id="53" name="Shape 50"/>
-          <p:cNvSpPr/>
-          <p:nvPr/>
-        </p:nvSpPr>
-        <p:spPr>
-          <a:xfrm>
-            <a:off x="566928" y="5486400"/>
-            <a:ext cx="6428232" cy="10973"/>
-          </a:xfrm>
-          <a:prstGeom prst="rect">
-            <a:avLst/>
-          </a:prstGeom>
-          <a:solidFill>
-            <a:srgbClr val="1A1A1A"/>
-          </a:solidFill>
-          <a:ln/>
-        </p:spPr>
-      </p:sp>
-      <p:sp>
-        <p:nvSpPr>
-          <p:cNvPr id="54" name="Text 51"/>
-          <p:cNvSpPr/>
-          <p:nvPr/>
-        </p:nvSpPr>
-        <p:spPr>
-          <a:xfrm>
-            <a:off x="566928" y="5797296"/>
-            <a:ext cx="6428232" cy="164592"/>
-          </a:xfrm>
-          <a:prstGeom prst="rect">
-            <a:avLst/>
-          </a:prstGeom>
-          <a:noFill/>
-          <a:ln/>
-        </p:spPr>
-        <p:txBody>
-          <a:bodyPr wrap="square" lIns="0" tIns="0" rIns="0" bIns="0" rtlCol="0" anchor="ctr"/>
-          <a:lstStyle/>
-          <a:p>
-            <a:pPr algn="l" indent="0" marL="0">
-              <a:buNone/>
-            </a:pPr>
-            <a:r>
-              <a:rPr lang="en-US" sz="760" b="1" spc="120" kern="0" dirty="0">
-                <a:solidFill>
-                  <a:srgbClr val="1A1A1A"/>
-                </a:solidFill>
-                <a:latin typeface="Arial" pitchFamily="34" charset="0"/>
-                <a:ea typeface="Arial" pitchFamily="34" charset="-122"/>
-                <a:cs typeface="Arial" pitchFamily="34" charset="-120"/>
-              </a:rPr>
-              <a:t>UNDER WATCH</a:t>
-            </a:r>
-            <a:endParaRPr lang="en-US" sz="760" dirty="0"/>
-          </a:p>
-        </p:txBody>
-      </p:sp>
-      <p:sp>
-        <p:nvSpPr>
-          <p:cNvPr id="55" name="Shape 52"/>
-          <p:cNvSpPr/>
-          <p:nvPr/>
-        </p:nvSpPr>
-        <p:spPr>
-          <a:xfrm>
-            <a:off x="566928" y="5971032"/>
-            <a:ext cx="6428232" cy="7315"/>
-          </a:xfrm>
-          <a:prstGeom prst="rect">
-            <a:avLst/>
-          </a:prstGeom>
-          <a:solidFill>
-            <a:srgbClr val="C8C8C8"/>
-          </a:solidFill>
-          <a:ln/>
-        </p:spPr>
-      </p:sp>
-      <p:sp>
-        <p:nvSpPr>
-          <p:cNvPr id="56" name="Shape 53"/>
-          <p:cNvSpPr/>
-          <p:nvPr/>
-        </p:nvSpPr>
-        <p:spPr>
-          <a:xfrm>
-            <a:off x="566928" y="6126480"/>
-            <a:ext cx="36576" cy="548640"/>
+          <p:cNvPr id="57" name="Shape 54"/>
+          <p:cNvSpPr/>
+          <p:nvPr/>
+        </p:nvSpPr>
+        <p:spPr>
+          <a:xfrm>
+            <a:off x="566928" y="7589520"/>
+            <a:ext cx="54864" cy="1572768"/>
           </a:xfrm>
           <a:prstGeom prst="rect">
             <a:avLst/>
@@ -2666,373 +2686,14 @@
       </p:sp>
       <p:sp>
         <p:nvSpPr>
-          <p:cNvPr id="57" name="Text 54"/>
-          <p:cNvSpPr/>
-          <p:nvPr/>
-        </p:nvSpPr>
-        <p:spPr>
-          <a:xfrm>
-            <a:off x="731520" y="6126480"/>
-            <a:ext cx="4965192" cy="201168"/>
-          </a:xfrm>
-          <a:prstGeom prst="rect">
-            <a:avLst/>
-          </a:prstGeom>
-          <a:noFill/>
-          <a:ln/>
-        </p:spPr>
-        <p:txBody>
-          <a:bodyPr wrap="square" lIns="0" tIns="0" rIns="0" bIns="0" rtlCol="0" anchor="ctr"/>
-          <a:lstStyle/>
-          <a:p>
-            <a:pPr algn="l" indent="0" marL="0">
-              <a:buNone/>
-            </a:pPr>
-            <a:r>
-              <a:rPr lang="en-US" sz="960" b="1" dirty="0">
-                <a:solidFill>
-                  <a:srgbClr val="1A1A1A"/>
-                </a:solidFill>
-                <a:latin typeface="Arial" pitchFamily="34" charset="0"/>
-                <a:ea typeface="Arial" pitchFamily="34" charset="-122"/>
-                <a:cs typeface="Arial" pitchFamily="34" charset="-120"/>
-              </a:rPr>
-              <a:t>Nil-budget cost lines</a:t>
-            </a:r>
-            <a:endParaRPr lang="en-US" sz="960" dirty="0"/>
-          </a:p>
-        </p:txBody>
-      </p:sp>
-      <p:sp>
-        <p:nvSpPr>
           <p:cNvPr id="58" name="Text 55"/>
           <p:cNvSpPr/>
           <p:nvPr/>
         </p:nvSpPr>
         <p:spPr>
           <a:xfrm>
-            <a:off x="5623560" y="6126480"/>
-            <a:ext cx="1371600" cy="201168"/>
-          </a:xfrm>
-          <a:prstGeom prst="rect">
-            <a:avLst/>
-          </a:prstGeom>
-          <a:noFill/>
-          <a:ln/>
-        </p:spPr>
-        <p:txBody>
-          <a:bodyPr wrap="square" lIns="0" tIns="0" rIns="0" bIns="0" rtlCol="0" anchor="ctr"/>
-          <a:lstStyle/>
-          <a:p>
-            <a:pPr algn="r" indent="0" marL="0">
-              <a:buNone/>
-            </a:pPr>
-            <a:r>
-              <a:rPr lang="en-US" sz="980" b="1" dirty="0">
-                <a:solidFill>
-                  <a:srgbClr val="1A1A1A"/>
-                </a:solidFill>
-                <a:latin typeface="Arial" pitchFamily="34" charset="0"/>
-                <a:ea typeface="Arial" pitchFamily="34" charset="-122"/>
-                <a:cs typeface="Arial" pitchFamily="34" charset="-120"/>
-              </a:rPr>
-              <a:t>$6.1k</a:t>
-            </a:r>
-            <a:endParaRPr lang="en-US" sz="980" dirty="0"/>
-          </a:p>
-        </p:txBody>
-      </p:sp>
-      <p:sp>
-        <p:nvSpPr>
-          <p:cNvPr id="59" name="Text 56"/>
-          <p:cNvSpPr/>
-          <p:nvPr/>
-        </p:nvSpPr>
-        <p:spPr>
-          <a:xfrm>
-            <a:off x="731520" y="6345936"/>
-            <a:ext cx="6099048" cy="274320"/>
-          </a:xfrm>
-          <a:prstGeom prst="rect">
-            <a:avLst/>
-          </a:prstGeom>
-          <a:noFill/>
-          <a:ln/>
-        </p:spPr>
-        <p:txBody>
-          <a:bodyPr wrap="square" lIns="0" tIns="0" rIns="0" bIns="0" rtlCol="0" anchor="t"/>
-          <a:lstStyle/>
-          <a:p>
-            <a:pPr algn="l" indent="0" marL="0">
-              <a:lnSpc>
-                <a:spcPct val="126000"/>
-              </a:lnSpc>
-              <a:buNone/>
-            </a:pPr>
-            <a:r>
-              <a:rPr lang="en-US" sz="900" dirty="0">
-                <a:solidFill>
-                  <a:srgbClr val="1A1A1A"/>
-                </a:solidFill>
-                <a:latin typeface="Arial" pitchFamily="34" charset="0"/>
-                <a:ea typeface="Arial" pitchFamily="34" charset="-122"/>
-                <a:cs typeface="Arial" pitchFamily="34" charset="-120"/>
-              </a:rPr>
-              <a:t>Civilian overtime and sundry expenses require coding and budget-line confirmation with the Financial Adviser.</a:t>
-            </a:r>
-            <a:endParaRPr lang="en-US" sz="900" dirty="0"/>
-          </a:p>
-        </p:txBody>
-      </p:sp>
-      <p:sp>
-        <p:nvSpPr>
-          <p:cNvPr id="60" name="Shape 57"/>
-          <p:cNvSpPr/>
-          <p:nvPr/>
-        </p:nvSpPr>
-        <p:spPr>
-          <a:xfrm>
-            <a:off x="566928" y="6876288"/>
-            <a:ext cx="36576" cy="438912"/>
-          </a:xfrm>
-          <a:prstGeom prst="rect">
-            <a:avLst/>
-          </a:prstGeom>
-          <a:solidFill>
-            <a:srgbClr val="B3A650"/>
-          </a:solidFill>
-          <a:ln/>
-        </p:spPr>
-      </p:sp>
-      <p:sp>
-        <p:nvSpPr>
-          <p:cNvPr id="61" name="Text 58"/>
-          <p:cNvSpPr/>
-          <p:nvPr/>
-        </p:nvSpPr>
-        <p:spPr>
-          <a:xfrm>
-            <a:off x="731520" y="6876288"/>
-            <a:ext cx="4965192" cy="201168"/>
-          </a:xfrm>
-          <a:prstGeom prst="rect">
-            <a:avLst/>
-          </a:prstGeom>
-          <a:noFill/>
-          <a:ln/>
-        </p:spPr>
-        <p:txBody>
-          <a:bodyPr wrap="square" lIns="0" tIns="0" rIns="0" bIns="0" rtlCol="0" anchor="ctr"/>
-          <a:lstStyle/>
-          <a:p>
-            <a:pPr algn="l" indent="0" marL="0">
-              <a:buNone/>
-            </a:pPr>
-            <a:r>
-              <a:rPr lang="en-US" sz="960" b="1" dirty="0">
-                <a:solidFill>
-                  <a:srgbClr val="1A1A1A"/>
-                </a:solidFill>
-                <a:latin typeface="Arial" pitchFamily="34" charset="0"/>
-                <a:ea typeface="Arial" pitchFamily="34" charset="-122"/>
-                <a:cs typeface="Arial" pitchFamily="34" charset="-120"/>
-              </a:rPr>
-              <a:t>Civilian allowances</a:t>
-            </a:r>
-            <a:endParaRPr lang="en-US" sz="960" dirty="0"/>
-          </a:p>
-        </p:txBody>
-      </p:sp>
-      <p:sp>
-        <p:nvSpPr>
-          <p:cNvPr id="62" name="Text 59"/>
-          <p:cNvSpPr/>
-          <p:nvPr/>
-        </p:nvSpPr>
-        <p:spPr>
-          <a:xfrm>
-            <a:off x="5623560" y="6876288"/>
-            <a:ext cx="1371600" cy="201168"/>
-          </a:xfrm>
-          <a:prstGeom prst="rect">
-            <a:avLst/>
-          </a:prstGeom>
-          <a:noFill/>
-          <a:ln/>
-        </p:spPr>
-        <p:txBody>
-          <a:bodyPr wrap="square" lIns="0" tIns="0" rIns="0" bIns="0" rtlCol="0" anchor="ctr"/>
-          <a:lstStyle/>
-          <a:p>
-            <a:pPr algn="r" indent="0" marL="0">
-              <a:buNone/>
-            </a:pPr>
-            <a:r>
-              <a:rPr lang="en-US" sz="980" b="1" dirty="0">
-                <a:solidFill>
-                  <a:srgbClr val="1A1A1A"/>
-                </a:solidFill>
-                <a:latin typeface="Arial" pitchFamily="34" charset="0"/>
-                <a:ea typeface="Arial" pitchFamily="34" charset="-122"/>
-                <a:cs typeface="Arial" pitchFamily="34" charset="-120"/>
-              </a:rPr>
-              <a:t>53% consumed</a:t>
-            </a:r>
-            <a:endParaRPr lang="en-US" sz="980" dirty="0"/>
-          </a:p>
-        </p:txBody>
-      </p:sp>
-      <p:sp>
-        <p:nvSpPr>
-          <p:cNvPr id="63" name="Text 60"/>
-          <p:cNvSpPr/>
-          <p:nvPr/>
-        </p:nvSpPr>
-        <p:spPr>
-          <a:xfrm>
-            <a:off x="731520" y="7095744"/>
-            <a:ext cx="6099048" cy="274320"/>
-          </a:xfrm>
-          <a:prstGeom prst="rect">
-            <a:avLst/>
-          </a:prstGeom>
-          <a:noFill/>
-          <a:ln/>
-        </p:spPr>
-        <p:txBody>
-          <a:bodyPr wrap="square" lIns="0" tIns="0" rIns="0" bIns="0" rtlCol="0" anchor="t"/>
-          <a:lstStyle/>
-          <a:p>
-            <a:pPr algn="l" indent="0" marL="0">
-              <a:lnSpc>
-                <a:spcPct val="126000"/>
-              </a:lnSpc>
-              <a:buNone/>
-            </a:pPr>
-            <a:r>
-              <a:rPr lang="en-US" sz="900" dirty="0">
-                <a:solidFill>
-                  <a:srgbClr val="1A1A1A"/>
-                </a:solidFill>
-                <a:latin typeface="Arial" pitchFamily="34" charset="0"/>
-                <a:ea typeface="Arial" pitchFamily="34" charset="-122"/>
-                <a:cs typeface="Arial" pitchFamily="34" charset="-120"/>
-              </a:rPr>
-              <a:t>Run rate to be confirmed before Month 2.</a:t>
-            </a:r>
-            <a:endParaRPr lang="en-US" sz="900" dirty="0"/>
-          </a:p>
-        </p:txBody>
-      </p:sp>
-      <p:sp>
-        <p:nvSpPr>
-          <p:cNvPr id="64" name="Text 61"/>
-          <p:cNvSpPr/>
-          <p:nvPr/>
-        </p:nvSpPr>
-        <p:spPr>
-          <a:xfrm>
-            <a:off x="566928" y="7918704"/>
-            <a:ext cx="6428232" cy="164592"/>
-          </a:xfrm>
-          <a:prstGeom prst="rect">
-            <a:avLst/>
-          </a:prstGeom>
-          <a:noFill/>
-          <a:ln/>
-        </p:spPr>
-        <p:txBody>
-          <a:bodyPr wrap="square" lIns="0" tIns="0" rIns="0" bIns="0" rtlCol="0" anchor="ctr"/>
-          <a:lstStyle/>
-          <a:p>
-            <a:pPr algn="l" indent="0" marL="0">
-              <a:buNone/>
-            </a:pPr>
-            <a:r>
-              <a:rPr lang="en-US" sz="760" b="1" spc="120" kern="0" dirty="0">
-                <a:solidFill>
-                  <a:srgbClr val="1A1A1A"/>
-                </a:solidFill>
-                <a:latin typeface="Arial" pitchFamily="34" charset="0"/>
-                <a:ea typeface="Arial" pitchFamily="34" charset="-122"/>
-                <a:cs typeface="Arial" pitchFamily="34" charset="-120"/>
-              </a:rPr>
-              <a:t>MONTH 1 COMMAND ASSESSMENT</a:t>
-            </a:r>
-            <a:endParaRPr lang="en-US" sz="760" dirty="0"/>
-          </a:p>
-        </p:txBody>
-      </p:sp>
-      <p:sp>
-        <p:nvSpPr>
-          <p:cNvPr id="65" name="Shape 62"/>
-          <p:cNvSpPr/>
-          <p:nvPr/>
-        </p:nvSpPr>
-        <p:spPr>
-          <a:xfrm>
-            <a:off x="566928" y="8092440"/>
-            <a:ext cx="6428232" cy="7315"/>
-          </a:xfrm>
-          <a:prstGeom prst="rect">
-            <a:avLst/>
-          </a:prstGeom>
-          <a:solidFill>
-            <a:srgbClr val="C8C8C8"/>
-          </a:solidFill>
-          <a:ln/>
-        </p:spPr>
-      </p:sp>
-      <p:sp>
-        <p:nvSpPr>
-          <p:cNvPr id="66" name="Shape 63"/>
-          <p:cNvSpPr/>
-          <p:nvPr/>
-        </p:nvSpPr>
-        <p:spPr>
-          <a:xfrm>
-            <a:off x="566928" y="8247888"/>
-            <a:ext cx="6428232" cy="1225296"/>
-          </a:xfrm>
-          <a:prstGeom prst="rect">
-            <a:avLst/>
-          </a:prstGeom>
-          <a:solidFill>
-            <a:srgbClr val="1A1A1A"/>
-          </a:solidFill>
-          <a:ln/>
-        </p:spPr>
-      </p:sp>
-      <p:sp>
-        <p:nvSpPr>
-          <p:cNvPr id="67" name="Shape 64"/>
-          <p:cNvSpPr/>
-          <p:nvPr/>
-        </p:nvSpPr>
-        <p:spPr>
-          <a:xfrm>
-            <a:off x="566928" y="8247888"/>
-            <a:ext cx="50292" cy="1225296"/>
-          </a:xfrm>
-          <a:prstGeom prst="rect">
-            <a:avLst/>
-          </a:prstGeom>
-          <a:solidFill>
-            <a:srgbClr val="B3A650"/>
-          </a:solidFill>
-          <a:ln/>
-        </p:spPr>
-      </p:sp>
-      <p:sp>
-        <p:nvSpPr>
-          <p:cNvPr id="68" name="Text 65"/>
-          <p:cNvSpPr/>
-          <p:nvPr/>
-        </p:nvSpPr>
-        <p:spPr>
-          <a:xfrm>
-            <a:off x="877824" y="8467344"/>
-            <a:ext cx="5806440" cy="822960"/>
+            <a:off x="914400" y="7863840"/>
+            <a:ext cx="5733288" cy="1042416"/>
           </a:xfrm>
           <a:prstGeom prst="rect">
             <a:avLst/>
@@ -3051,7 +2712,7 @@
               <a:buNone/>
             </a:pPr>
             <a:r>
-              <a:rPr lang="en-US" sz="1040" dirty="0">
+              <a:rPr lang="en-US" sz="1140" dirty="0">
                 <a:solidFill>
                   <a:srgbClr val="FFFFFF"/>
                 </a:solidFill>
@@ -3061,13 +2722,13 @@
               </a:rPr>
               <a:t>FY26/27 remains on track. July's $17.5k adverse variance is assessed predominantly as front-loaded expenditure supporting the August course programme, rather than an emerging budget pressure. No corrective action is required at this stage beyond monitoring the combined July and August position.</a:t>
             </a:r>
-            <a:endParaRPr lang="en-US" sz="1040" dirty="0"/>
-          </a:p>
-        </p:txBody>
-      </p:sp>
-      <p:sp>
-        <p:nvSpPr>
-          <p:cNvPr id="69" name="Shape 66"/>
+            <a:endParaRPr lang="en-US" sz="1140" dirty="0"/>
+          </a:p>
+        </p:txBody>
+      </p:sp>
+      <p:sp>
+        <p:nvSpPr>
+          <p:cNvPr id="59" name="Shape 56"/>
           <p:cNvSpPr/>
           <p:nvPr/>
         </p:nvSpPr>
@@ -3087,7 +2748,7 @@
       </p:sp>
       <p:sp>
         <p:nvSpPr>
-          <p:cNvPr id="70" name="Text 67"/>
+          <p:cNvPr id="60" name="Text 57"/>
           <p:cNvSpPr/>
           <p:nvPr/>
         </p:nvSpPr>
@@ -3126,7 +2787,7 @@
       </p:sp>
       <p:sp>
         <p:nvSpPr>
-          <p:cNvPr id="71" name="Text 68"/>
+          <p:cNvPr id="61" name="Text 58"/>
           <p:cNvSpPr/>
           <p:nvPr/>
         </p:nvSpPr>

</xml_diff>

<commit_message>
Update the month 1 command assessment
Attributes the July overspend to named August activities: the Adventure
Race, Pacific Response Group training, and ELDA Lead Systems (Alpine
Tour). Panel depth follows the shorter text.

Co-Authored-By: Claude Fable 5 <noreply@anthropic.com>
Claude-Session: https://claude.ai/code/session_01YLo1WfwUDkbwfJEF3ZNVbB
</commit_message>
<xml_diff>
--- a/output/nzalc-month1-comdt-update.pptx
+++ b/output/nzalc-month1-comdt-update.pptx
@@ -2653,7 +2653,7 @@
         <p:spPr>
           <a:xfrm>
             <a:off x="566928" y="7589520"/>
-            <a:ext cx="6428232" cy="1572768"/>
+            <a:ext cx="6428232" cy="1298448"/>
           </a:xfrm>
           <a:prstGeom prst="rect">
             <a:avLst/>
@@ -2673,7 +2673,7 @@
         <p:spPr>
           <a:xfrm>
             <a:off x="566928" y="7589520"/>
-            <a:ext cx="54864" cy="1572768"/>
+            <a:ext cx="54864" cy="1298448"/>
           </a:xfrm>
           <a:prstGeom prst="rect">
             <a:avLst/>
@@ -2693,7 +2693,7 @@
         <p:spPr>
           <a:xfrm>
             <a:off x="914400" y="7863840"/>
-            <a:ext cx="5733288" cy="1042416"/>
+            <a:ext cx="5733288" cy="822960"/>
           </a:xfrm>
           <a:prstGeom prst="rect">
             <a:avLst/>
@@ -2720,7 +2720,7 @@
                 <a:ea typeface="Arial" pitchFamily="34" charset="-122"/>
                 <a:cs typeface="Arial" pitchFamily="34" charset="-120"/>
               </a:rPr>
-              <a:t>FY26/27 remains on track. July's $17.5k adverse variance is assessed predominantly as front-loaded expenditure supporting the August course programme, rather than an emerging budget pressure. No corrective action is required at this stage beyond monitoring the combined July and August position.</a:t>
+              <a:t>FY26/27 remains on track. July's $17.5k overspend is attributed to front-loaded expenditure in support of August course delivery, including the Adventure Race, Pacific Response Group training, and ELDA Lead Systems (Alpine Tour).</a:t>
             </a:r>
             <a:endParaRPr lang="en-US" sz="1140" dirty="0"/>
           </a:p>

</xml_diff>